<commit_message>
Audit Tableau examples and clarify life expectancy pie chart
</commit_message>
<xml_diff>
--- a/lectures/w04-tableau-chart-types.pptx
+++ b/lectures/w04-tableau-chart-types.pptx
@@ -2,18 +2,18 @@
 <file path=ppt/presentation.xml><?xml version="1.0" encoding="utf-8"?>
 <p:presentation xmlns:p="http://schemas.openxmlformats.org/presentationml/2006/main">
   <p:sldMasterIdLst>
-    <p:sldMasterId xmlns:r="http://schemas.openxmlformats.org/officeDocument/2006/relationships" id="2147483648" r:id="R79dd9c20e0e04424"/>
+    <p:sldMasterId xmlns:r="http://schemas.openxmlformats.org/officeDocument/2006/relationships" id="2147483648" r:id="R4a82670c651a4ef7"/>
   </p:sldMasterIdLst>
   <p:notesMasterIdLst>
-    <p:notesMasterId xmlns:r="http://schemas.openxmlformats.org/officeDocument/2006/relationships" r:id="Rf381cd884a334121"/>
+    <p:notesMasterId xmlns:r="http://schemas.openxmlformats.org/officeDocument/2006/relationships" r:id="Rfe4b7685429c487a"/>
   </p:notesMasterIdLst>
   <p:sldIdLst>
-    <p:sldId xmlns:r="http://schemas.openxmlformats.org/officeDocument/2006/relationships" id="256" r:id="Rc1a8ab1f09924317"/>
-    <p:sldId xmlns:r="http://schemas.openxmlformats.org/officeDocument/2006/relationships" id="257" r:id="R9aa7803dd4a146cd"/>
-    <p:sldId xmlns:r="http://schemas.openxmlformats.org/officeDocument/2006/relationships" id="258" r:id="R13118ce475f54591"/>
-    <p:sldId xmlns:r="http://schemas.openxmlformats.org/officeDocument/2006/relationships" id="259" r:id="R07fb9a2fb66240bc"/>
-    <p:sldId xmlns:r="http://schemas.openxmlformats.org/officeDocument/2006/relationships" id="260" r:id="R15797f61c62b4870"/>
-    <p:sldId xmlns:r="http://schemas.openxmlformats.org/officeDocument/2006/relationships" id="261" r:id="R465935e5aecc4985"/>
+    <p:sldId xmlns:r="http://schemas.openxmlformats.org/officeDocument/2006/relationships" id="256" r:id="Ra19c5cb72d1147c3"/>
+    <p:sldId xmlns:r="http://schemas.openxmlformats.org/officeDocument/2006/relationships" id="257" r:id="R1dda2c24dfa8423b"/>
+    <p:sldId xmlns:r="http://schemas.openxmlformats.org/officeDocument/2006/relationships" id="258" r:id="R98f3fa04c7c84381"/>
+    <p:sldId xmlns:r="http://schemas.openxmlformats.org/officeDocument/2006/relationships" id="259" r:id="R862d0ffdc62b4edd"/>
+    <p:sldId xmlns:r="http://schemas.openxmlformats.org/officeDocument/2006/relationships" id="260" r:id="R186cf2589b424e26"/>
+    <p:sldId xmlns:r="http://schemas.openxmlformats.org/officeDocument/2006/relationships" id="261" r:id="Rb78629e2e1a04c87"/>
   </p:sldIdLst>
   <p:sldSz cx="12192000" cy="6858000"/>
   <p:notesSz cx="6858000" cy="9144000"/>
@@ -822,17 +822,17 @@
           <a:lstStyle xmlns:a="http://schemas.openxmlformats.org/drawingml/2006/main"/>
           <a:p xmlns:a="http://schemas.openxmlformats.org/drawingml/2006/main">
             <a:r>
-              <a:t>Pie and treemap both use counts of the 197 country records in the dataset for 2020. Missing region becomes Unknown (retain it in the denominator). This is neither population share nor economic share. In Tableau use region as dimension and COUNTD(Country) as measure, filter Year=2020, then Show Me Pie or Treemap. Treemaps support hierarchies; this example has one grouping level. Compare area estimates with the earlier bar chart for precise ranking. Prefer a few meaningful categories in pies. Treemap rectangles use a recursively split area layout with exact area proportional to counts, with slight visual white gutters between regions.</a:t>
+              <a:t>Both charts count countries by Life Expectancy band in 2020. Filter Year=2020 and Life Expectancy&gt;0, excluding nulls. Calculated field Life band: IF [Life Expectancy] &lt; 70 THEN "Under 70" ELSEIF [Life Expectancy] &lt; 80 THEN "70–79" ELSE "80+" END. Pie marks: Life band on Color, COUNTD(Country) on Angle. Put Life band and COUNTD(Country) on Label; add a second COUNTD(Country) to Label with Quick Table Calculation &gt; Percent of Total (compute over Life band). Treemap: Life band on Color and COUNTD(Country) on Size and Label. Sort counts descending. Counts: 97,68,29; total194. Percentages: 50.0%,35.1%,14.9%. Never sum life expectancy, or use incomplete Population as a total. These are country shares, not shares of people. Pie start angle/layout may differ by Tableau version.</a:t>
+            </a:r>
+          </a:p>
+          <a:p xmlns:a="http://schemas.openxmlformats.org/drawingml/2006/main">
+            <a:r>
+              <a:t>https://help.tableau.com/current/pro/desktop/en-us/buildexamples_pie.htm</a:t>
             </a:r>
           </a:p>
           <a:p xmlns:a="http://schemas.openxmlformats.org/drawingml/2006/main">
             <a:r>
               <a:t>https://help.tableau.com/current/pro/desktop/en-us/buildexamples_treemap.htm</a:t>
-            </a:r>
-          </a:p>
-          <a:p xmlns:a="http://schemas.openxmlformats.org/drawingml/2006/main">
-            <a:r>
-              <a:t>https://help.tableau.com/current/pro/desktop/en-us/buildexamples_pie.htm</a:t>
             </a:r>
           </a:p>
           <a:p xmlns:a="http://schemas.openxmlformats.org/drawingml/2006/main">
@@ -1004,7 +1004,7 @@
           <p:cNvPr id="3" name="Title">
             <a:extLst xmlns:a="http://schemas.openxmlformats.org/drawingml/2006/main">
               <a:ext uri="{FF2B5EF4-FFF2-40B4-BE49-F238E27FC236}">
-                <a16:creationId xmlns:a16="http://schemas.microsoft.com/office/drawing/2014/main" id="{DBB8631A-ACD3-4E0F-B449-526C7EC3F3A9}"/>
+                <a16:creationId xmlns:a16="http://schemas.microsoft.com/office/drawing/2014/main" id="{AF259782-0733-44CF-892A-6AAD66BDFE11}"/>
               </a:ext>
             </a:extLst>
           </p:cNvPr>
@@ -1161,7 +1161,7 @@
           <p:cNvPr id="2" name="Subtitle">
             <a:extLst xmlns:a="http://schemas.openxmlformats.org/drawingml/2006/main">
               <a:ext uri="{FF2B5EF4-FFF2-40B4-BE49-F238E27FC236}">
-                <a16:creationId xmlns:a16="http://schemas.microsoft.com/office/drawing/2014/main" id="{729375D5-77B5-490D-8FB8-B209FBC7D592}"/>
+                <a16:creationId xmlns:a16="http://schemas.microsoft.com/office/drawing/2014/main" id="{CBAA877E-2370-4089-B784-8DFA5533B5DD}"/>
               </a:ext>
             </a:extLst>
           </p:cNvPr>
@@ -1335,7 +1335,7 @@
           <p:cNvPr id="2" name="Section title">
             <a:extLst xmlns:a="http://schemas.openxmlformats.org/drawingml/2006/main">
               <a:ext uri="{FF2B5EF4-FFF2-40B4-BE49-F238E27FC236}">
-                <a16:creationId xmlns:a16="http://schemas.microsoft.com/office/drawing/2014/main" id="{1401AD84-DB1A-42CD-A80B-5E0A3638A21E}"/>
+                <a16:creationId xmlns:a16="http://schemas.microsoft.com/office/drawing/2014/main" id="{5AD7C478-8ADE-40BA-8455-0FAD50EC13CD}"/>
               </a:ext>
             </a:extLst>
           </p:cNvPr>
@@ -1509,7 +1509,7 @@
           <p:cNvPr id="3" name="Title">
             <a:extLst xmlns:a="http://schemas.openxmlformats.org/drawingml/2006/main">
               <a:ext uri="{FF2B5EF4-FFF2-40B4-BE49-F238E27FC236}">
-                <a16:creationId xmlns:a16="http://schemas.microsoft.com/office/drawing/2014/main" id="{EDB28301-ED92-4943-91AD-3554A66CAB46}"/>
+                <a16:creationId xmlns:a16="http://schemas.microsoft.com/office/drawing/2014/main" id="{B2F96908-45AC-4E56-B76E-FB5D990CE03C}"/>
               </a:ext>
             </a:extLst>
           </p:cNvPr>
@@ -1666,7 +1666,7 @@
           <p:cNvPr id="2" name="Body">
             <a:extLst xmlns:a="http://schemas.openxmlformats.org/drawingml/2006/main">
               <a:ext uri="{FF2B5EF4-FFF2-40B4-BE49-F238E27FC236}">
-                <a16:creationId xmlns:a16="http://schemas.microsoft.com/office/drawing/2014/main" id="{DAC062EC-0476-4219-81C4-EBC809CB2BA0}"/>
+                <a16:creationId xmlns:a16="http://schemas.microsoft.com/office/drawing/2014/main" id="{2027D56E-E0C4-46C7-B191-9EE144A450FC}"/>
               </a:ext>
             </a:extLst>
           </p:cNvPr>
@@ -1840,7 +1840,7 @@
           <p:cNvPr id="4" name="Title">
             <a:extLst xmlns:a="http://schemas.openxmlformats.org/drawingml/2006/main">
               <a:ext uri="{FF2B5EF4-FFF2-40B4-BE49-F238E27FC236}">
-                <a16:creationId xmlns:a16="http://schemas.microsoft.com/office/drawing/2014/main" id="{CDC7C9F4-7160-44F2-977A-C1D864AE8F11}"/>
+                <a16:creationId xmlns:a16="http://schemas.microsoft.com/office/drawing/2014/main" id="{EDA7C0BF-C0D7-4662-B519-580D700AD0B1}"/>
               </a:ext>
             </a:extLst>
           </p:cNvPr>
@@ -1997,7 +1997,7 @@
           <p:cNvPr id="2" name="Left column">
             <a:extLst xmlns:a="http://schemas.openxmlformats.org/drawingml/2006/main">
               <a:ext uri="{FF2B5EF4-FFF2-40B4-BE49-F238E27FC236}">
-                <a16:creationId xmlns:a16="http://schemas.microsoft.com/office/drawing/2014/main" id="{0AD95255-DF60-42A3-BFC7-8CE6D12B1141}"/>
+                <a16:creationId xmlns:a16="http://schemas.microsoft.com/office/drawing/2014/main" id="{7FE5F1B1-1A3A-4660-B54D-5E6E1DAF293D}"/>
               </a:ext>
             </a:extLst>
           </p:cNvPr>
@@ -2154,7 +2154,7 @@
           <p:cNvPr id="3" name="Right column">
             <a:extLst xmlns:a="http://schemas.openxmlformats.org/drawingml/2006/main">
               <a:ext uri="{FF2B5EF4-FFF2-40B4-BE49-F238E27FC236}">
-                <a16:creationId xmlns:a16="http://schemas.microsoft.com/office/drawing/2014/main" id="{4E41C284-34FE-457B-B76F-C57F04544EFE}"/>
+                <a16:creationId xmlns:a16="http://schemas.microsoft.com/office/drawing/2014/main" id="{0BE20597-B6BF-4116-B370-322AFFD2AE0C}"/>
               </a:ext>
             </a:extLst>
           </p:cNvPr>
@@ -2328,7 +2328,7 @@
           <p:cNvPr id="3" name="Title">
             <a:extLst xmlns:a="http://schemas.openxmlformats.org/drawingml/2006/main">
               <a:ext uri="{FF2B5EF4-FFF2-40B4-BE49-F238E27FC236}">
-                <a16:creationId xmlns:a16="http://schemas.microsoft.com/office/drawing/2014/main" id="{98733B81-C178-48BC-9DEC-B5DA576B9066}"/>
+                <a16:creationId xmlns:a16="http://schemas.microsoft.com/office/drawing/2014/main" id="{7998875E-98A5-4900-BCC5-BB19772F926F}"/>
               </a:ext>
             </a:extLst>
           </p:cNvPr>
@@ -2485,7 +2485,7 @@
           <p:cNvPr id="2" name="Left column">
             <a:extLst xmlns:a="http://schemas.openxmlformats.org/drawingml/2006/main">
               <a:ext uri="{FF2B5EF4-FFF2-40B4-BE49-F238E27FC236}">
-                <a16:creationId xmlns:a16="http://schemas.microsoft.com/office/drawing/2014/main" id="{0F5CC21D-31C7-48DC-99DA-DCDC2AABC053}"/>
+                <a16:creationId xmlns:a16="http://schemas.microsoft.com/office/drawing/2014/main" id="{CDFFC17C-F20E-4200-9594-7AE05E9B5AA7}"/>
               </a:ext>
             </a:extLst>
           </p:cNvPr>
@@ -2680,12 +2680,12 @@
   </p:cSld>
   <p:clrMap bg1="lt1" tx1="dk1" bg2="lt2" tx2="dk2" accent1="accent1" accent2="accent2" accent3="accent3" accent4="accent4" accent5="accent5" accent6="accent6" hlink="hlink" folHlink="folHlink"/>
   <p:sldLayoutIdLst>
-    <p:sldLayoutId xmlns:r="http://schemas.openxmlformats.org/officeDocument/2006/relationships" id="2147483649" r:id="Re26b933647e84c7d"/>
-    <p:sldLayoutId xmlns:r="http://schemas.openxmlformats.org/officeDocument/2006/relationships" id="2147483650" r:id="Rcf39d5be7b88495c"/>
-    <p:sldLayoutId xmlns:r="http://schemas.openxmlformats.org/officeDocument/2006/relationships" id="2147483651" r:id="R1cbb47d22eb145f2"/>
-    <p:sldLayoutId xmlns:r="http://schemas.openxmlformats.org/officeDocument/2006/relationships" id="2147483652" r:id="Rdd4a861d3e3e4b85"/>
-    <p:sldLayoutId xmlns:r="http://schemas.openxmlformats.org/officeDocument/2006/relationships" id="2147483653" r:id="Re10feb854ebf45ff"/>
-    <p:sldLayoutId xmlns:r="http://schemas.openxmlformats.org/officeDocument/2006/relationships" id="2147483654" r:id="R1cef473a0c954b9c"/>
+    <p:sldLayoutId xmlns:r="http://schemas.openxmlformats.org/officeDocument/2006/relationships" id="2147483649" r:id="R8e23da75ce7a4fa6"/>
+    <p:sldLayoutId xmlns:r="http://schemas.openxmlformats.org/officeDocument/2006/relationships" id="2147483650" r:id="R8935d7d83ef044c4"/>
+    <p:sldLayoutId xmlns:r="http://schemas.openxmlformats.org/officeDocument/2006/relationships" id="2147483651" r:id="R307a93584657496c"/>
+    <p:sldLayoutId xmlns:r="http://schemas.openxmlformats.org/officeDocument/2006/relationships" id="2147483652" r:id="Rac18f910545e4a5b"/>
+    <p:sldLayoutId xmlns:r="http://schemas.openxmlformats.org/officeDocument/2006/relationships" id="2147483653" r:id="R5552b87ecb364002"/>
+    <p:sldLayoutId xmlns:r="http://schemas.openxmlformats.org/officeDocument/2006/relationships" id="2147483654" r:id="R0bfe061c4e8c43af"/>
   </p:sldLayoutIdLst>
   <p:txStyles>
     <p:titleStyle>
@@ -6247,7 +6247,7 @@
           <c:idx val="0"/>
           <c:order val="0"/>
           <c:tx>
-            <c:v>Country records</c:v>
+            <c:v>Countries</c:v>
           </c:tx>
           <c:spPr>
             <a:solidFill xmlns:a="http://schemas.openxmlformats.org/drawingml/2006/main">
@@ -6278,86 +6278,46 @@
               </a:solidFill>
             </c:spPr>
           </c:dPt>
-          <c:dPt>
-            <c:idx val="3"/>
-            <c:spPr>
-              <a:solidFill xmlns:a="http://schemas.openxmlformats.org/drawingml/2006/main">
-                <a:srgbClr val="647545"/>
-              </a:solidFill>
-            </c:spPr>
-          </c:dPt>
-          <c:dPt>
-            <c:idx val="4"/>
-            <c:spPr>
-              <a:solidFill xmlns:a="http://schemas.openxmlformats.org/drawingml/2006/main">
-                <a:srgbClr val="805773"/>
-              </a:solidFill>
-            </c:spPr>
-          </c:dPt>
-          <c:dPt>
-            <c:idx val="5"/>
-            <c:spPr>
-              <a:solidFill xmlns:a="http://schemas.openxmlformats.org/drawingml/2006/main">
-                <a:srgbClr val="AAA49B"/>
-              </a:solidFill>
-            </c:spPr>
-          </c:dPt>
           <c:cat>
             <c:strRef>
-              <c:f>'Chart Data'!$A$2:$A$7</c:f>
+              <c:f>'Chart Data'!$A$2:$A$4</c:f>
               <c:strCache>
-                <c:ptCount val="6"/>
+                <c:ptCount val="3"/>
                 <c:pt idx="0">
-                  <c:v>Africa</c:v>
+                  <c:v>70–79 years
+97 · 50.0%</c:v>
                 </c:pt>
                 <c:pt idx="1">
-                  <c:v>Americas</c:v>
+                  <c:v>Under 70
+68 · 35.1%</c:v>
                 </c:pt>
                 <c:pt idx="2">
-                  <c:v>Asia</c:v>
-                </c:pt>
-                <c:pt idx="3">
-                  <c:v>Europe</c:v>
-                </c:pt>
-                <c:pt idx="4">
-                  <c:v>Oceania</c:v>
-                </c:pt>
-                <c:pt idx="5">
-                  <c:v>Unknown</c:v>
+                  <c:v>80+ years
+29 · 14.9%</c:v>
                 </c:pt>
               </c:strCache>
             </c:strRef>
           </c:cat>
           <c:val>
             <c:numRef>
-              <c:f>'Chart Data'!$B$2:$B$7</c:f>
+              <c:f>'Chart Data'!$B$2:$B$4</c:f>
               <c:numCache>
                 <c:formatCode>General</c:formatCode>
-                <c:ptCount val="6"/>
+                <c:ptCount val="3"/>
                 <c:pt idx="0">
-                  <c:v>52</c:v>
+                  <c:v>97</c:v>
                 </c:pt>
                 <c:pt idx="1">
-                  <c:v>32</c:v>
+                  <c:v>68</c:v>
                 </c:pt>
                 <c:pt idx="2">
-                  <c:v>41</c:v>
-                </c:pt>
-                <c:pt idx="3">
-                  <c:v>41</c:v>
-                </c:pt>
-                <c:pt idx="4">
-                  <c:v>13</c:v>
-                </c:pt>
-                <c:pt idx="5">
-                  <c:v>18</c:v>
+                  <c:v>29</c:v>
                 </c:pt>
               </c:numCache>
             </c:numRef>
           </c:val>
         </c:ser>
         <c:dLbls>
-          <c:numFmt formatCode="0%" sourceLinked="0"/>
           <c:txPr>
             <a:bodyPr xmlns:a="http://schemas.openxmlformats.org/drawingml/2006/main" anchorCtr="1"/>
             <a:lstStyle xmlns:a="http://schemas.openxmlformats.org/drawingml/2006/main"/>
@@ -6377,9 +6337,9 @@
           <c:dLblPos val="ctr"/>
           <c:showLegendKey val="0"/>
           <c:showVal val="0"/>
-          <c:showCatName val="0"/>
+          <c:showCatName val="1"/>
           <c:showSerName val="0"/>
-          <c:showPercent val="1"/>
+          <c:showPercent val="0"/>
           <c:showBubbleSize val="0"/>
           <c:showLeaderLines val="0"/>
         </c:dLbls>
@@ -6420,7 +6380,7 @@
           <p:cNvPr id="10" name="">
             <a:extLst xmlns:a="http://schemas.openxmlformats.org/drawingml/2006/main">
               <a:ext uri="{FF2B5EF4-FFF2-40B4-BE49-F238E27FC236}">
-                <a16:creationId xmlns:a16="http://schemas.microsoft.com/office/drawing/2014/main" id="{93A526D1-2F60-4A8F-BAED-FB17672578C5}"/>
+                <a16:creationId xmlns:a16="http://schemas.microsoft.com/office/drawing/2014/main" id="{0537CED8-4889-468E-9B0A-EAD1FED0B8D7}"/>
               </a:ext>
             </a:extLst>
           </p:cNvPr>
@@ -6486,7 +6446,7 @@
           <p:cNvPr id="2" name="">
             <a:extLst xmlns:a="http://schemas.openxmlformats.org/drawingml/2006/main">
               <a:ext uri="{FF2B5EF4-FFF2-40B4-BE49-F238E27FC236}">
-                <a16:creationId xmlns:a16="http://schemas.microsoft.com/office/drawing/2014/main" id="{732581F2-B6C7-4878-A0A9-C7DFE994AEC2}"/>
+                <a16:creationId xmlns:a16="http://schemas.microsoft.com/office/drawing/2014/main" id="{3D761684-37D6-4883-AC6E-507D68F45098}"/>
               </a:ext>
             </a:extLst>
           </p:cNvPr>
@@ -6552,7 +6512,7 @@
           <p:cNvPr id="3" name="">
             <a:extLst xmlns:a="http://schemas.openxmlformats.org/drawingml/2006/main">
               <a:ext uri="{FF2B5EF4-FFF2-40B4-BE49-F238E27FC236}">
-                <a16:creationId xmlns:a16="http://schemas.microsoft.com/office/drawing/2014/main" id="{5D630643-AA4A-4D29-8A17-2B21ECD5C12E}"/>
+                <a16:creationId xmlns:a16="http://schemas.microsoft.com/office/drawing/2014/main" id="{45B005C6-8659-4780-9629-AB461E35A516}"/>
               </a:ext>
             </a:extLst>
           </p:cNvPr>
@@ -6618,7 +6578,7 @@
           <p:cNvPr id="4" name="">
             <a:extLst xmlns:a="http://schemas.openxmlformats.org/drawingml/2006/main">
               <a:ext uri="{FF2B5EF4-FFF2-40B4-BE49-F238E27FC236}">
-                <a16:creationId xmlns:a16="http://schemas.microsoft.com/office/drawing/2014/main" id="{2FB67802-C488-4A6A-83D5-0C62DA95F016}"/>
+                <a16:creationId xmlns:a16="http://schemas.microsoft.com/office/drawing/2014/main" id="{C67A6FBB-ECC1-49D9-B459-FCD07DEEEAB3}"/>
               </a:ext>
             </a:extLst>
           </p:cNvPr>
@@ -6684,7 +6644,7 @@
           <p:cNvPr id="5" name="">
             <a:extLst xmlns:a="http://schemas.openxmlformats.org/drawingml/2006/main">
               <a:ext uri="{FF2B5EF4-FFF2-40B4-BE49-F238E27FC236}">
-                <a16:creationId xmlns:a16="http://schemas.microsoft.com/office/drawing/2014/main" id="{DE83C90E-D2AE-4214-B024-F918C6A28365}"/>
+                <a16:creationId xmlns:a16="http://schemas.microsoft.com/office/drawing/2014/main" id="{0CDDD1E1-2CC6-46C1-8BAA-DC09C578C82F}"/>
               </a:ext>
             </a:extLst>
           </p:cNvPr>
@@ -6750,7 +6710,7 @@
           <p:cNvPr id="6" name="">
             <a:extLst xmlns:a="http://schemas.openxmlformats.org/drawingml/2006/main">
               <a:ext uri="{FF2B5EF4-FFF2-40B4-BE49-F238E27FC236}">
-                <a16:creationId xmlns:a16="http://schemas.microsoft.com/office/drawing/2014/main" id="{A78B835B-3A1C-4F86-90F8-05F65728CBB6}"/>
+                <a16:creationId xmlns:a16="http://schemas.microsoft.com/office/drawing/2014/main" id="{EB4D9D43-DD84-4907-902C-83AD7C6F989B}"/>
               </a:ext>
             </a:extLst>
           </p:cNvPr>
@@ -6816,7 +6776,7 @@
           <p:cNvPr id="7" name="Chart">
             <a:extLst xmlns:a="http://schemas.openxmlformats.org/drawingml/2006/main">
               <a:ext uri="{FF2B5EF4-FFF2-40B4-BE49-F238E27FC236}">
-                <a16:creationId xmlns:a16="http://schemas.microsoft.com/office/drawing/2014/main" id="{CE1E23FB-60A5-4D1A-91F8-0510D82D53CB}"/>
+                <a16:creationId xmlns:a16="http://schemas.microsoft.com/office/drawing/2014/main" id="{BEFA5F5F-DBF4-4859-87B8-37A76B734157}"/>
               </a:ext>
             </a:extLst>
           </p:cNvPr>
@@ -6829,7 +6789,7 @@
         </p:xfrm>
         <a:graphic xmlns:a="http://schemas.openxmlformats.org/drawingml/2006/main">
           <a:graphicData uri="http://schemas.openxmlformats.org/drawingml/2006/chart">
-            <c:chart xmlns:r="http://schemas.openxmlformats.org/officeDocument/2006/relationships" xmlns:c="http://schemas.openxmlformats.org/drawingml/2006/chart" r:id="Rf0ff67d475eb499a"/>
+            <c:chart xmlns:r="http://schemas.openxmlformats.org/officeDocument/2006/relationships" xmlns:c="http://schemas.openxmlformats.org/drawingml/2006/chart" r:id="Rcdcce7df17304594"/>
           </a:graphicData>
         </a:graphic>
       </p:graphicFrame>
@@ -6838,7 +6798,7 @@
           <p:cNvPr id="8" name="Chart">
             <a:extLst xmlns:a="http://schemas.openxmlformats.org/drawingml/2006/main">
               <a:ext uri="{FF2B5EF4-FFF2-40B4-BE49-F238E27FC236}">
-                <a16:creationId xmlns:a16="http://schemas.microsoft.com/office/drawing/2014/main" id="{04468462-3A75-48BB-824C-BE392870CB2F}"/>
+                <a16:creationId xmlns:a16="http://schemas.microsoft.com/office/drawing/2014/main" id="{2902A39B-1170-4218-B17A-FE10015359E8}"/>
               </a:ext>
             </a:extLst>
           </p:cNvPr>
@@ -6851,7 +6811,7 @@
         </p:xfrm>
         <a:graphic xmlns:a="http://schemas.openxmlformats.org/drawingml/2006/main">
           <a:graphicData uri="http://schemas.openxmlformats.org/drawingml/2006/chart">
-            <c:chart xmlns:r="http://schemas.openxmlformats.org/officeDocument/2006/relationships" xmlns:c="http://schemas.openxmlformats.org/drawingml/2006/chart" r:id="R494ffe5a818b4c0a"/>
+            <c:chart xmlns:r="http://schemas.openxmlformats.org/officeDocument/2006/relationships" xmlns:c="http://schemas.openxmlformats.org/drawingml/2006/chart" r:id="R3486b09748524c42"/>
           </a:graphicData>
         </a:graphic>
       </p:graphicFrame>
@@ -6860,7 +6820,7 @@
           <p:cNvPr id="9" name="">
             <a:extLst xmlns:a="http://schemas.openxmlformats.org/drawingml/2006/main">
               <a:ext uri="{FF2B5EF4-FFF2-40B4-BE49-F238E27FC236}">
-                <a16:creationId xmlns:a16="http://schemas.microsoft.com/office/drawing/2014/main" id="{2A1C15BD-2921-4381-B411-A63367DFBBFC}"/>
+                <a16:creationId xmlns:a16="http://schemas.microsoft.com/office/drawing/2014/main" id="{6B1A86D8-6A6B-40EE-B0AD-35AFD7C49115}"/>
               </a:ext>
             </a:extLst>
           </p:cNvPr>
@@ -6924,7 +6884,7 @@
     </p:spTree>
     <p:extLst>
       <p:ext uri="{BB962C8B-B14F-4D97-AF65-F5344CB8AC3E}">
-        <p14:creationId xmlns:p14="http://schemas.microsoft.com/office/powerpoint/2010/main" val="321123985"/>
+        <p14:creationId xmlns:p14="http://schemas.microsoft.com/office/powerpoint/2010/main" val="684100192"/>
       </p:ext>
     </p:extLst>
   </p:cSld>
@@ -6955,7 +6915,7 @@
           <p:cNvPr id="11" name="">
             <a:extLst xmlns:a="http://schemas.openxmlformats.org/drawingml/2006/main">
               <a:ext uri="{FF2B5EF4-FFF2-40B4-BE49-F238E27FC236}">
-                <a16:creationId xmlns:a16="http://schemas.microsoft.com/office/drawing/2014/main" id="{26CAC688-2C0E-49F5-A873-65613D70CA82}"/>
+                <a16:creationId xmlns:a16="http://schemas.microsoft.com/office/drawing/2014/main" id="{3A493690-55B7-4DAA-AD00-CDF43B4B503B}"/>
               </a:ext>
             </a:extLst>
           </p:cNvPr>
@@ -7021,7 +6981,7 @@
           <p:cNvPr id="2" name="">
             <a:extLst xmlns:a="http://schemas.openxmlformats.org/drawingml/2006/main">
               <a:ext uri="{FF2B5EF4-FFF2-40B4-BE49-F238E27FC236}">
-                <a16:creationId xmlns:a16="http://schemas.microsoft.com/office/drawing/2014/main" id="{ECD2B2C0-1242-4F58-B519-F80A74D1C0C6}"/>
+                <a16:creationId xmlns:a16="http://schemas.microsoft.com/office/drawing/2014/main" id="{8D5B663E-B6D0-45D2-BDA4-FCAF76387233}"/>
               </a:ext>
             </a:extLst>
           </p:cNvPr>
@@ -7087,7 +7047,7 @@
           <p:cNvPr id="3" name="">
             <a:extLst xmlns:a="http://schemas.openxmlformats.org/drawingml/2006/main">
               <a:ext uri="{FF2B5EF4-FFF2-40B4-BE49-F238E27FC236}">
-                <a16:creationId xmlns:a16="http://schemas.microsoft.com/office/drawing/2014/main" id="{A4FB2876-3F44-4F6F-82B3-1C44F45A1552}"/>
+                <a16:creationId xmlns:a16="http://schemas.microsoft.com/office/drawing/2014/main" id="{3D74AF15-0A56-4475-A9EB-8CD405FFFC95}"/>
               </a:ext>
             </a:extLst>
           </p:cNvPr>
@@ -7153,7 +7113,7 @@
           <p:cNvPr id="4" name="">
             <a:extLst xmlns:a="http://schemas.openxmlformats.org/drawingml/2006/main">
               <a:ext uri="{FF2B5EF4-FFF2-40B4-BE49-F238E27FC236}">
-                <a16:creationId xmlns:a16="http://schemas.microsoft.com/office/drawing/2014/main" id="{9A661449-64FD-4EB7-8841-9AEAA8131F1C}"/>
+                <a16:creationId xmlns:a16="http://schemas.microsoft.com/office/drawing/2014/main" id="{5D9DAA6B-0336-44D5-95EE-B081B9B73EC6}"/>
               </a:ext>
             </a:extLst>
           </p:cNvPr>
@@ -7219,7 +7179,7 @@
           <p:cNvPr id="5" name="">
             <a:extLst xmlns:a="http://schemas.openxmlformats.org/drawingml/2006/main">
               <a:ext uri="{FF2B5EF4-FFF2-40B4-BE49-F238E27FC236}">
-                <a16:creationId xmlns:a16="http://schemas.microsoft.com/office/drawing/2014/main" id="{5B81B27B-AD79-41E4-8D93-762A7E70834B}"/>
+                <a16:creationId xmlns:a16="http://schemas.microsoft.com/office/drawing/2014/main" id="{B290A295-8D93-4A2B-AC70-3740EDB962C2}"/>
               </a:ext>
             </a:extLst>
           </p:cNvPr>
@@ -7285,7 +7245,7 @@
           <p:cNvPr id="6" name="">
             <a:extLst xmlns:a="http://schemas.openxmlformats.org/drawingml/2006/main">
               <a:ext uri="{FF2B5EF4-FFF2-40B4-BE49-F238E27FC236}">
-                <a16:creationId xmlns:a16="http://schemas.microsoft.com/office/drawing/2014/main" id="{560E9AE2-54E7-4CF8-B7F4-70F7878BA5A4}"/>
+                <a16:creationId xmlns:a16="http://schemas.microsoft.com/office/drawing/2014/main" id="{FEA05ED9-C4FD-4362-8D3C-024D74574476}"/>
               </a:ext>
             </a:extLst>
           </p:cNvPr>
@@ -7351,7 +7311,7 @@
           <p:cNvPr id="7" name="Chart">
             <a:extLst xmlns:a="http://schemas.openxmlformats.org/drawingml/2006/main">
               <a:ext uri="{FF2B5EF4-FFF2-40B4-BE49-F238E27FC236}">
-                <a16:creationId xmlns:a16="http://schemas.microsoft.com/office/drawing/2014/main" id="{868FCF3D-A724-4F1E-B033-1BD30124E18A}"/>
+                <a16:creationId xmlns:a16="http://schemas.microsoft.com/office/drawing/2014/main" id="{D56FAC84-8766-41F2-BCDF-B92D5FDCFEDF}"/>
               </a:ext>
             </a:extLst>
           </p:cNvPr>
@@ -7364,7 +7324,7 @@
         </p:xfrm>
         <a:graphic xmlns:a="http://schemas.openxmlformats.org/drawingml/2006/main">
           <a:graphicData uri="http://schemas.openxmlformats.org/drawingml/2006/chart">
-            <c:chart xmlns:r="http://schemas.openxmlformats.org/officeDocument/2006/relationships" xmlns:c="http://schemas.openxmlformats.org/drawingml/2006/chart" r:id="Rfd86c96e15ab4003"/>
+            <c:chart xmlns:r="http://schemas.openxmlformats.org/officeDocument/2006/relationships" xmlns:c="http://schemas.openxmlformats.org/drawingml/2006/chart" r:id="R1b74407e880a49ae"/>
           </a:graphicData>
         </a:graphic>
       </p:graphicFrame>
@@ -7373,7 +7333,7 @@
           <p:cNvPr id="8" name="Chart">
             <a:extLst xmlns:a="http://schemas.openxmlformats.org/drawingml/2006/main">
               <a:ext uri="{FF2B5EF4-FFF2-40B4-BE49-F238E27FC236}">
-                <a16:creationId xmlns:a16="http://schemas.microsoft.com/office/drawing/2014/main" id="{7E594DE0-D060-4511-8678-5E267FA5BE0B}"/>
+                <a16:creationId xmlns:a16="http://schemas.microsoft.com/office/drawing/2014/main" id="{1F898B20-034C-4FE9-A659-AD75BB946924}"/>
               </a:ext>
             </a:extLst>
           </p:cNvPr>
@@ -7386,7 +7346,7 @@
         </p:xfrm>
         <a:graphic xmlns:a="http://schemas.openxmlformats.org/drawingml/2006/main">
           <a:graphicData uri="http://schemas.openxmlformats.org/drawingml/2006/chart">
-            <c:chart xmlns:r="http://schemas.openxmlformats.org/officeDocument/2006/relationships" xmlns:c="http://schemas.openxmlformats.org/drawingml/2006/chart" r:id="R9de0f9a29e814b44"/>
+            <c:chart xmlns:r="http://schemas.openxmlformats.org/officeDocument/2006/relationships" xmlns:c="http://schemas.openxmlformats.org/drawingml/2006/chart" r:id="Re38ddd6924b64290"/>
           </a:graphicData>
         </a:graphic>
       </p:graphicFrame>
@@ -7395,7 +7355,7 @@
           <p:cNvPr id="9" name="">
             <a:extLst xmlns:a="http://schemas.openxmlformats.org/drawingml/2006/main">
               <a:ext uri="{FF2B5EF4-FFF2-40B4-BE49-F238E27FC236}">
-                <a16:creationId xmlns:a16="http://schemas.microsoft.com/office/drawing/2014/main" id="{2A46C022-8807-4779-B500-7B8AF3EE7B07}"/>
+                <a16:creationId xmlns:a16="http://schemas.microsoft.com/office/drawing/2014/main" id="{2050B862-8F1E-4758-A25E-E5848A0AB931}"/>
               </a:ext>
             </a:extLst>
           </p:cNvPr>
@@ -7461,7 +7421,7 @@
           <p:cNvPr id="10" name="">
             <a:extLst xmlns:a="http://schemas.openxmlformats.org/drawingml/2006/main">
               <a:ext uri="{FF2B5EF4-FFF2-40B4-BE49-F238E27FC236}">
-                <a16:creationId xmlns:a16="http://schemas.microsoft.com/office/drawing/2014/main" id="{25702705-0130-4A1D-8376-99194A494816}"/>
+                <a16:creationId xmlns:a16="http://schemas.microsoft.com/office/drawing/2014/main" id="{9DF6872F-C6FD-41D0-970B-D43B3E6D7638}"/>
               </a:ext>
             </a:extLst>
           </p:cNvPr>
@@ -7525,7 +7485,7 @@
     </p:spTree>
     <p:extLst>
       <p:ext uri="{BB962C8B-B14F-4D97-AF65-F5344CB8AC3E}">
-        <p14:creationId xmlns:p14="http://schemas.microsoft.com/office/powerpoint/2010/main" val="1616700673"/>
+        <p14:creationId xmlns:p14="http://schemas.microsoft.com/office/powerpoint/2010/main" val="719328212"/>
       </p:ext>
     </p:extLst>
   </p:cSld>
@@ -7556,7 +7516,7 @@
           <p:cNvPr id="57" name="">
             <a:extLst xmlns:a="http://schemas.openxmlformats.org/drawingml/2006/main">
               <a:ext uri="{FF2B5EF4-FFF2-40B4-BE49-F238E27FC236}">
-                <a16:creationId xmlns:a16="http://schemas.microsoft.com/office/drawing/2014/main" id="{4FBD98AA-A103-49E4-B90C-C70AA2F8FF6F}"/>
+                <a16:creationId xmlns:a16="http://schemas.microsoft.com/office/drawing/2014/main" id="{144B272E-29D5-4076-AE97-4E0D381B3050}"/>
               </a:ext>
             </a:extLst>
           </p:cNvPr>
@@ -7622,7 +7582,7 @@
           <p:cNvPr id="2" name="">
             <a:extLst xmlns:a="http://schemas.openxmlformats.org/drawingml/2006/main">
               <a:ext uri="{FF2B5EF4-FFF2-40B4-BE49-F238E27FC236}">
-                <a16:creationId xmlns:a16="http://schemas.microsoft.com/office/drawing/2014/main" id="{7D1D5771-CB57-4C90-8E97-43CFD6109A4A}"/>
+                <a16:creationId xmlns:a16="http://schemas.microsoft.com/office/drawing/2014/main" id="{03C2E16C-D181-4C1E-9C68-4313AF4D5BE6}"/>
               </a:ext>
             </a:extLst>
           </p:cNvPr>
@@ -7688,7 +7648,7 @@
           <p:cNvPr id="3" name="">
             <a:extLst xmlns:a="http://schemas.openxmlformats.org/drawingml/2006/main">
               <a:ext uri="{FF2B5EF4-FFF2-40B4-BE49-F238E27FC236}">
-                <a16:creationId xmlns:a16="http://schemas.microsoft.com/office/drawing/2014/main" id="{1A4F1CE5-9E16-4499-A3D7-C1FCE014A311}"/>
+                <a16:creationId xmlns:a16="http://schemas.microsoft.com/office/drawing/2014/main" id="{D8D29DEA-61A2-4F1D-9A4E-146137398437}"/>
               </a:ext>
             </a:extLst>
           </p:cNvPr>
@@ -7754,7 +7714,7 @@
           <p:cNvPr id="4" name="">
             <a:extLst xmlns:a="http://schemas.openxmlformats.org/drawingml/2006/main">
               <a:ext uri="{FF2B5EF4-FFF2-40B4-BE49-F238E27FC236}">
-                <a16:creationId xmlns:a16="http://schemas.microsoft.com/office/drawing/2014/main" id="{E413A253-5254-4643-A31C-FDC7F1FBDEF2}"/>
+                <a16:creationId xmlns:a16="http://schemas.microsoft.com/office/drawing/2014/main" id="{293202FD-A490-4FFC-AE00-C081FACD63F9}"/>
               </a:ext>
             </a:extLst>
           </p:cNvPr>
@@ -7820,7 +7780,7 @@
           <p:cNvPr id="5" name="">
             <a:extLst xmlns:a="http://schemas.openxmlformats.org/drawingml/2006/main">
               <a:ext uri="{FF2B5EF4-FFF2-40B4-BE49-F238E27FC236}">
-                <a16:creationId xmlns:a16="http://schemas.microsoft.com/office/drawing/2014/main" id="{492A4431-2637-471B-8E2B-3E4DF8F16632}"/>
+                <a16:creationId xmlns:a16="http://schemas.microsoft.com/office/drawing/2014/main" id="{59A3A23E-365F-4651-BE78-342C683129C5}"/>
               </a:ext>
             </a:extLst>
           </p:cNvPr>
@@ -7886,7 +7846,7 @@
           <p:cNvPr id="6" name="">
             <a:extLst xmlns:a="http://schemas.openxmlformats.org/drawingml/2006/main">
               <a:ext uri="{FF2B5EF4-FFF2-40B4-BE49-F238E27FC236}">
-                <a16:creationId xmlns:a16="http://schemas.microsoft.com/office/drawing/2014/main" id="{3501AE6A-6C0B-4F53-92B8-0C8C2BD07916}"/>
+                <a16:creationId xmlns:a16="http://schemas.microsoft.com/office/drawing/2014/main" id="{6BAF49AD-E244-47C3-932D-CB3AA7835866}"/>
               </a:ext>
             </a:extLst>
           </p:cNvPr>
@@ -7952,7 +7912,7 @@
           <p:cNvPr id="7" name="Chart">
             <a:extLst xmlns:a="http://schemas.openxmlformats.org/drawingml/2006/main">
               <a:ext uri="{FF2B5EF4-FFF2-40B4-BE49-F238E27FC236}">
-                <a16:creationId xmlns:a16="http://schemas.microsoft.com/office/drawing/2014/main" id="{36BE49C4-1F77-47C3-AA3D-D3B9C9F6D5A0}"/>
+                <a16:creationId xmlns:a16="http://schemas.microsoft.com/office/drawing/2014/main" id="{E56A0E56-F61E-43B6-BED9-CFCABFD76569}"/>
               </a:ext>
             </a:extLst>
           </p:cNvPr>
@@ -7965,7 +7925,7 @@
         </p:xfrm>
         <a:graphic xmlns:a="http://schemas.openxmlformats.org/drawingml/2006/main">
           <a:graphicData uri="http://schemas.openxmlformats.org/drawingml/2006/chart">
-            <c:chart xmlns:r="http://schemas.openxmlformats.org/officeDocument/2006/relationships" xmlns:c="http://schemas.openxmlformats.org/drawingml/2006/chart" r:id="Ra6b3521247bf4ac6"/>
+            <c:chart xmlns:r="http://schemas.openxmlformats.org/officeDocument/2006/relationships" xmlns:c="http://schemas.openxmlformats.org/drawingml/2006/chart" r:id="Re4fcc5753da14944"/>
           </a:graphicData>
         </a:graphic>
       </p:graphicFrame>
@@ -7974,7 +7934,7 @@
           <p:cNvPr id="8" name="">
             <a:extLst xmlns:a="http://schemas.openxmlformats.org/drawingml/2006/main">
               <a:ext uri="{FF2B5EF4-FFF2-40B4-BE49-F238E27FC236}">
-                <a16:creationId xmlns:a16="http://schemas.microsoft.com/office/drawing/2014/main" id="{D69AA086-2D5A-4BD1-99B0-D5B83D03C278}"/>
+                <a16:creationId xmlns:a16="http://schemas.microsoft.com/office/drawing/2014/main" id="{DFA90AE0-E971-4E17-A709-7BFD7186F647}"/>
               </a:ext>
             </a:extLst>
           </p:cNvPr>
@@ -8004,7 +7964,7 @@
           <p:cNvPr id="9" name="">
             <a:extLst xmlns:a="http://schemas.openxmlformats.org/drawingml/2006/main">
               <a:ext uri="{FF2B5EF4-FFF2-40B4-BE49-F238E27FC236}">
-                <a16:creationId xmlns:a16="http://schemas.microsoft.com/office/drawing/2014/main" id="{0A42B247-698C-4763-9FA1-1147FDC421E4}"/>
+                <a16:creationId xmlns:a16="http://schemas.microsoft.com/office/drawing/2014/main" id="{48EFEB65-92A6-406C-88A7-004F31703943}"/>
               </a:ext>
             </a:extLst>
           </p:cNvPr>
@@ -8070,7 +8030,7 @@
           <p:cNvPr id="10" name="">
             <a:extLst xmlns:a="http://schemas.openxmlformats.org/drawingml/2006/main">
               <a:ext uri="{FF2B5EF4-FFF2-40B4-BE49-F238E27FC236}">
-                <a16:creationId xmlns:a16="http://schemas.microsoft.com/office/drawing/2014/main" id="{5928E544-016B-4434-B70E-2A9D22A6BB00}"/>
+                <a16:creationId xmlns:a16="http://schemas.microsoft.com/office/drawing/2014/main" id="{2F1EE76E-F1AE-4BC4-BD3A-2BF03A403CDA}"/>
               </a:ext>
             </a:extLst>
           </p:cNvPr>
@@ -8100,7 +8060,7 @@
           <p:cNvPr id="11" name="">
             <a:extLst xmlns:a="http://schemas.openxmlformats.org/drawingml/2006/main">
               <a:ext uri="{FF2B5EF4-FFF2-40B4-BE49-F238E27FC236}">
-                <a16:creationId xmlns:a16="http://schemas.microsoft.com/office/drawing/2014/main" id="{BF133351-C595-4FA1-AADD-9441C1121DE4}"/>
+                <a16:creationId xmlns:a16="http://schemas.microsoft.com/office/drawing/2014/main" id="{A190FD25-A8C9-45EA-94DE-EA7B6CA9C1C9}"/>
               </a:ext>
             </a:extLst>
           </p:cNvPr>
@@ -8166,7 +8126,7 @@
           <p:cNvPr id="12" name="">
             <a:extLst xmlns:a="http://schemas.openxmlformats.org/drawingml/2006/main">
               <a:ext uri="{FF2B5EF4-FFF2-40B4-BE49-F238E27FC236}">
-                <a16:creationId xmlns:a16="http://schemas.microsoft.com/office/drawing/2014/main" id="{23C4179A-4E59-4C34-85F2-428856389779}"/>
+                <a16:creationId xmlns:a16="http://schemas.microsoft.com/office/drawing/2014/main" id="{E427B71F-2212-427F-8F23-D8CA66185B14}"/>
               </a:ext>
             </a:extLst>
           </p:cNvPr>
@@ -8196,7 +8156,7 @@
           <p:cNvPr id="13" name="">
             <a:extLst xmlns:a="http://schemas.openxmlformats.org/drawingml/2006/main">
               <a:ext uri="{FF2B5EF4-FFF2-40B4-BE49-F238E27FC236}">
-                <a16:creationId xmlns:a16="http://schemas.microsoft.com/office/drawing/2014/main" id="{FEC1D944-C524-48BA-9B73-0AF9546C575E}"/>
+                <a16:creationId xmlns:a16="http://schemas.microsoft.com/office/drawing/2014/main" id="{9237E73B-C8E9-4178-9B4F-B3E4AA6D4832}"/>
               </a:ext>
             </a:extLst>
           </p:cNvPr>
@@ -8262,7 +8222,7 @@
           <p:cNvPr id="14" name="">
             <a:extLst xmlns:a="http://schemas.openxmlformats.org/drawingml/2006/main">
               <a:ext uri="{FF2B5EF4-FFF2-40B4-BE49-F238E27FC236}">
-                <a16:creationId xmlns:a16="http://schemas.microsoft.com/office/drawing/2014/main" id="{8211E7BE-B6F7-46C0-910F-3873FF7D9E81}"/>
+                <a16:creationId xmlns:a16="http://schemas.microsoft.com/office/drawing/2014/main" id="{C93254CA-BD8C-4B92-8159-F6A880C178C7}"/>
               </a:ext>
             </a:extLst>
           </p:cNvPr>
@@ -8292,7 +8252,7 @@
           <p:cNvPr id="15" name="">
             <a:extLst xmlns:a="http://schemas.openxmlformats.org/drawingml/2006/main">
               <a:ext uri="{FF2B5EF4-FFF2-40B4-BE49-F238E27FC236}">
-                <a16:creationId xmlns:a16="http://schemas.microsoft.com/office/drawing/2014/main" id="{6B849137-5F95-4D10-8BC5-737BBE224B9C}"/>
+                <a16:creationId xmlns:a16="http://schemas.microsoft.com/office/drawing/2014/main" id="{DA350925-2841-456E-8C22-FA33CE43B7BE}"/>
               </a:ext>
             </a:extLst>
           </p:cNvPr>
@@ -8358,7 +8318,7 @@
           <p:cNvPr id="16" name="">
             <a:extLst xmlns:a="http://schemas.openxmlformats.org/drawingml/2006/main">
               <a:ext uri="{FF2B5EF4-FFF2-40B4-BE49-F238E27FC236}">
-                <a16:creationId xmlns:a16="http://schemas.microsoft.com/office/drawing/2014/main" id="{6FD37422-3FF4-4436-8894-4A4880CC1A0B}"/>
+                <a16:creationId xmlns:a16="http://schemas.microsoft.com/office/drawing/2014/main" id="{A910EF14-3662-4A08-8723-B0649F203E13}"/>
               </a:ext>
             </a:extLst>
           </p:cNvPr>
@@ -8388,7 +8348,7 @@
           <p:cNvPr id="17" name="">
             <a:extLst xmlns:a="http://schemas.openxmlformats.org/drawingml/2006/main">
               <a:ext uri="{FF2B5EF4-FFF2-40B4-BE49-F238E27FC236}">
-                <a16:creationId xmlns:a16="http://schemas.microsoft.com/office/drawing/2014/main" id="{F44290B6-3A2C-4481-8D74-50955E797B63}"/>
+                <a16:creationId xmlns:a16="http://schemas.microsoft.com/office/drawing/2014/main" id="{C03A26DA-C1BB-477A-BD7D-51061DE3EEEC}"/>
               </a:ext>
             </a:extLst>
           </p:cNvPr>
@@ -8454,7 +8414,7 @@
           <p:cNvPr id="18" name="">
             <a:extLst xmlns:a="http://schemas.openxmlformats.org/drawingml/2006/main">
               <a:ext uri="{FF2B5EF4-FFF2-40B4-BE49-F238E27FC236}">
-                <a16:creationId xmlns:a16="http://schemas.microsoft.com/office/drawing/2014/main" id="{905A5486-195C-4CF0-B180-2FFD24937633}"/>
+                <a16:creationId xmlns:a16="http://schemas.microsoft.com/office/drawing/2014/main" id="{76F87FDD-8C55-4C2B-AC53-A264E8B202B9}"/>
               </a:ext>
             </a:extLst>
           </p:cNvPr>
@@ -8484,7 +8444,7 @@
           <p:cNvPr id="19" name="">
             <a:extLst xmlns:a="http://schemas.openxmlformats.org/drawingml/2006/main">
               <a:ext uri="{FF2B5EF4-FFF2-40B4-BE49-F238E27FC236}">
-                <a16:creationId xmlns:a16="http://schemas.microsoft.com/office/drawing/2014/main" id="{34928045-EF5C-4538-A7AE-B64F41326F88}"/>
+                <a16:creationId xmlns:a16="http://schemas.microsoft.com/office/drawing/2014/main" id="{CCBAF748-0B34-4A60-8E91-EE83901C12A5}"/>
               </a:ext>
             </a:extLst>
           </p:cNvPr>
@@ -8550,7 +8510,7 @@
           <p:cNvPr id="20" name="">
             <a:extLst xmlns:a="http://schemas.openxmlformats.org/drawingml/2006/main">
               <a:ext uri="{FF2B5EF4-FFF2-40B4-BE49-F238E27FC236}">
-                <a16:creationId xmlns:a16="http://schemas.microsoft.com/office/drawing/2014/main" id="{AC5A48CB-5299-4531-9D61-D93D4F8E58B8}"/>
+                <a16:creationId xmlns:a16="http://schemas.microsoft.com/office/drawing/2014/main" id="{90010B45-4E47-4CE1-B254-F35C5BD99685}"/>
               </a:ext>
             </a:extLst>
           </p:cNvPr>
@@ -8580,7 +8540,7 @@
           <p:cNvPr id="21" name="">
             <a:extLst xmlns:a="http://schemas.openxmlformats.org/drawingml/2006/main">
               <a:ext uri="{FF2B5EF4-FFF2-40B4-BE49-F238E27FC236}">
-                <a16:creationId xmlns:a16="http://schemas.microsoft.com/office/drawing/2014/main" id="{6669DF61-286B-4EB3-8195-947315CEDD0D}"/>
+                <a16:creationId xmlns:a16="http://schemas.microsoft.com/office/drawing/2014/main" id="{AC5F2CB9-CCE0-4748-9D65-26CD585F350B}"/>
               </a:ext>
             </a:extLst>
           </p:cNvPr>
@@ -8610,7 +8570,7 @@
           <p:cNvPr id="22" name="">
             <a:extLst xmlns:a="http://schemas.openxmlformats.org/drawingml/2006/main">
               <a:ext uri="{FF2B5EF4-FFF2-40B4-BE49-F238E27FC236}">
-                <a16:creationId xmlns:a16="http://schemas.microsoft.com/office/drawing/2014/main" id="{89C85BED-5016-455B-B13F-66AB1FC8D5E9}"/>
+                <a16:creationId xmlns:a16="http://schemas.microsoft.com/office/drawing/2014/main" id="{A4013B41-BA97-4030-8BEF-C1A10BBF1EF4}"/>
               </a:ext>
             </a:extLst>
           </p:cNvPr>
@@ -8640,7 +8600,7 @@
           <p:cNvPr id="23" name="">
             <a:extLst xmlns:a="http://schemas.openxmlformats.org/drawingml/2006/main">
               <a:ext uri="{FF2B5EF4-FFF2-40B4-BE49-F238E27FC236}">
-                <a16:creationId xmlns:a16="http://schemas.microsoft.com/office/drawing/2014/main" id="{7180D1F5-3B59-428A-8034-B65F91924FA1}"/>
+                <a16:creationId xmlns:a16="http://schemas.microsoft.com/office/drawing/2014/main" id="{FBEE368B-9211-4621-81C8-2D76BA3EE8CE}"/>
               </a:ext>
             </a:extLst>
           </p:cNvPr>
@@ -8670,7 +8630,7 @@
           <p:cNvPr id="24" name="">
             <a:extLst xmlns:a="http://schemas.openxmlformats.org/drawingml/2006/main">
               <a:ext uri="{FF2B5EF4-FFF2-40B4-BE49-F238E27FC236}">
-                <a16:creationId xmlns:a16="http://schemas.microsoft.com/office/drawing/2014/main" id="{8E45C44F-E542-429C-9F6F-A4505854996A}"/>
+                <a16:creationId xmlns:a16="http://schemas.microsoft.com/office/drawing/2014/main" id="{0496FD51-EB7D-4E1C-A933-58C1C63E8EE6}"/>
               </a:ext>
             </a:extLst>
           </p:cNvPr>
@@ -8700,7 +8660,7 @@
           <p:cNvPr id="25" name="">
             <a:extLst xmlns:a="http://schemas.openxmlformats.org/drawingml/2006/main">
               <a:ext uri="{FF2B5EF4-FFF2-40B4-BE49-F238E27FC236}">
-                <a16:creationId xmlns:a16="http://schemas.microsoft.com/office/drawing/2014/main" id="{16275F90-A7C2-4078-B132-42A9E333A2A2}"/>
+                <a16:creationId xmlns:a16="http://schemas.microsoft.com/office/drawing/2014/main" id="{F64C6DC4-4AAB-4D62-8E79-BFEF1725CFA2}"/>
               </a:ext>
             </a:extLst>
           </p:cNvPr>
@@ -8730,7 +8690,7 @@
           <p:cNvPr id="26" name="">
             <a:extLst xmlns:a="http://schemas.openxmlformats.org/drawingml/2006/main">
               <a:ext uri="{FF2B5EF4-FFF2-40B4-BE49-F238E27FC236}">
-                <a16:creationId xmlns:a16="http://schemas.microsoft.com/office/drawing/2014/main" id="{03321594-AB57-4E12-9995-33DF50CB0BA7}"/>
+                <a16:creationId xmlns:a16="http://schemas.microsoft.com/office/drawing/2014/main" id="{2B717A67-6F8E-4482-9185-624D7BC98034}"/>
               </a:ext>
             </a:extLst>
           </p:cNvPr>
@@ -8760,7 +8720,7 @@
           <p:cNvPr id="27" name="">
             <a:extLst xmlns:a="http://schemas.openxmlformats.org/drawingml/2006/main">
               <a:ext uri="{FF2B5EF4-FFF2-40B4-BE49-F238E27FC236}">
-                <a16:creationId xmlns:a16="http://schemas.microsoft.com/office/drawing/2014/main" id="{43292DC2-98ED-4548-AAD8-14DB3534A9E5}"/>
+                <a16:creationId xmlns:a16="http://schemas.microsoft.com/office/drawing/2014/main" id="{80A7E1D8-29E4-45D0-B46F-64AA95353C3E}"/>
               </a:ext>
             </a:extLst>
           </p:cNvPr>
@@ -8826,7 +8786,7 @@
           <p:cNvPr id="28" name="">
             <a:extLst xmlns:a="http://schemas.openxmlformats.org/drawingml/2006/main">
               <a:ext uri="{FF2B5EF4-FFF2-40B4-BE49-F238E27FC236}">
-                <a16:creationId xmlns:a16="http://schemas.microsoft.com/office/drawing/2014/main" id="{A09C272C-6C61-4D88-A631-6D88CB0370E9}"/>
+                <a16:creationId xmlns:a16="http://schemas.microsoft.com/office/drawing/2014/main" id="{151C4F38-8743-4964-95AF-8FB6F76A6D6A}"/>
               </a:ext>
             </a:extLst>
           </p:cNvPr>
@@ -8856,7 +8816,7 @@
           <p:cNvPr id="29" name="">
             <a:extLst xmlns:a="http://schemas.openxmlformats.org/drawingml/2006/main">
               <a:ext uri="{FF2B5EF4-FFF2-40B4-BE49-F238E27FC236}">
-                <a16:creationId xmlns:a16="http://schemas.microsoft.com/office/drawing/2014/main" id="{16150C9E-37C4-43EF-91D3-50EE2BB4E4D5}"/>
+                <a16:creationId xmlns:a16="http://schemas.microsoft.com/office/drawing/2014/main" id="{27C845AB-73E5-44A5-B019-B8CE6DF35F9B}"/>
               </a:ext>
             </a:extLst>
           </p:cNvPr>
@@ -8886,7 +8846,7 @@
           <p:cNvPr id="30" name="">
             <a:extLst xmlns:a="http://schemas.openxmlformats.org/drawingml/2006/main">
               <a:ext uri="{FF2B5EF4-FFF2-40B4-BE49-F238E27FC236}">
-                <a16:creationId xmlns:a16="http://schemas.microsoft.com/office/drawing/2014/main" id="{E0B0B521-2215-4F7F-A758-ABA00BEDE9B1}"/>
+                <a16:creationId xmlns:a16="http://schemas.microsoft.com/office/drawing/2014/main" id="{BE77668C-2D5A-4CEF-A0A0-4792AA272F5A}"/>
               </a:ext>
             </a:extLst>
           </p:cNvPr>
@@ -8916,7 +8876,7 @@
           <p:cNvPr id="31" name="">
             <a:extLst xmlns:a="http://schemas.openxmlformats.org/drawingml/2006/main">
               <a:ext uri="{FF2B5EF4-FFF2-40B4-BE49-F238E27FC236}">
-                <a16:creationId xmlns:a16="http://schemas.microsoft.com/office/drawing/2014/main" id="{45CD780A-23C8-4D5D-864F-D1AF76DE0CFA}"/>
+                <a16:creationId xmlns:a16="http://schemas.microsoft.com/office/drawing/2014/main" id="{3288C92C-44D4-4E15-B2A7-48A9BA9FFA26}"/>
               </a:ext>
             </a:extLst>
           </p:cNvPr>
@@ -8946,7 +8906,7 @@
           <p:cNvPr id="32" name="">
             <a:extLst xmlns:a="http://schemas.openxmlformats.org/drawingml/2006/main">
               <a:ext uri="{FF2B5EF4-FFF2-40B4-BE49-F238E27FC236}">
-                <a16:creationId xmlns:a16="http://schemas.microsoft.com/office/drawing/2014/main" id="{236C0217-A873-462D-85F1-D9B3CCF8FBE3}"/>
+                <a16:creationId xmlns:a16="http://schemas.microsoft.com/office/drawing/2014/main" id="{D3D3F95A-1D1A-4883-95EB-56DAC57161FE}"/>
               </a:ext>
             </a:extLst>
           </p:cNvPr>
@@ -8976,7 +8936,7 @@
           <p:cNvPr id="33" name="">
             <a:extLst xmlns:a="http://schemas.openxmlformats.org/drawingml/2006/main">
               <a:ext uri="{FF2B5EF4-FFF2-40B4-BE49-F238E27FC236}">
-                <a16:creationId xmlns:a16="http://schemas.microsoft.com/office/drawing/2014/main" id="{B450C9BE-F808-43BF-B5B1-966AB94573A8}"/>
+                <a16:creationId xmlns:a16="http://schemas.microsoft.com/office/drawing/2014/main" id="{335A3F86-918D-4BB2-8C38-B515E27C996C}"/>
               </a:ext>
             </a:extLst>
           </p:cNvPr>
@@ -9006,7 +8966,7 @@
           <p:cNvPr id="34" name="">
             <a:extLst xmlns:a="http://schemas.openxmlformats.org/drawingml/2006/main">
               <a:ext uri="{FF2B5EF4-FFF2-40B4-BE49-F238E27FC236}">
-                <a16:creationId xmlns:a16="http://schemas.microsoft.com/office/drawing/2014/main" id="{9116C8D6-CAFB-48B2-8785-BFC792A16B9E}"/>
+                <a16:creationId xmlns:a16="http://schemas.microsoft.com/office/drawing/2014/main" id="{18501BE1-8EF9-4855-B378-3AB00AF4C7A4}"/>
               </a:ext>
             </a:extLst>
           </p:cNvPr>
@@ -9072,7 +9032,7 @@
           <p:cNvPr id="35" name="">
             <a:extLst xmlns:a="http://schemas.openxmlformats.org/drawingml/2006/main">
               <a:ext uri="{FF2B5EF4-FFF2-40B4-BE49-F238E27FC236}">
-                <a16:creationId xmlns:a16="http://schemas.microsoft.com/office/drawing/2014/main" id="{CBEEDA24-94F2-4895-ABC4-F136E1355964}"/>
+                <a16:creationId xmlns:a16="http://schemas.microsoft.com/office/drawing/2014/main" id="{013A29FA-B79C-43AB-AB51-A7CD2ED9C10B}"/>
               </a:ext>
             </a:extLst>
           </p:cNvPr>
@@ -9102,7 +9062,7 @@
           <p:cNvPr id="36" name="">
             <a:extLst xmlns:a="http://schemas.openxmlformats.org/drawingml/2006/main">
               <a:ext uri="{FF2B5EF4-FFF2-40B4-BE49-F238E27FC236}">
-                <a16:creationId xmlns:a16="http://schemas.microsoft.com/office/drawing/2014/main" id="{DE724337-FCA3-47B5-8270-122D922C532B}"/>
+                <a16:creationId xmlns:a16="http://schemas.microsoft.com/office/drawing/2014/main" id="{3A20F206-8A87-438E-9115-C31443C20EEF}"/>
               </a:ext>
             </a:extLst>
           </p:cNvPr>
@@ -9132,7 +9092,7 @@
           <p:cNvPr id="37" name="">
             <a:extLst xmlns:a="http://schemas.openxmlformats.org/drawingml/2006/main">
               <a:ext uri="{FF2B5EF4-FFF2-40B4-BE49-F238E27FC236}">
-                <a16:creationId xmlns:a16="http://schemas.microsoft.com/office/drawing/2014/main" id="{66ADF25A-C4BA-4E04-B04A-0E6C1AB22261}"/>
+                <a16:creationId xmlns:a16="http://schemas.microsoft.com/office/drawing/2014/main" id="{035F77CE-1496-48FB-8482-82B75E0DD0E0}"/>
               </a:ext>
             </a:extLst>
           </p:cNvPr>
@@ -9162,7 +9122,7 @@
           <p:cNvPr id="38" name="">
             <a:extLst xmlns:a="http://schemas.openxmlformats.org/drawingml/2006/main">
               <a:ext uri="{FF2B5EF4-FFF2-40B4-BE49-F238E27FC236}">
-                <a16:creationId xmlns:a16="http://schemas.microsoft.com/office/drawing/2014/main" id="{BF757105-4542-4389-AC53-33E14DEB789B}"/>
+                <a16:creationId xmlns:a16="http://schemas.microsoft.com/office/drawing/2014/main" id="{04CADA89-0C89-4C91-AEB5-6817C11665CE}"/>
               </a:ext>
             </a:extLst>
           </p:cNvPr>
@@ -9192,7 +9152,7 @@
           <p:cNvPr id="39" name="">
             <a:extLst xmlns:a="http://schemas.openxmlformats.org/drawingml/2006/main">
               <a:ext uri="{FF2B5EF4-FFF2-40B4-BE49-F238E27FC236}">
-                <a16:creationId xmlns:a16="http://schemas.microsoft.com/office/drawing/2014/main" id="{988DDED6-A60E-4B4B-8E14-8364EF9D2676}"/>
+                <a16:creationId xmlns:a16="http://schemas.microsoft.com/office/drawing/2014/main" id="{E720E18F-AFCE-4719-BAC9-57753B9C2C66}"/>
               </a:ext>
             </a:extLst>
           </p:cNvPr>
@@ -9222,7 +9182,7 @@
           <p:cNvPr id="40" name="">
             <a:extLst xmlns:a="http://schemas.openxmlformats.org/drawingml/2006/main">
               <a:ext uri="{FF2B5EF4-FFF2-40B4-BE49-F238E27FC236}">
-                <a16:creationId xmlns:a16="http://schemas.microsoft.com/office/drawing/2014/main" id="{0BC1C154-68E0-4112-A7AF-B6D5E37EE9F8}"/>
+                <a16:creationId xmlns:a16="http://schemas.microsoft.com/office/drawing/2014/main" id="{BCDF279C-9EB7-46D6-9D29-BC557C755184}"/>
               </a:ext>
             </a:extLst>
           </p:cNvPr>
@@ -9288,7 +9248,7 @@
           <p:cNvPr id="41" name="">
             <a:extLst xmlns:a="http://schemas.openxmlformats.org/drawingml/2006/main">
               <a:ext uri="{FF2B5EF4-FFF2-40B4-BE49-F238E27FC236}">
-                <a16:creationId xmlns:a16="http://schemas.microsoft.com/office/drawing/2014/main" id="{87D72BCE-738B-4C3E-8F86-35B3EABCFA60}"/>
+                <a16:creationId xmlns:a16="http://schemas.microsoft.com/office/drawing/2014/main" id="{3DEBDC8A-03A8-4A0D-956C-E68E337D2C06}"/>
               </a:ext>
             </a:extLst>
           </p:cNvPr>
@@ -9318,7 +9278,7 @@
           <p:cNvPr id="42" name="">
             <a:extLst xmlns:a="http://schemas.openxmlformats.org/drawingml/2006/main">
               <a:ext uri="{FF2B5EF4-FFF2-40B4-BE49-F238E27FC236}">
-                <a16:creationId xmlns:a16="http://schemas.microsoft.com/office/drawing/2014/main" id="{C53A1021-D706-4A6B-81C8-52C65CBECBB8}"/>
+                <a16:creationId xmlns:a16="http://schemas.microsoft.com/office/drawing/2014/main" id="{5CBEB58D-F12F-4541-8F82-2AE230780FF1}"/>
               </a:ext>
             </a:extLst>
           </p:cNvPr>
@@ -9348,7 +9308,7 @@
           <p:cNvPr id="43" name="">
             <a:extLst xmlns:a="http://schemas.openxmlformats.org/drawingml/2006/main">
               <a:ext uri="{FF2B5EF4-FFF2-40B4-BE49-F238E27FC236}">
-                <a16:creationId xmlns:a16="http://schemas.microsoft.com/office/drawing/2014/main" id="{A4A125BF-BF87-4107-AE70-879DFE5CF700}"/>
+                <a16:creationId xmlns:a16="http://schemas.microsoft.com/office/drawing/2014/main" id="{DEED28FE-6465-4B94-8DA3-0DED0A263EEC}"/>
               </a:ext>
             </a:extLst>
           </p:cNvPr>
@@ -9378,7 +9338,7 @@
           <p:cNvPr id="44" name="">
             <a:extLst xmlns:a="http://schemas.openxmlformats.org/drawingml/2006/main">
               <a:ext uri="{FF2B5EF4-FFF2-40B4-BE49-F238E27FC236}">
-                <a16:creationId xmlns:a16="http://schemas.microsoft.com/office/drawing/2014/main" id="{D63244E1-5B6E-4582-9446-1A3AE74B603D}"/>
+                <a16:creationId xmlns:a16="http://schemas.microsoft.com/office/drawing/2014/main" id="{7BABC5E3-BDC0-47FC-B61C-8FF0C2C67596}"/>
               </a:ext>
             </a:extLst>
           </p:cNvPr>
@@ -9408,7 +9368,7 @@
           <p:cNvPr id="45" name="">
             <a:extLst xmlns:a="http://schemas.openxmlformats.org/drawingml/2006/main">
               <a:ext uri="{FF2B5EF4-FFF2-40B4-BE49-F238E27FC236}">
-                <a16:creationId xmlns:a16="http://schemas.microsoft.com/office/drawing/2014/main" id="{2BEC07C8-CA61-494F-8592-E63B6E0883FF}"/>
+                <a16:creationId xmlns:a16="http://schemas.microsoft.com/office/drawing/2014/main" id="{DC4B786F-A672-4CDA-AFD7-75B036575A32}"/>
               </a:ext>
             </a:extLst>
           </p:cNvPr>
@@ -9438,7 +9398,7 @@
           <p:cNvPr id="46" name="">
             <a:extLst xmlns:a="http://schemas.openxmlformats.org/drawingml/2006/main">
               <a:ext uri="{FF2B5EF4-FFF2-40B4-BE49-F238E27FC236}">
-                <a16:creationId xmlns:a16="http://schemas.microsoft.com/office/drawing/2014/main" id="{B7BF76BC-7133-4FDE-B0FD-AA6C599A26DE}"/>
+                <a16:creationId xmlns:a16="http://schemas.microsoft.com/office/drawing/2014/main" id="{C7D846BF-2CFE-4CE9-83FE-C72416BD5FCB}"/>
               </a:ext>
             </a:extLst>
           </p:cNvPr>
@@ -9504,7 +9464,7 @@
           <p:cNvPr id="47" name="">
             <a:extLst xmlns:a="http://schemas.openxmlformats.org/drawingml/2006/main">
               <a:ext uri="{FF2B5EF4-FFF2-40B4-BE49-F238E27FC236}">
-                <a16:creationId xmlns:a16="http://schemas.microsoft.com/office/drawing/2014/main" id="{8FD18A7F-4967-4ECD-A0B1-9BEE9B81561D}"/>
+                <a16:creationId xmlns:a16="http://schemas.microsoft.com/office/drawing/2014/main" id="{C4DCE50E-B54E-4AA1-B0AF-91F9031821B8}"/>
               </a:ext>
             </a:extLst>
           </p:cNvPr>
@@ -9534,7 +9494,7 @@
           <p:cNvPr id="48" name="">
             <a:extLst xmlns:a="http://schemas.openxmlformats.org/drawingml/2006/main">
               <a:ext uri="{FF2B5EF4-FFF2-40B4-BE49-F238E27FC236}">
-                <a16:creationId xmlns:a16="http://schemas.microsoft.com/office/drawing/2014/main" id="{EEC10272-976D-4E7C-99AC-BFBC90752019}"/>
+                <a16:creationId xmlns:a16="http://schemas.microsoft.com/office/drawing/2014/main" id="{8312A982-7913-4625-ADC2-78C8E264DE12}"/>
               </a:ext>
             </a:extLst>
           </p:cNvPr>
@@ -9564,7 +9524,7 @@
           <p:cNvPr id="49" name="">
             <a:extLst xmlns:a="http://schemas.openxmlformats.org/drawingml/2006/main">
               <a:ext uri="{FF2B5EF4-FFF2-40B4-BE49-F238E27FC236}">
-                <a16:creationId xmlns:a16="http://schemas.microsoft.com/office/drawing/2014/main" id="{683FDE37-D5F3-4FA8-A8CA-BA3B26BA4217}"/>
+                <a16:creationId xmlns:a16="http://schemas.microsoft.com/office/drawing/2014/main" id="{6BC17CD3-BC7B-49D8-8704-C8A84737E8A1}"/>
               </a:ext>
             </a:extLst>
           </p:cNvPr>
@@ -9594,7 +9554,7 @@
           <p:cNvPr id="50" name="">
             <a:extLst xmlns:a="http://schemas.openxmlformats.org/drawingml/2006/main">
               <a:ext uri="{FF2B5EF4-FFF2-40B4-BE49-F238E27FC236}">
-                <a16:creationId xmlns:a16="http://schemas.microsoft.com/office/drawing/2014/main" id="{EAA074D3-2255-461A-A223-A55BC1D17BC9}"/>
+                <a16:creationId xmlns:a16="http://schemas.microsoft.com/office/drawing/2014/main" id="{5049FCD4-5F8A-4823-834D-F584CDC214B2}"/>
               </a:ext>
             </a:extLst>
           </p:cNvPr>
@@ -9624,7 +9584,7 @@
           <p:cNvPr id="51" name="">
             <a:extLst xmlns:a="http://schemas.openxmlformats.org/drawingml/2006/main">
               <a:ext uri="{FF2B5EF4-FFF2-40B4-BE49-F238E27FC236}">
-                <a16:creationId xmlns:a16="http://schemas.microsoft.com/office/drawing/2014/main" id="{D04E20D9-E117-4FC3-8779-65E456719DA0}"/>
+                <a16:creationId xmlns:a16="http://schemas.microsoft.com/office/drawing/2014/main" id="{7160667C-A07A-4DCB-B8B5-B842FC54AD40}"/>
               </a:ext>
             </a:extLst>
           </p:cNvPr>
@@ -9654,7 +9614,7 @@
           <p:cNvPr id="52" name="">
             <a:extLst xmlns:a="http://schemas.openxmlformats.org/drawingml/2006/main">
               <a:ext uri="{FF2B5EF4-FFF2-40B4-BE49-F238E27FC236}">
-                <a16:creationId xmlns:a16="http://schemas.microsoft.com/office/drawing/2014/main" id="{0FE6978C-F623-4362-B3D4-75B9DA9D940F}"/>
+                <a16:creationId xmlns:a16="http://schemas.microsoft.com/office/drawing/2014/main" id="{4466C7B3-136E-4986-9DCD-05779ABF78F8}"/>
               </a:ext>
             </a:extLst>
           </p:cNvPr>
@@ -9684,7 +9644,7 @@
           <p:cNvPr id="53" name="">
             <a:extLst xmlns:a="http://schemas.openxmlformats.org/drawingml/2006/main">
               <a:ext uri="{FF2B5EF4-FFF2-40B4-BE49-F238E27FC236}">
-                <a16:creationId xmlns:a16="http://schemas.microsoft.com/office/drawing/2014/main" id="{0BBD6574-F78E-4898-8712-B7552BC4BAE8}"/>
+                <a16:creationId xmlns:a16="http://schemas.microsoft.com/office/drawing/2014/main" id="{D8B85009-2BD7-4B14-B832-E60CC320217A}"/>
               </a:ext>
             </a:extLst>
           </p:cNvPr>
@@ -9714,7 +9674,7 @@
           <p:cNvPr id="54" name="">
             <a:extLst xmlns:a="http://schemas.openxmlformats.org/drawingml/2006/main">
               <a:ext uri="{FF2B5EF4-FFF2-40B4-BE49-F238E27FC236}">
-                <a16:creationId xmlns:a16="http://schemas.microsoft.com/office/drawing/2014/main" id="{E992B381-FF4E-45AA-BD67-4D440268F4BC}"/>
+                <a16:creationId xmlns:a16="http://schemas.microsoft.com/office/drawing/2014/main" id="{3E1AD127-9C2A-43E3-B027-E8404334BB97}"/>
               </a:ext>
             </a:extLst>
           </p:cNvPr>
@@ -9780,7 +9740,7 @@
           <p:cNvPr id="55" name="">
             <a:extLst xmlns:a="http://schemas.openxmlformats.org/drawingml/2006/main">
               <a:ext uri="{FF2B5EF4-FFF2-40B4-BE49-F238E27FC236}">
-                <a16:creationId xmlns:a16="http://schemas.microsoft.com/office/drawing/2014/main" id="{0A5965F8-54FA-41D1-B4AA-6A77857398AE}"/>
+                <a16:creationId xmlns:a16="http://schemas.microsoft.com/office/drawing/2014/main" id="{6DE2CB67-0691-4627-8375-1D095FFC30F2}"/>
               </a:ext>
             </a:extLst>
           </p:cNvPr>
@@ -9846,7 +9806,7 @@
           <p:cNvPr id="56" name="">
             <a:extLst xmlns:a="http://schemas.openxmlformats.org/drawingml/2006/main">
               <a:ext uri="{FF2B5EF4-FFF2-40B4-BE49-F238E27FC236}">
-                <a16:creationId xmlns:a16="http://schemas.microsoft.com/office/drawing/2014/main" id="{EE43091B-8A3E-428B-8039-EF9411B92550}"/>
+                <a16:creationId xmlns:a16="http://schemas.microsoft.com/office/drawing/2014/main" id="{262CFD9F-5842-479A-B66C-29D198BF3E02}"/>
               </a:ext>
             </a:extLst>
           </p:cNvPr>
@@ -9910,7 +9870,7 @@
     </p:spTree>
     <p:extLst>
       <p:ext uri="{BB962C8B-B14F-4D97-AF65-F5344CB8AC3E}">
-        <p14:creationId xmlns:p14="http://schemas.microsoft.com/office/powerpoint/2010/main" val="1555820126"/>
+        <p14:creationId xmlns:p14="http://schemas.microsoft.com/office/powerpoint/2010/main" val="1585431991"/>
       </p:ext>
     </p:extLst>
   </p:cSld>
@@ -9941,7 +9901,7 @@
           <p:cNvPr id="82" name="">
             <a:extLst xmlns:a="http://schemas.openxmlformats.org/drawingml/2006/main">
               <a:ext uri="{FF2B5EF4-FFF2-40B4-BE49-F238E27FC236}">
-                <a16:creationId xmlns:a16="http://schemas.microsoft.com/office/drawing/2014/main" id="{7EDF2601-FA69-44F2-99EC-5FB133B229F6}"/>
+                <a16:creationId xmlns:a16="http://schemas.microsoft.com/office/drawing/2014/main" id="{562CD8F9-6222-4F25-A4AD-5D087FD40E0F}"/>
               </a:ext>
             </a:extLst>
           </p:cNvPr>
@@ -10007,7 +9967,7 @@
           <p:cNvPr id="2" name="">
             <a:extLst xmlns:a="http://schemas.openxmlformats.org/drawingml/2006/main">
               <a:ext uri="{FF2B5EF4-FFF2-40B4-BE49-F238E27FC236}">
-                <a16:creationId xmlns:a16="http://schemas.microsoft.com/office/drawing/2014/main" id="{8B62AA53-4F96-45A2-89DD-2189393FC4E0}"/>
+                <a16:creationId xmlns:a16="http://schemas.microsoft.com/office/drawing/2014/main" id="{7A336AFC-0A08-4015-A578-5449ABFBE43A}"/>
               </a:ext>
             </a:extLst>
           </p:cNvPr>
@@ -10073,7 +10033,7 @@
           <p:cNvPr id="3" name="">
             <a:extLst xmlns:a="http://schemas.openxmlformats.org/drawingml/2006/main">
               <a:ext uri="{FF2B5EF4-FFF2-40B4-BE49-F238E27FC236}">
-                <a16:creationId xmlns:a16="http://schemas.microsoft.com/office/drawing/2014/main" id="{31FD97C1-0433-4A8B-87F8-D3843C0E3816}"/>
+                <a16:creationId xmlns:a16="http://schemas.microsoft.com/office/drawing/2014/main" id="{05957EE1-CC80-414E-A0F5-E55DE32B40DD}"/>
               </a:ext>
             </a:extLst>
           </p:cNvPr>
@@ -10139,7 +10099,7 @@
           <p:cNvPr id="4" name="">
             <a:extLst xmlns:a="http://schemas.openxmlformats.org/drawingml/2006/main">
               <a:ext uri="{FF2B5EF4-FFF2-40B4-BE49-F238E27FC236}">
-                <a16:creationId xmlns:a16="http://schemas.microsoft.com/office/drawing/2014/main" id="{5A3B71FB-D98B-4797-88B1-31F53DDCE95E}"/>
+                <a16:creationId xmlns:a16="http://schemas.microsoft.com/office/drawing/2014/main" id="{EBCE85F3-D591-4416-A29C-2A963F573630}"/>
               </a:ext>
             </a:extLst>
           </p:cNvPr>
@@ -10205,7 +10165,7 @@
           <p:cNvPr id="5" name="">
             <a:extLst xmlns:a="http://schemas.openxmlformats.org/drawingml/2006/main">
               <a:ext uri="{FF2B5EF4-FFF2-40B4-BE49-F238E27FC236}">
-                <a16:creationId xmlns:a16="http://schemas.microsoft.com/office/drawing/2014/main" id="{0E6BD7CE-C46A-42B3-9200-57BAFFBC5A5E}"/>
+                <a16:creationId xmlns:a16="http://schemas.microsoft.com/office/drawing/2014/main" id="{343716B4-B8C7-43CD-B073-1A1ADF0D0E4D}"/>
               </a:ext>
             </a:extLst>
           </p:cNvPr>
@@ -10271,7 +10231,7 @@
           <p:cNvPr id="6" name="">
             <a:extLst xmlns:a="http://schemas.openxmlformats.org/drawingml/2006/main">
               <a:ext uri="{FF2B5EF4-FFF2-40B4-BE49-F238E27FC236}">
-                <a16:creationId xmlns:a16="http://schemas.microsoft.com/office/drawing/2014/main" id="{52F12FC6-FA9E-4CEC-AB5A-BA9F585B21E1}"/>
+                <a16:creationId xmlns:a16="http://schemas.microsoft.com/office/drawing/2014/main" id="{40F03313-E4DE-45CB-A033-7312FFE3296F}"/>
               </a:ext>
             </a:extLst>
           </p:cNvPr>
@@ -10337,7 +10297,7 @@
           <p:cNvPr id="7" name="Chart">
             <a:extLst xmlns:a="http://schemas.openxmlformats.org/drawingml/2006/main">
               <a:ext uri="{FF2B5EF4-FFF2-40B4-BE49-F238E27FC236}">
-                <a16:creationId xmlns:a16="http://schemas.microsoft.com/office/drawing/2014/main" id="{5C0C5B2B-AAB3-48E8-ADA1-599227283C99}"/>
+                <a16:creationId xmlns:a16="http://schemas.microsoft.com/office/drawing/2014/main" id="{3921AB6A-46E0-4E56-AF93-97185BE3E868}"/>
               </a:ext>
             </a:extLst>
           </p:cNvPr>
@@ -10350,7 +10310,7 @@
         </p:xfrm>
         <a:graphic xmlns:a="http://schemas.openxmlformats.org/drawingml/2006/main">
           <a:graphicData uri="http://schemas.openxmlformats.org/drawingml/2006/chart">
-            <c:chart xmlns:r="http://schemas.openxmlformats.org/officeDocument/2006/relationships" xmlns:c="http://schemas.openxmlformats.org/drawingml/2006/chart" r:id="R0a17033057e84aa9"/>
+            <c:chart xmlns:r="http://schemas.openxmlformats.org/officeDocument/2006/relationships" xmlns:c="http://schemas.openxmlformats.org/drawingml/2006/chart" r:id="Rb9a42f57ca1f4ea2"/>
           </a:graphicData>
         </a:graphic>
       </p:graphicFrame>
@@ -10359,7 +10319,7 @@
           <p:cNvPr id="8" name="">
             <a:extLst xmlns:a="http://schemas.openxmlformats.org/drawingml/2006/main">
               <a:ext uri="{FF2B5EF4-FFF2-40B4-BE49-F238E27FC236}">
-                <a16:creationId xmlns:a16="http://schemas.microsoft.com/office/drawing/2014/main" id="{57584224-76E9-4732-AC82-BE1865EB9332}"/>
+                <a16:creationId xmlns:a16="http://schemas.microsoft.com/office/drawing/2014/main" id="{18AEF622-7E9A-4552-8FF2-1098011F74DD}"/>
               </a:ext>
             </a:extLst>
           </p:cNvPr>
@@ -10425,7 +10385,7 @@
           <p:cNvPr id="9" name="">
             <a:extLst xmlns:a="http://schemas.openxmlformats.org/drawingml/2006/main">
               <a:ext uri="{FF2B5EF4-FFF2-40B4-BE49-F238E27FC236}">
-                <a16:creationId xmlns:a16="http://schemas.microsoft.com/office/drawing/2014/main" id="{9440F6C7-9D16-47F1-8EFD-32C77188FAB3}"/>
+                <a16:creationId xmlns:a16="http://schemas.microsoft.com/office/drawing/2014/main" id="{645091D8-8A47-4BA6-9826-99C0B9E91575}"/>
               </a:ext>
             </a:extLst>
           </p:cNvPr>
@@ -10491,7 +10451,7 @@
           <p:cNvPr id="10" name="">
             <a:extLst xmlns:a="http://schemas.openxmlformats.org/drawingml/2006/main">
               <a:ext uri="{FF2B5EF4-FFF2-40B4-BE49-F238E27FC236}">
-                <a16:creationId xmlns:a16="http://schemas.microsoft.com/office/drawing/2014/main" id="{802F07A3-24F5-4171-8A7F-979EA5FCCECC}"/>
+                <a16:creationId xmlns:a16="http://schemas.microsoft.com/office/drawing/2014/main" id="{68F6D6BF-5FDA-4ACB-BAAE-D11A9E38790B}"/>
               </a:ext>
             </a:extLst>
           </p:cNvPr>
@@ -10557,7 +10517,7 @@
           <p:cNvPr id="11" name="">
             <a:extLst xmlns:a="http://schemas.openxmlformats.org/drawingml/2006/main">
               <a:ext uri="{FF2B5EF4-FFF2-40B4-BE49-F238E27FC236}">
-                <a16:creationId xmlns:a16="http://schemas.microsoft.com/office/drawing/2014/main" id="{06913981-EC0A-46E8-B937-6E7E8F994396}"/>
+                <a16:creationId xmlns:a16="http://schemas.microsoft.com/office/drawing/2014/main" id="{9BEF81A9-78C7-4349-94BD-1B038FAABE4B}"/>
               </a:ext>
             </a:extLst>
           </p:cNvPr>
@@ -10623,7 +10583,7 @@
           <p:cNvPr id="12" name="">
             <a:extLst xmlns:a="http://schemas.openxmlformats.org/drawingml/2006/main">
               <a:ext uri="{FF2B5EF4-FFF2-40B4-BE49-F238E27FC236}">
-                <a16:creationId xmlns:a16="http://schemas.microsoft.com/office/drawing/2014/main" id="{DF4D6977-2A4F-4A57-A129-51F341890ECF}"/>
+                <a16:creationId xmlns:a16="http://schemas.microsoft.com/office/drawing/2014/main" id="{B5D11A46-3B0F-4317-A31F-0EC8CA639E81}"/>
               </a:ext>
             </a:extLst>
           </p:cNvPr>
@@ -10689,7 +10649,7 @@
           <p:cNvPr id="13" name="">
             <a:extLst xmlns:a="http://schemas.openxmlformats.org/drawingml/2006/main">
               <a:ext uri="{FF2B5EF4-FFF2-40B4-BE49-F238E27FC236}">
-                <a16:creationId xmlns:a16="http://schemas.microsoft.com/office/drawing/2014/main" id="{4BE1D246-D3A7-4700-89B0-A0F201D0773E}"/>
+                <a16:creationId xmlns:a16="http://schemas.microsoft.com/office/drawing/2014/main" id="{39FB0559-F7CF-45DE-B997-7E82D8A5B3BA}"/>
               </a:ext>
             </a:extLst>
           </p:cNvPr>
@@ -10755,7 +10715,7 @@
           <p:cNvPr id="14" name="">
             <a:extLst xmlns:a="http://schemas.openxmlformats.org/drawingml/2006/main">
               <a:ext uri="{FF2B5EF4-FFF2-40B4-BE49-F238E27FC236}">
-                <a16:creationId xmlns:a16="http://schemas.microsoft.com/office/drawing/2014/main" id="{A2CC5A22-AA7A-4498-9DEC-9B6644B8E8FB}"/>
+                <a16:creationId xmlns:a16="http://schemas.microsoft.com/office/drawing/2014/main" id="{EA0611DD-23F6-48D7-9B2D-2DB5E4EB9DF3}"/>
               </a:ext>
             </a:extLst>
           </p:cNvPr>
@@ -10785,7 +10745,7 @@
           <p:cNvPr id="15" name="">
             <a:extLst xmlns:a="http://schemas.openxmlformats.org/drawingml/2006/main">
               <a:ext uri="{FF2B5EF4-FFF2-40B4-BE49-F238E27FC236}">
-                <a16:creationId xmlns:a16="http://schemas.microsoft.com/office/drawing/2014/main" id="{BA7853E1-8A80-41BD-97BC-88556FA4E405}"/>
+                <a16:creationId xmlns:a16="http://schemas.microsoft.com/office/drawing/2014/main" id="{2BB127E2-B8D5-4CC2-9845-B16156905DD6}"/>
               </a:ext>
             </a:extLst>
           </p:cNvPr>
@@ -10851,7 +10811,7 @@
           <p:cNvPr id="16" name="">
             <a:extLst xmlns:a="http://schemas.openxmlformats.org/drawingml/2006/main">
               <a:ext uri="{FF2B5EF4-FFF2-40B4-BE49-F238E27FC236}">
-                <a16:creationId xmlns:a16="http://schemas.microsoft.com/office/drawing/2014/main" id="{8B8E780E-7B42-49BE-8946-A976DEECCA6E}"/>
+                <a16:creationId xmlns:a16="http://schemas.microsoft.com/office/drawing/2014/main" id="{C29D37CC-D8D5-4AA8-AD35-A99223E937EF}"/>
               </a:ext>
             </a:extLst>
           </p:cNvPr>
@@ -10881,7 +10841,7 @@
           <p:cNvPr id="17" name="">
             <a:extLst xmlns:a="http://schemas.openxmlformats.org/drawingml/2006/main">
               <a:ext uri="{FF2B5EF4-FFF2-40B4-BE49-F238E27FC236}">
-                <a16:creationId xmlns:a16="http://schemas.microsoft.com/office/drawing/2014/main" id="{0A9551AB-3E7D-43A8-A0A0-D0544DDA4AFB}"/>
+                <a16:creationId xmlns:a16="http://schemas.microsoft.com/office/drawing/2014/main" id="{54BADEC0-7ADB-45FB-95F8-7E43A106AF32}"/>
               </a:ext>
             </a:extLst>
           </p:cNvPr>
@@ -10947,7 +10907,7 @@
           <p:cNvPr id="18" name="">
             <a:extLst xmlns:a="http://schemas.openxmlformats.org/drawingml/2006/main">
               <a:ext uri="{FF2B5EF4-FFF2-40B4-BE49-F238E27FC236}">
-                <a16:creationId xmlns:a16="http://schemas.microsoft.com/office/drawing/2014/main" id="{4EC69D30-57E2-45B4-BE6B-C6B594002EDA}"/>
+                <a16:creationId xmlns:a16="http://schemas.microsoft.com/office/drawing/2014/main" id="{A14CF107-65EC-492B-9299-B49E3EA25526}"/>
               </a:ext>
             </a:extLst>
           </p:cNvPr>
@@ -10977,7 +10937,7 @@
           <p:cNvPr id="19" name="">
             <a:extLst xmlns:a="http://schemas.openxmlformats.org/drawingml/2006/main">
               <a:ext uri="{FF2B5EF4-FFF2-40B4-BE49-F238E27FC236}">
-                <a16:creationId xmlns:a16="http://schemas.microsoft.com/office/drawing/2014/main" id="{D91C17CB-EC84-41D3-B0BA-1DB319244EAA}"/>
+                <a16:creationId xmlns:a16="http://schemas.microsoft.com/office/drawing/2014/main" id="{5F247480-2556-4F45-BC44-8800A6B05D9F}"/>
               </a:ext>
             </a:extLst>
           </p:cNvPr>
@@ -11043,7 +11003,7 @@
           <p:cNvPr id="20" name="">
             <a:extLst xmlns:a="http://schemas.openxmlformats.org/drawingml/2006/main">
               <a:ext uri="{FF2B5EF4-FFF2-40B4-BE49-F238E27FC236}">
-                <a16:creationId xmlns:a16="http://schemas.microsoft.com/office/drawing/2014/main" id="{BB8D685E-3E95-4239-9409-C1708808D815}"/>
+                <a16:creationId xmlns:a16="http://schemas.microsoft.com/office/drawing/2014/main" id="{301F49C4-7ECF-47B4-A9AF-ED89B3E8F6C3}"/>
               </a:ext>
             </a:extLst>
           </p:cNvPr>
@@ -11073,7 +11033,7 @@
           <p:cNvPr id="21" name="">
             <a:extLst xmlns:a="http://schemas.openxmlformats.org/drawingml/2006/main">
               <a:ext uri="{FF2B5EF4-FFF2-40B4-BE49-F238E27FC236}">
-                <a16:creationId xmlns:a16="http://schemas.microsoft.com/office/drawing/2014/main" id="{D6A282A1-F6FF-473C-B0EB-31C191542814}"/>
+                <a16:creationId xmlns:a16="http://schemas.microsoft.com/office/drawing/2014/main" id="{AFBBFF86-3C00-466A-9FB3-D485BEB2634C}"/>
               </a:ext>
             </a:extLst>
           </p:cNvPr>
@@ -11139,7 +11099,7 @@
           <p:cNvPr id="22" name="">
             <a:extLst xmlns:a="http://schemas.openxmlformats.org/drawingml/2006/main">
               <a:ext uri="{FF2B5EF4-FFF2-40B4-BE49-F238E27FC236}">
-                <a16:creationId xmlns:a16="http://schemas.microsoft.com/office/drawing/2014/main" id="{E9412BF9-E10C-449A-A23B-82EAFD57041E}"/>
+                <a16:creationId xmlns:a16="http://schemas.microsoft.com/office/drawing/2014/main" id="{4E62A749-40E9-472D-A940-919D81530382}"/>
               </a:ext>
             </a:extLst>
           </p:cNvPr>
@@ -11169,7 +11129,7 @@
           <p:cNvPr id="23" name="">
             <a:extLst xmlns:a="http://schemas.openxmlformats.org/drawingml/2006/main">
               <a:ext uri="{FF2B5EF4-FFF2-40B4-BE49-F238E27FC236}">
-                <a16:creationId xmlns:a16="http://schemas.microsoft.com/office/drawing/2014/main" id="{0FC85F6C-F67B-4C89-81C5-6A937D34E86A}"/>
+                <a16:creationId xmlns:a16="http://schemas.microsoft.com/office/drawing/2014/main" id="{0143E479-F5BE-4A79-8784-F052E029122B}"/>
               </a:ext>
             </a:extLst>
           </p:cNvPr>
@@ -11235,7 +11195,7 @@
           <p:cNvPr id="24" name="">
             <a:extLst xmlns:a="http://schemas.openxmlformats.org/drawingml/2006/main">
               <a:ext uri="{FF2B5EF4-FFF2-40B4-BE49-F238E27FC236}">
-                <a16:creationId xmlns:a16="http://schemas.microsoft.com/office/drawing/2014/main" id="{A0AF2D3D-0388-4CA3-994D-A6239BFF3423}"/>
+                <a16:creationId xmlns:a16="http://schemas.microsoft.com/office/drawing/2014/main" id="{73C99975-9C2E-4210-8018-DDA0AF14C8B0}"/>
               </a:ext>
             </a:extLst>
           </p:cNvPr>
@@ -11301,7 +11261,7 @@
           <p:cNvPr id="25" name="">
             <a:extLst xmlns:a="http://schemas.openxmlformats.org/drawingml/2006/main">
               <a:ext uri="{FF2B5EF4-FFF2-40B4-BE49-F238E27FC236}">
-                <a16:creationId xmlns:a16="http://schemas.microsoft.com/office/drawing/2014/main" id="{D5CFAC6D-47E5-427E-8006-85D4EBB4F0EB}"/>
+                <a16:creationId xmlns:a16="http://schemas.microsoft.com/office/drawing/2014/main" id="{8753C386-ECEE-4E44-A18E-7A832E759168}"/>
               </a:ext>
             </a:extLst>
           </p:cNvPr>
@@ -11331,7 +11291,7 @@
           <p:cNvPr id="26" name="">
             <a:extLst xmlns:a="http://schemas.openxmlformats.org/drawingml/2006/main">
               <a:ext uri="{FF2B5EF4-FFF2-40B4-BE49-F238E27FC236}">
-                <a16:creationId xmlns:a16="http://schemas.microsoft.com/office/drawing/2014/main" id="{28207F02-2689-4DB3-93B1-F35EFEB819C8}"/>
+                <a16:creationId xmlns:a16="http://schemas.microsoft.com/office/drawing/2014/main" id="{BDD1C9D1-5DC4-4AA8-901E-A2C2C75173CB}"/>
               </a:ext>
             </a:extLst>
           </p:cNvPr>
@@ -11397,7 +11357,7 @@
           <p:cNvPr id="27" name="">
             <a:extLst xmlns:a="http://schemas.openxmlformats.org/drawingml/2006/main">
               <a:ext uri="{FF2B5EF4-FFF2-40B4-BE49-F238E27FC236}">
-                <a16:creationId xmlns:a16="http://schemas.microsoft.com/office/drawing/2014/main" id="{69FFA96B-A7B4-497D-BFF5-7215EBE01169}"/>
+                <a16:creationId xmlns:a16="http://schemas.microsoft.com/office/drawing/2014/main" id="{C232728A-BBD6-4F92-A070-A08F0F33A883}"/>
               </a:ext>
             </a:extLst>
           </p:cNvPr>
@@ -11427,7 +11387,7 @@
           <p:cNvPr id="28" name="">
             <a:extLst xmlns:a="http://schemas.openxmlformats.org/drawingml/2006/main">
               <a:ext uri="{FF2B5EF4-FFF2-40B4-BE49-F238E27FC236}">
-                <a16:creationId xmlns:a16="http://schemas.microsoft.com/office/drawing/2014/main" id="{E48ED022-548A-40F2-AB81-C491AED93650}"/>
+                <a16:creationId xmlns:a16="http://schemas.microsoft.com/office/drawing/2014/main" id="{57A64674-7CF9-4FF3-9310-5BE361D28A21}"/>
               </a:ext>
             </a:extLst>
           </p:cNvPr>
@@ -11493,7 +11453,7 @@
           <p:cNvPr id="29" name="">
             <a:extLst xmlns:a="http://schemas.openxmlformats.org/drawingml/2006/main">
               <a:ext uri="{FF2B5EF4-FFF2-40B4-BE49-F238E27FC236}">
-                <a16:creationId xmlns:a16="http://schemas.microsoft.com/office/drawing/2014/main" id="{5E2DA56B-4816-49E5-9C13-6D43BC20087C}"/>
+                <a16:creationId xmlns:a16="http://schemas.microsoft.com/office/drawing/2014/main" id="{13DB596B-9AB2-46B0-8051-64B779E148FE}"/>
               </a:ext>
             </a:extLst>
           </p:cNvPr>
@@ -11523,7 +11483,7 @@
           <p:cNvPr id="30" name="">
             <a:extLst xmlns:a="http://schemas.openxmlformats.org/drawingml/2006/main">
               <a:ext uri="{FF2B5EF4-FFF2-40B4-BE49-F238E27FC236}">
-                <a16:creationId xmlns:a16="http://schemas.microsoft.com/office/drawing/2014/main" id="{7C4EBEE9-666A-4F40-BC59-E2870FA70A2B}"/>
+                <a16:creationId xmlns:a16="http://schemas.microsoft.com/office/drawing/2014/main" id="{48D51FF4-AFA2-4E52-9CF3-3FA1D64BD56A}"/>
               </a:ext>
             </a:extLst>
           </p:cNvPr>
@@ -11589,7 +11549,7 @@
           <p:cNvPr id="31" name="">
             <a:extLst xmlns:a="http://schemas.openxmlformats.org/drawingml/2006/main">
               <a:ext uri="{FF2B5EF4-FFF2-40B4-BE49-F238E27FC236}">
-                <a16:creationId xmlns:a16="http://schemas.microsoft.com/office/drawing/2014/main" id="{339B26D9-19A3-41CD-83EB-F94BBE26AB8D}"/>
+                <a16:creationId xmlns:a16="http://schemas.microsoft.com/office/drawing/2014/main" id="{E47AD1AD-7041-49A7-85A1-4687D96AF1CB}"/>
               </a:ext>
             </a:extLst>
           </p:cNvPr>
@@ -11619,7 +11579,7 @@
           <p:cNvPr id="32" name="">
             <a:extLst xmlns:a="http://schemas.openxmlformats.org/drawingml/2006/main">
               <a:ext uri="{FF2B5EF4-FFF2-40B4-BE49-F238E27FC236}">
-                <a16:creationId xmlns:a16="http://schemas.microsoft.com/office/drawing/2014/main" id="{294094C5-3E8F-42E4-A8A1-6BC67AFFC0A9}"/>
+                <a16:creationId xmlns:a16="http://schemas.microsoft.com/office/drawing/2014/main" id="{F1FB9D88-7DAE-4589-9CB9-BA7FA23C914B}"/>
               </a:ext>
             </a:extLst>
           </p:cNvPr>
@@ -11685,7 +11645,7 @@
           <p:cNvPr id="33" name="">
             <a:extLst xmlns:a="http://schemas.openxmlformats.org/drawingml/2006/main">
               <a:ext uri="{FF2B5EF4-FFF2-40B4-BE49-F238E27FC236}">
-                <a16:creationId xmlns:a16="http://schemas.microsoft.com/office/drawing/2014/main" id="{1E8E0306-2792-4B13-A78E-137709A78964}"/>
+                <a16:creationId xmlns:a16="http://schemas.microsoft.com/office/drawing/2014/main" id="{E51B8241-342B-4A9A-BA08-66F97D3FBD1B}"/>
               </a:ext>
             </a:extLst>
           </p:cNvPr>
@@ -11715,7 +11675,7 @@
           <p:cNvPr id="34" name="">
             <a:extLst xmlns:a="http://schemas.openxmlformats.org/drawingml/2006/main">
               <a:ext uri="{FF2B5EF4-FFF2-40B4-BE49-F238E27FC236}">
-                <a16:creationId xmlns:a16="http://schemas.microsoft.com/office/drawing/2014/main" id="{DAEA3079-80AF-416D-A104-9D40049DB9FD}"/>
+                <a16:creationId xmlns:a16="http://schemas.microsoft.com/office/drawing/2014/main" id="{D7D0B41A-1887-4A42-BE84-3B0ACDFDE722}"/>
               </a:ext>
             </a:extLst>
           </p:cNvPr>
@@ -11781,7 +11741,7 @@
           <p:cNvPr id="35" name="">
             <a:extLst xmlns:a="http://schemas.openxmlformats.org/drawingml/2006/main">
               <a:ext uri="{FF2B5EF4-FFF2-40B4-BE49-F238E27FC236}">
-                <a16:creationId xmlns:a16="http://schemas.microsoft.com/office/drawing/2014/main" id="{EE4E1513-FD81-47DE-AB52-9C902FD371A0}"/>
+                <a16:creationId xmlns:a16="http://schemas.microsoft.com/office/drawing/2014/main" id="{7B410B71-8F15-4A93-A600-53D741A770D6}"/>
               </a:ext>
             </a:extLst>
           </p:cNvPr>
@@ -11847,7 +11807,7 @@
           <p:cNvPr id="36" name="">
             <a:extLst xmlns:a="http://schemas.openxmlformats.org/drawingml/2006/main">
               <a:ext uri="{FF2B5EF4-FFF2-40B4-BE49-F238E27FC236}">
-                <a16:creationId xmlns:a16="http://schemas.microsoft.com/office/drawing/2014/main" id="{8D5F424C-7B05-474E-B18B-0E1734C36384}"/>
+                <a16:creationId xmlns:a16="http://schemas.microsoft.com/office/drawing/2014/main" id="{1ECF2A65-A788-4033-9D09-E1226C39FAD3}"/>
               </a:ext>
             </a:extLst>
           </p:cNvPr>
@@ -11877,7 +11837,7 @@
           <p:cNvPr id="37" name="">
             <a:extLst xmlns:a="http://schemas.openxmlformats.org/drawingml/2006/main">
               <a:ext uri="{FF2B5EF4-FFF2-40B4-BE49-F238E27FC236}">
-                <a16:creationId xmlns:a16="http://schemas.microsoft.com/office/drawing/2014/main" id="{E1229318-4B0C-4001-B5F0-3E2960772064}"/>
+                <a16:creationId xmlns:a16="http://schemas.microsoft.com/office/drawing/2014/main" id="{6CDF9BD5-E330-462B-A26E-B2AD39AD4C28}"/>
               </a:ext>
             </a:extLst>
           </p:cNvPr>
@@ -11943,7 +11903,7 @@
           <p:cNvPr id="38" name="">
             <a:extLst xmlns:a="http://schemas.openxmlformats.org/drawingml/2006/main">
               <a:ext uri="{FF2B5EF4-FFF2-40B4-BE49-F238E27FC236}">
-                <a16:creationId xmlns:a16="http://schemas.microsoft.com/office/drawing/2014/main" id="{E4CA16F2-05A1-42A6-825E-75CE8C41C4CA}"/>
+                <a16:creationId xmlns:a16="http://schemas.microsoft.com/office/drawing/2014/main" id="{B0DF27C2-42DC-41F8-A0EA-D3A526AD7A9F}"/>
               </a:ext>
             </a:extLst>
           </p:cNvPr>
@@ -11973,7 +11933,7 @@
           <p:cNvPr id="39" name="">
             <a:extLst xmlns:a="http://schemas.openxmlformats.org/drawingml/2006/main">
               <a:ext uri="{FF2B5EF4-FFF2-40B4-BE49-F238E27FC236}">
-                <a16:creationId xmlns:a16="http://schemas.microsoft.com/office/drawing/2014/main" id="{6228AEFD-645F-497C-B922-B3303C8ADFD7}"/>
+                <a16:creationId xmlns:a16="http://schemas.microsoft.com/office/drawing/2014/main" id="{CB0916A2-7E1E-4F7F-816D-74E1E60EE294}"/>
               </a:ext>
             </a:extLst>
           </p:cNvPr>
@@ -12039,7 +11999,7 @@
           <p:cNvPr id="40" name="">
             <a:extLst xmlns:a="http://schemas.openxmlformats.org/drawingml/2006/main">
               <a:ext uri="{FF2B5EF4-FFF2-40B4-BE49-F238E27FC236}">
-                <a16:creationId xmlns:a16="http://schemas.microsoft.com/office/drawing/2014/main" id="{E40B8236-DCA0-41C8-BB8F-543936CF6BF4}"/>
+                <a16:creationId xmlns:a16="http://schemas.microsoft.com/office/drawing/2014/main" id="{08849585-BA68-4EE9-9BFA-29A4EEE51B74}"/>
               </a:ext>
             </a:extLst>
           </p:cNvPr>
@@ -12069,7 +12029,7 @@
           <p:cNvPr id="41" name="">
             <a:extLst xmlns:a="http://schemas.openxmlformats.org/drawingml/2006/main">
               <a:ext uri="{FF2B5EF4-FFF2-40B4-BE49-F238E27FC236}">
-                <a16:creationId xmlns:a16="http://schemas.microsoft.com/office/drawing/2014/main" id="{5740EE23-B150-4EC0-93D2-40A4840797DD}"/>
+                <a16:creationId xmlns:a16="http://schemas.microsoft.com/office/drawing/2014/main" id="{F59A33F2-643F-403C-9338-9B6B243EA04D}"/>
               </a:ext>
             </a:extLst>
           </p:cNvPr>
@@ -12135,7 +12095,7 @@
           <p:cNvPr id="42" name="">
             <a:extLst xmlns:a="http://schemas.openxmlformats.org/drawingml/2006/main">
               <a:ext uri="{FF2B5EF4-FFF2-40B4-BE49-F238E27FC236}">
-                <a16:creationId xmlns:a16="http://schemas.microsoft.com/office/drawing/2014/main" id="{FC700F90-9464-4F33-B779-EF6234E17C58}"/>
+                <a16:creationId xmlns:a16="http://schemas.microsoft.com/office/drawing/2014/main" id="{EDE4105A-D4ED-40FC-BFB0-0E49C24F6F8B}"/>
               </a:ext>
             </a:extLst>
           </p:cNvPr>
@@ -12165,7 +12125,7 @@
           <p:cNvPr id="43" name="">
             <a:extLst xmlns:a="http://schemas.openxmlformats.org/drawingml/2006/main">
               <a:ext uri="{FF2B5EF4-FFF2-40B4-BE49-F238E27FC236}">
-                <a16:creationId xmlns:a16="http://schemas.microsoft.com/office/drawing/2014/main" id="{5C0FE8CA-E196-4BE9-8147-4DDB8A3256DE}"/>
+                <a16:creationId xmlns:a16="http://schemas.microsoft.com/office/drawing/2014/main" id="{661B0C60-BC56-41BB-AD83-AE3B7BD91BCC}"/>
               </a:ext>
             </a:extLst>
           </p:cNvPr>
@@ -12231,7 +12191,7 @@
           <p:cNvPr id="44" name="">
             <a:extLst xmlns:a="http://schemas.openxmlformats.org/drawingml/2006/main">
               <a:ext uri="{FF2B5EF4-FFF2-40B4-BE49-F238E27FC236}">
-                <a16:creationId xmlns:a16="http://schemas.microsoft.com/office/drawing/2014/main" id="{3EAC169F-4A3C-4270-B113-F65764BA3D08}"/>
+                <a16:creationId xmlns:a16="http://schemas.microsoft.com/office/drawing/2014/main" id="{224E2273-AE99-4B01-BE78-411A1DE9DC7D}"/>
               </a:ext>
             </a:extLst>
           </p:cNvPr>
@@ -12261,7 +12221,7 @@
           <p:cNvPr id="45" name="">
             <a:extLst xmlns:a="http://schemas.openxmlformats.org/drawingml/2006/main">
               <a:ext uri="{FF2B5EF4-FFF2-40B4-BE49-F238E27FC236}">
-                <a16:creationId xmlns:a16="http://schemas.microsoft.com/office/drawing/2014/main" id="{AB09A6E5-D64A-4CD6-AE4E-227CB88D1059}"/>
+                <a16:creationId xmlns:a16="http://schemas.microsoft.com/office/drawing/2014/main" id="{C4940E98-FC8A-4ACA-8630-C319AB4FA7C2}"/>
               </a:ext>
             </a:extLst>
           </p:cNvPr>
@@ -12327,7 +12287,7 @@
           <p:cNvPr id="46" name="">
             <a:extLst xmlns:a="http://schemas.openxmlformats.org/drawingml/2006/main">
               <a:ext uri="{FF2B5EF4-FFF2-40B4-BE49-F238E27FC236}">
-                <a16:creationId xmlns:a16="http://schemas.microsoft.com/office/drawing/2014/main" id="{1DBCB7A1-0FA9-49B2-88E2-C5198B63CC34}"/>
+                <a16:creationId xmlns:a16="http://schemas.microsoft.com/office/drawing/2014/main" id="{96185BE3-2694-41CA-BD37-A0D8EA53ECAC}"/>
               </a:ext>
             </a:extLst>
           </p:cNvPr>
@@ -12393,7 +12353,7 @@
           <p:cNvPr id="47" name="">
             <a:extLst xmlns:a="http://schemas.openxmlformats.org/drawingml/2006/main">
               <a:ext uri="{FF2B5EF4-FFF2-40B4-BE49-F238E27FC236}">
-                <a16:creationId xmlns:a16="http://schemas.microsoft.com/office/drawing/2014/main" id="{0F67D43A-D7BC-48DA-9B25-0A1AC187B7E7}"/>
+                <a16:creationId xmlns:a16="http://schemas.microsoft.com/office/drawing/2014/main" id="{F3A251FE-773A-459A-BDF5-BC21ED7A6984}"/>
               </a:ext>
             </a:extLst>
           </p:cNvPr>
@@ -12423,7 +12383,7 @@
           <p:cNvPr id="48" name="">
             <a:extLst xmlns:a="http://schemas.openxmlformats.org/drawingml/2006/main">
               <a:ext uri="{FF2B5EF4-FFF2-40B4-BE49-F238E27FC236}">
-                <a16:creationId xmlns:a16="http://schemas.microsoft.com/office/drawing/2014/main" id="{D15302D0-5388-4D6F-B417-E1A05BD1EF87}"/>
+                <a16:creationId xmlns:a16="http://schemas.microsoft.com/office/drawing/2014/main" id="{0D21F386-F386-4586-8D61-37D0BA200193}"/>
               </a:ext>
             </a:extLst>
           </p:cNvPr>
@@ -12489,7 +12449,7 @@
           <p:cNvPr id="49" name="">
             <a:extLst xmlns:a="http://schemas.openxmlformats.org/drawingml/2006/main">
               <a:ext uri="{FF2B5EF4-FFF2-40B4-BE49-F238E27FC236}">
-                <a16:creationId xmlns:a16="http://schemas.microsoft.com/office/drawing/2014/main" id="{F862ACFC-BBD1-49DB-B8F2-C98BF643AEC1}"/>
+                <a16:creationId xmlns:a16="http://schemas.microsoft.com/office/drawing/2014/main" id="{B219A19A-BE99-4254-BD1E-3C70FDD41669}"/>
               </a:ext>
             </a:extLst>
           </p:cNvPr>
@@ -12519,7 +12479,7 @@
           <p:cNvPr id="50" name="">
             <a:extLst xmlns:a="http://schemas.openxmlformats.org/drawingml/2006/main">
               <a:ext uri="{FF2B5EF4-FFF2-40B4-BE49-F238E27FC236}">
-                <a16:creationId xmlns:a16="http://schemas.microsoft.com/office/drawing/2014/main" id="{6E2D87B7-5E1E-4DBA-9776-10917C933CE9}"/>
+                <a16:creationId xmlns:a16="http://schemas.microsoft.com/office/drawing/2014/main" id="{22B760E2-2FF4-4F96-91B1-536B04CA1406}"/>
               </a:ext>
             </a:extLst>
           </p:cNvPr>
@@ -12585,7 +12545,7 @@
           <p:cNvPr id="51" name="">
             <a:extLst xmlns:a="http://schemas.openxmlformats.org/drawingml/2006/main">
               <a:ext uri="{FF2B5EF4-FFF2-40B4-BE49-F238E27FC236}">
-                <a16:creationId xmlns:a16="http://schemas.microsoft.com/office/drawing/2014/main" id="{291D7042-2D27-453B-84CF-028A3EFB5A12}"/>
+                <a16:creationId xmlns:a16="http://schemas.microsoft.com/office/drawing/2014/main" id="{48BCF7B0-68F9-4518-96F9-8651F78FFF94}"/>
               </a:ext>
             </a:extLst>
           </p:cNvPr>
@@ -12615,7 +12575,7 @@
           <p:cNvPr id="52" name="">
             <a:extLst xmlns:a="http://schemas.openxmlformats.org/drawingml/2006/main">
               <a:ext uri="{FF2B5EF4-FFF2-40B4-BE49-F238E27FC236}">
-                <a16:creationId xmlns:a16="http://schemas.microsoft.com/office/drawing/2014/main" id="{BE88C9A2-2487-4CB3-AC7A-130A77483C78}"/>
+                <a16:creationId xmlns:a16="http://schemas.microsoft.com/office/drawing/2014/main" id="{E66A8FB4-A1DC-4C4A-854F-79A13DE9EBAD}"/>
               </a:ext>
             </a:extLst>
           </p:cNvPr>
@@ -12681,7 +12641,7 @@
           <p:cNvPr id="53" name="">
             <a:extLst xmlns:a="http://schemas.openxmlformats.org/drawingml/2006/main">
               <a:ext uri="{FF2B5EF4-FFF2-40B4-BE49-F238E27FC236}">
-                <a16:creationId xmlns:a16="http://schemas.microsoft.com/office/drawing/2014/main" id="{C1E090B8-E80D-49AA-A974-48F89DF0D641}"/>
+                <a16:creationId xmlns:a16="http://schemas.microsoft.com/office/drawing/2014/main" id="{50A6B889-4D44-47AE-8839-FA72463B5A2E}"/>
               </a:ext>
             </a:extLst>
           </p:cNvPr>
@@ -12711,7 +12671,7 @@
           <p:cNvPr id="54" name="">
             <a:extLst xmlns:a="http://schemas.openxmlformats.org/drawingml/2006/main">
               <a:ext uri="{FF2B5EF4-FFF2-40B4-BE49-F238E27FC236}">
-                <a16:creationId xmlns:a16="http://schemas.microsoft.com/office/drawing/2014/main" id="{CE2F67A2-3B01-4CE1-A746-F816F4B0CFED}"/>
+                <a16:creationId xmlns:a16="http://schemas.microsoft.com/office/drawing/2014/main" id="{DEB6BCF5-4028-4538-8970-89D219AACE56}"/>
               </a:ext>
             </a:extLst>
           </p:cNvPr>
@@ -12777,7 +12737,7 @@
           <p:cNvPr id="55" name="">
             <a:extLst xmlns:a="http://schemas.openxmlformats.org/drawingml/2006/main">
               <a:ext uri="{FF2B5EF4-FFF2-40B4-BE49-F238E27FC236}">
-                <a16:creationId xmlns:a16="http://schemas.microsoft.com/office/drawing/2014/main" id="{BE838A58-3FD5-4AE2-AA73-C0EEECE56D8C}"/>
+                <a16:creationId xmlns:a16="http://schemas.microsoft.com/office/drawing/2014/main" id="{5CFEDB54-9919-4CB9-8660-EAC682E6193A}"/>
               </a:ext>
             </a:extLst>
           </p:cNvPr>
@@ -12807,7 +12767,7 @@
           <p:cNvPr id="56" name="">
             <a:extLst xmlns:a="http://schemas.openxmlformats.org/drawingml/2006/main">
               <a:ext uri="{FF2B5EF4-FFF2-40B4-BE49-F238E27FC236}">
-                <a16:creationId xmlns:a16="http://schemas.microsoft.com/office/drawing/2014/main" id="{E77A1272-7AE8-4E6B-8673-C4A775E603FE}"/>
+                <a16:creationId xmlns:a16="http://schemas.microsoft.com/office/drawing/2014/main" id="{75DC37A5-D3B7-4396-A617-5266FF466232}"/>
               </a:ext>
             </a:extLst>
           </p:cNvPr>
@@ -12873,7 +12833,7 @@
           <p:cNvPr id="57" name="">
             <a:extLst xmlns:a="http://schemas.openxmlformats.org/drawingml/2006/main">
               <a:ext uri="{FF2B5EF4-FFF2-40B4-BE49-F238E27FC236}">
-                <a16:creationId xmlns:a16="http://schemas.microsoft.com/office/drawing/2014/main" id="{70A480B1-9FF9-4261-A351-5D4B7178732D}"/>
+                <a16:creationId xmlns:a16="http://schemas.microsoft.com/office/drawing/2014/main" id="{70CB87AD-B6E9-4C79-A434-AA4D190BB500}"/>
               </a:ext>
             </a:extLst>
           </p:cNvPr>
@@ -12939,7 +12899,7 @@
           <p:cNvPr id="58" name="">
             <a:extLst xmlns:a="http://schemas.openxmlformats.org/drawingml/2006/main">
               <a:ext uri="{FF2B5EF4-FFF2-40B4-BE49-F238E27FC236}">
-                <a16:creationId xmlns:a16="http://schemas.microsoft.com/office/drawing/2014/main" id="{69BD5527-7C80-4C88-B5F0-79045FCC322E}"/>
+                <a16:creationId xmlns:a16="http://schemas.microsoft.com/office/drawing/2014/main" id="{43D39B43-4DE8-4AC5-A7B3-FACF44098999}"/>
               </a:ext>
             </a:extLst>
           </p:cNvPr>
@@ -12969,7 +12929,7 @@
           <p:cNvPr id="59" name="">
             <a:extLst xmlns:a="http://schemas.openxmlformats.org/drawingml/2006/main">
               <a:ext uri="{FF2B5EF4-FFF2-40B4-BE49-F238E27FC236}">
-                <a16:creationId xmlns:a16="http://schemas.microsoft.com/office/drawing/2014/main" id="{6D470339-CFEC-41B1-88A7-30EEB2562907}"/>
+                <a16:creationId xmlns:a16="http://schemas.microsoft.com/office/drawing/2014/main" id="{EF90F4BA-365E-4460-8099-6E45D2E86388}"/>
               </a:ext>
             </a:extLst>
           </p:cNvPr>
@@ -13035,7 +12995,7 @@
           <p:cNvPr id="60" name="">
             <a:extLst xmlns:a="http://schemas.openxmlformats.org/drawingml/2006/main">
               <a:ext uri="{FF2B5EF4-FFF2-40B4-BE49-F238E27FC236}">
-                <a16:creationId xmlns:a16="http://schemas.microsoft.com/office/drawing/2014/main" id="{06299C9D-19B3-45E1-87E9-C6B633EDEBD3}"/>
+                <a16:creationId xmlns:a16="http://schemas.microsoft.com/office/drawing/2014/main" id="{D70AE5C6-DCFA-4FB4-9DC1-CF981ACE38EE}"/>
               </a:ext>
             </a:extLst>
           </p:cNvPr>
@@ -13065,7 +13025,7 @@
           <p:cNvPr id="61" name="">
             <a:extLst xmlns:a="http://schemas.openxmlformats.org/drawingml/2006/main">
               <a:ext uri="{FF2B5EF4-FFF2-40B4-BE49-F238E27FC236}">
-                <a16:creationId xmlns:a16="http://schemas.microsoft.com/office/drawing/2014/main" id="{6678A863-6947-4863-AEED-09B200E4622A}"/>
+                <a16:creationId xmlns:a16="http://schemas.microsoft.com/office/drawing/2014/main" id="{9995827D-EED0-4F17-82FF-E841359EE546}"/>
               </a:ext>
             </a:extLst>
           </p:cNvPr>
@@ -13131,7 +13091,7 @@
           <p:cNvPr id="62" name="">
             <a:extLst xmlns:a="http://schemas.openxmlformats.org/drawingml/2006/main">
               <a:ext uri="{FF2B5EF4-FFF2-40B4-BE49-F238E27FC236}">
-                <a16:creationId xmlns:a16="http://schemas.microsoft.com/office/drawing/2014/main" id="{B94E18CE-6D87-4942-BE87-E896C62BE2A4}"/>
+                <a16:creationId xmlns:a16="http://schemas.microsoft.com/office/drawing/2014/main" id="{63BAD5EA-B9BC-40C7-8F94-E6895983C3DB}"/>
               </a:ext>
             </a:extLst>
           </p:cNvPr>
@@ -13161,7 +13121,7 @@
           <p:cNvPr id="63" name="">
             <a:extLst xmlns:a="http://schemas.openxmlformats.org/drawingml/2006/main">
               <a:ext uri="{FF2B5EF4-FFF2-40B4-BE49-F238E27FC236}">
-                <a16:creationId xmlns:a16="http://schemas.microsoft.com/office/drawing/2014/main" id="{694F1927-2B79-4730-AB2D-7299772AE25F}"/>
+                <a16:creationId xmlns:a16="http://schemas.microsoft.com/office/drawing/2014/main" id="{00452F30-6F93-4BA2-8AD5-59798359A127}"/>
               </a:ext>
             </a:extLst>
           </p:cNvPr>
@@ -13227,7 +13187,7 @@
           <p:cNvPr id="64" name="">
             <a:extLst xmlns:a="http://schemas.openxmlformats.org/drawingml/2006/main">
               <a:ext uri="{FF2B5EF4-FFF2-40B4-BE49-F238E27FC236}">
-                <a16:creationId xmlns:a16="http://schemas.microsoft.com/office/drawing/2014/main" id="{41A5185D-4230-4733-9BD0-EC76A04FB232}"/>
+                <a16:creationId xmlns:a16="http://schemas.microsoft.com/office/drawing/2014/main" id="{7B8BCB3F-FDB7-41F9-86D1-D996CBA734C5}"/>
               </a:ext>
             </a:extLst>
           </p:cNvPr>
@@ -13257,7 +13217,7 @@
           <p:cNvPr id="65" name="">
             <a:extLst xmlns:a="http://schemas.openxmlformats.org/drawingml/2006/main">
               <a:ext uri="{FF2B5EF4-FFF2-40B4-BE49-F238E27FC236}">
-                <a16:creationId xmlns:a16="http://schemas.microsoft.com/office/drawing/2014/main" id="{70A926FA-8B77-43C8-8B3D-4308B62D6A18}"/>
+                <a16:creationId xmlns:a16="http://schemas.microsoft.com/office/drawing/2014/main" id="{F55ED05B-1F77-4BC7-87FC-B4AED278F1D0}"/>
               </a:ext>
             </a:extLst>
           </p:cNvPr>
@@ -13323,7 +13283,7 @@
           <p:cNvPr id="66" name="">
             <a:extLst xmlns:a="http://schemas.openxmlformats.org/drawingml/2006/main">
               <a:ext uri="{FF2B5EF4-FFF2-40B4-BE49-F238E27FC236}">
-                <a16:creationId xmlns:a16="http://schemas.microsoft.com/office/drawing/2014/main" id="{A669E152-CE70-45F0-BC8D-801F5C1EAB5E}"/>
+                <a16:creationId xmlns:a16="http://schemas.microsoft.com/office/drawing/2014/main" id="{F985F842-3A03-4522-B0F8-AD8BEF3B8F94}"/>
               </a:ext>
             </a:extLst>
           </p:cNvPr>
@@ -13353,7 +13313,7 @@
           <p:cNvPr id="67" name="">
             <a:extLst xmlns:a="http://schemas.openxmlformats.org/drawingml/2006/main">
               <a:ext uri="{FF2B5EF4-FFF2-40B4-BE49-F238E27FC236}">
-                <a16:creationId xmlns:a16="http://schemas.microsoft.com/office/drawing/2014/main" id="{5BB52C6F-6046-471E-AC5C-729C1AC03D29}"/>
+                <a16:creationId xmlns:a16="http://schemas.microsoft.com/office/drawing/2014/main" id="{1E11258C-BBD1-4D2A-8409-884090E2B4A8}"/>
               </a:ext>
             </a:extLst>
           </p:cNvPr>
@@ -13419,7 +13379,7 @@
           <p:cNvPr id="68" name="">
             <a:extLst xmlns:a="http://schemas.openxmlformats.org/drawingml/2006/main">
               <a:ext uri="{FF2B5EF4-FFF2-40B4-BE49-F238E27FC236}">
-                <a16:creationId xmlns:a16="http://schemas.microsoft.com/office/drawing/2014/main" id="{9A46807A-30F5-4976-A5BE-01050B689E4B}"/>
+                <a16:creationId xmlns:a16="http://schemas.microsoft.com/office/drawing/2014/main" id="{7499890F-64DC-4E63-BA21-121630FBFFBE}"/>
               </a:ext>
             </a:extLst>
           </p:cNvPr>
@@ -13449,7 +13409,7 @@
           <p:cNvPr id="69" name="">
             <a:extLst xmlns:a="http://schemas.openxmlformats.org/drawingml/2006/main">
               <a:ext uri="{FF2B5EF4-FFF2-40B4-BE49-F238E27FC236}">
-                <a16:creationId xmlns:a16="http://schemas.microsoft.com/office/drawing/2014/main" id="{A2B322F9-743D-482D-B6CD-C213F2A49C00}"/>
+                <a16:creationId xmlns:a16="http://schemas.microsoft.com/office/drawing/2014/main" id="{A5431C6F-0785-440C-AEFC-61DD95E6261A}"/>
               </a:ext>
             </a:extLst>
           </p:cNvPr>
@@ -13515,7 +13475,7 @@
           <p:cNvPr id="70" name="">
             <a:extLst xmlns:a="http://schemas.openxmlformats.org/drawingml/2006/main">
               <a:ext uri="{FF2B5EF4-FFF2-40B4-BE49-F238E27FC236}">
-                <a16:creationId xmlns:a16="http://schemas.microsoft.com/office/drawing/2014/main" id="{281317C5-443C-45B0-8559-0493EA5A06D6}"/>
+                <a16:creationId xmlns:a16="http://schemas.microsoft.com/office/drawing/2014/main" id="{9E238905-44C7-412C-89C5-5DC9F1C65610}"/>
               </a:ext>
             </a:extLst>
           </p:cNvPr>
@@ -13545,7 +13505,7 @@
           <p:cNvPr id="71" name="">
             <a:extLst xmlns:a="http://schemas.openxmlformats.org/drawingml/2006/main">
               <a:ext uri="{FF2B5EF4-FFF2-40B4-BE49-F238E27FC236}">
-                <a16:creationId xmlns:a16="http://schemas.microsoft.com/office/drawing/2014/main" id="{F1E15057-ECCD-404E-8690-DB1F3D65810B}"/>
+                <a16:creationId xmlns:a16="http://schemas.microsoft.com/office/drawing/2014/main" id="{12457CA8-2B17-45CA-B3A3-047EB1AD1ECB}"/>
               </a:ext>
             </a:extLst>
           </p:cNvPr>
@@ -13611,7 +13571,7 @@
           <p:cNvPr id="72" name="">
             <a:extLst xmlns:a="http://schemas.openxmlformats.org/drawingml/2006/main">
               <a:ext uri="{FF2B5EF4-FFF2-40B4-BE49-F238E27FC236}">
-                <a16:creationId xmlns:a16="http://schemas.microsoft.com/office/drawing/2014/main" id="{0C8E5C10-E4FB-43A1-8EE9-CEB5940DF388}"/>
+                <a16:creationId xmlns:a16="http://schemas.microsoft.com/office/drawing/2014/main" id="{5B4BCC2B-9F2F-4BC7-99D8-95DB2DD01144}"/>
               </a:ext>
             </a:extLst>
           </p:cNvPr>
@@ -13641,7 +13601,7 @@
           <p:cNvPr id="73" name="">
             <a:extLst xmlns:a="http://schemas.openxmlformats.org/drawingml/2006/main">
               <a:ext uri="{FF2B5EF4-FFF2-40B4-BE49-F238E27FC236}">
-                <a16:creationId xmlns:a16="http://schemas.microsoft.com/office/drawing/2014/main" id="{8D16F834-8BF2-4185-B583-6347176CEB26}"/>
+                <a16:creationId xmlns:a16="http://schemas.microsoft.com/office/drawing/2014/main" id="{1CDCA16A-9AEC-401D-B4F3-6BC5B03FDF49}"/>
               </a:ext>
             </a:extLst>
           </p:cNvPr>
@@ -13707,7 +13667,7 @@
           <p:cNvPr id="74" name="">
             <a:extLst xmlns:a="http://schemas.openxmlformats.org/drawingml/2006/main">
               <a:ext uri="{FF2B5EF4-FFF2-40B4-BE49-F238E27FC236}">
-                <a16:creationId xmlns:a16="http://schemas.microsoft.com/office/drawing/2014/main" id="{5C871D1E-45EE-477E-A636-E5F820678A05}"/>
+                <a16:creationId xmlns:a16="http://schemas.microsoft.com/office/drawing/2014/main" id="{BC681E54-F172-47AE-83D6-6250BE76C5DA}"/>
               </a:ext>
             </a:extLst>
           </p:cNvPr>
@@ -13737,7 +13697,7 @@
           <p:cNvPr id="75" name="">
             <a:extLst xmlns:a="http://schemas.openxmlformats.org/drawingml/2006/main">
               <a:ext uri="{FF2B5EF4-FFF2-40B4-BE49-F238E27FC236}">
-                <a16:creationId xmlns:a16="http://schemas.microsoft.com/office/drawing/2014/main" id="{9EB2FDE3-F6BD-4094-887E-D33D340DCDA4}"/>
+                <a16:creationId xmlns:a16="http://schemas.microsoft.com/office/drawing/2014/main" id="{244C24BC-56F1-47C3-AAEF-0F227DD801E9}"/>
               </a:ext>
             </a:extLst>
           </p:cNvPr>
@@ -13803,7 +13763,7 @@
           <p:cNvPr id="76" name="">
             <a:extLst xmlns:a="http://schemas.openxmlformats.org/drawingml/2006/main">
               <a:ext uri="{FF2B5EF4-FFF2-40B4-BE49-F238E27FC236}">
-                <a16:creationId xmlns:a16="http://schemas.microsoft.com/office/drawing/2014/main" id="{D85F3B4C-B4AC-41AE-9DFE-9FEA7F61FF32}"/>
+                <a16:creationId xmlns:a16="http://schemas.microsoft.com/office/drawing/2014/main" id="{1FA3BAE4-6611-4EB3-8268-A735443B6EBA}"/>
               </a:ext>
             </a:extLst>
           </p:cNvPr>
@@ -13833,7 +13793,7 @@
           <p:cNvPr id="77" name="">
             <a:extLst xmlns:a="http://schemas.openxmlformats.org/drawingml/2006/main">
               <a:ext uri="{FF2B5EF4-FFF2-40B4-BE49-F238E27FC236}">
-                <a16:creationId xmlns:a16="http://schemas.microsoft.com/office/drawing/2014/main" id="{E412BD0B-3DE0-4ACA-AEBE-4860EE346FD8}"/>
+                <a16:creationId xmlns:a16="http://schemas.microsoft.com/office/drawing/2014/main" id="{8A67CB52-FD60-4B33-8844-65A8A0D1DEB3}"/>
               </a:ext>
             </a:extLst>
           </p:cNvPr>
@@ -13899,7 +13859,7 @@
           <p:cNvPr id="78" name="">
             <a:extLst xmlns:a="http://schemas.openxmlformats.org/drawingml/2006/main">
               <a:ext uri="{FF2B5EF4-FFF2-40B4-BE49-F238E27FC236}">
-                <a16:creationId xmlns:a16="http://schemas.microsoft.com/office/drawing/2014/main" id="{000079E2-001A-49EC-A3DC-919B30FD8C67}"/>
+                <a16:creationId xmlns:a16="http://schemas.microsoft.com/office/drawing/2014/main" id="{B975A8B8-FFE1-4DB4-9E1C-7F344BBA7BD5}"/>
               </a:ext>
             </a:extLst>
           </p:cNvPr>
@@ -13929,7 +13889,7 @@
           <p:cNvPr id="79" name="">
             <a:extLst xmlns:a="http://schemas.openxmlformats.org/drawingml/2006/main">
               <a:ext uri="{FF2B5EF4-FFF2-40B4-BE49-F238E27FC236}">
-                <a16:creationId xmlns:a16="http://schemas.microsoft.com/office/drawing/2014/main" id="{F9ABF5FF-63AB-4D8E-851F-C22FF12D486F}"/>
+                <a16:creationId xmlns:a16="http://schemas.microsoft.com/office/drawing/2014/main" id="{83CBF73B-BB50-4942-BCBB-B5266670471C}"/>
               </a:ext>
             </a:extLst>
           </p:cNvPr>
@@ -13995,7 +13955,7 @@
           <p:cNvPr id="80" name="">
             <a:extLst xmlns:a="http://schemas.openxmlformats.org/drawingml/2006/main">
               <a:ext uri="{FF2B5EF4-FFF2-40B4-BE49-F238E27FC236}">
-                <a16:creationId xmlns:a16="http://schemas.microsoft.com/office/drawing/2014/main" id="{D79E0A65-967A-464F-BDD5-32F545561296}"/>
+                <a16:creationId xmlns:a16="http://schemas.microsoft.com/office/drawing/2014/main" id="{01C284A4-7F65-4F0D-A9A5-7B38AF8D153B}"/>
               </a:ext>
             </a:extLst>
           </p:cNvPr>
@@ -14061,7 +14021,7 @@
           <p:cNvPr id="81" name="">
             <a:extLst xmlns:a="http://schemas.openxmlformats.org/drawingml/2006/main">
               <a:ext uri="{FF2B5EF4-FFF2-40B4-BE49-F238E27FC236}">
-                <a16:creationId xmlns:a16="http://schemas.microsoft.com/office/drawing/2014/main" id="{34846B03-898C-4F1F-9F7F-F84C42115A9C}"/>
+                <a16:creationId xmlns:a16="http://schemas.microsoft.com/office/drawing/2014/main" id="{A120D041-AE3E-494E-A70C-9C407E8A7AC1}"/>
               </a:ext>
             </a:extLst>
           </p:cNvPr>
@@ -14125,7 +14085,7 @@
     </p:spTree>
     <p:extLst>
       <p:ext uri="{BB962C8B-B14F-4D97-AF65-F5344CB8AC3E}">
-        <p14:creationId xmlns:p14="http://schemas.microsoft.com/office/powerpoint/2010/main" val="596023358"/>
+        <p14:creationId xmlns:p14="http://schemas.microsoft.com/office/powerpoint/2010/main" val="389052359"/>
       </p:ext>
     </p:extLst>
   </p:cSld>
@@ -14153,10 +14113,10 @@
       </p:grpSpPr>
       <p:sp>
         <p:nvSpPr>
-          <p:cNvPr id="33" name="">
-            <a:extLst xmlns:a="http://schemas.openxmlformats.org/drawingml/2006/main">
-              <a:ext uri="{FF2B5EF4-FFF2-40B4-BE49-F238E27FC236}">
-                <a16:creationId xmlns:a16="http://schemas.microsoft.com/office/drawing/2014/main" id="{ADD4930B-A6FA-4FFB-BCB7-CBAF907FE9BE}"/>
+          <p:cNvPr id="16" name="">
+            <a:extLst xmlns:a="http://schemas.openxmlformats.org/drawingml/2006/main">
+              <a:ext uri="{FF2B5EF4-FFF2-40B4-BE49-F238E27FC236}">
+                <a16:creationId xmlns:a16="http://schemas.microsoft.com/office/drawing/2014/main" id="{BA587F9A-B1E9-430F-A7D2-14CBA648365E}"/>
               </a:ext>
             </a:extLst>
           </p:cNvPr>
@@ -14222,7 +14182,7 @@
           <p:cNvPr id="2" name="">
             <a:extLst xmlns:a="http://schemas.openxmlformats.org/drawingml/2006/main">
               <a:ext uri="{FF2B5EF4-FFF2-40B4-BE49-F238E27FC236}">
-                <a16:creationId xmlns:a16="http://schemas.microsoft.com/office/drawing/2014/main" id="{5FFD9A7E-B826-4B3A-81AF-C40E96CA7F93}"/>
+                <a16:creationId xmlns:a16="http://schemas.microsoft.com/office/drawing/2014/main" id="{1FE8A3AF-3722-4880-A3A4-6D6F33B6102B}"/>
               </a:ext>
             </a:extLst>
           </p:cNvPr>
@@ -14278,7 +14238,7 @@
                 <a:ea typeface="Ubuntu Condensed"/>
                 <a:cs typeface="Ubuntu Condensed"/>
               </a:rPr>
-              <a:t>The same country records, grouped by region</a:t>
+              <a:t>How many countries fall in each life-expectancy band? (2020)</a:t>
             </a:r>
           </a:p>
         </p:txBody>
@@ -14288,7 +14248,7 @@
           <p:cNvPr id="3" name="">
             <a:extLst xmlns:a="http://schemas.openxmlformats.org/drawingml/2006/main">
               <a:ext uri="{FF2B5EF4-FFF2-40B4-BE49-F238E27FC236}">
-                <a16:creationId xmlns:a16="http://schemas.microsoft.com/office/drawing/2014/main" id="{3BA781BB-B28B-4A10-B6E4-0728F64C161C}"/>
+                <a16:creationId xmlns:a16="http://schemas.microsoft.com/office/drawing/2014/main" id="{69F04BFF-B9CD-4AD7-A9FA-0709EDA13201}"/>
               </a:ext>
             </a:extLst>
           </p:cNvPr>
@@ -14354,7 +14314,7 @@
           <p:cNvPr id="4" name="">
             <a:extLst xmlns:a="http://schemas.openxmlformats.org/drawingml/2006/main">
               <a:ext uri="{FF2B5EF4-FFF2-40B4-BE49-F238E27FC236}">
-                <a16:creationId xmlns:a16="http://schemas.microsoft.com/office/drawing/2014/main" id="{DD907079-9393-4328-97E2-C23637A66B68}"/>
+                <a16:creationId xmlns:a16="http://schemas.microsoft.com/office/drawing/2014/main" id="{7912480F-F24C-40B3-BBDC-258D8C09EE38}"/>
               </a:ext>
             </a:extLst>
           </p:cNvPr>
@@ -14420,7 +14380,7 @@
           <p:cNvPr id="5" name="">
             <a:extLst xmlns:a="http://schemas.openxmlformats.org/drawingml/2006/main">
               <a:ext uri="{FF2B5EF4-FFF2-40B4-BE49-F238E27FC236}">
-                <a16:creationId xmlns:a16="http://schemas.microsoft.com/office/drawing/2014/main" id="{E5AB973A-F5E7-49EA-A52D-4C576811F2AE}"/>
+                <a16:creationId xmlns:a16="http://schemas.microsoft.com/office/drawing/2014/main" id="{D3640C0A-3D8D-4147-AB9F-C75269CA8F65}"/>
               </a:ext>
             </a:extLst>
           </p:cNvPr>
@@ -14486,7 +14446,7 @@
           <p:cNvPr id="6" name="">
             <a:extLst xmlns:a="http://schemas.openxmlformats.org/drawingml/2006/main">
               <a:ext uri="{FF2B5EF4-FFF2-40B4-BE49-F238E27FC236}">
-                <a16:creationId xmlns:a16="http://schemas.microsoft.com/office/drawing/2014/main" id="{F2A4CAD0-B90D-476E-BFBE-792B03B3D0DE}"/>
+                <a16:creationId xmlns:a16="http://schemas.microsoft.com/office/drawing/2014/main" id="{7C596D97-D8B4-41A4-AFBC-DD2CA2466CC5}"/>
               </a:ext>
             </a:extLst>
           </p:cNvPr>
@@ -14552,7 +14512,7 @@
           <p:cNvPr id="7" name="Chart">
             <a:extLst xmlns:a="http://schemas.openxmlformats.org/drawingml/2006/main">
               <a:ext uri="{FF2B5EF4-FFF2-40B4-BE49-F238E27FC236}">
-                <a16:creationId xmlns:a16="http://schemas.microsoft.com/office/drawing/2014/main" id="{04443EDC-FC46-49E2-B70B-1B8881836E90}"/>
+                <a16:creationId xmlns:a16="http://schemas.microsoft.com/office/drawing/2014/main" id="{4EF225B6-AB37-437D-A20A-504A6FACB713}"/>
               </a:ext>
             </a:extLst>
           </p:cNvPr>
@@ -14560,12 +14520,12 @@
           <p:nvPr/>
         </p:nvGraphicFramePr>
         <p:xfrm>
-          <a:off xmlns:a="http://schemas.openxmlformats.org/drawingml/2006/main" x="238125" y="2733675"/>
-          <a:ext xmlns:a="http://schemas.openxmlformats.org/drawingml/2006/main" cx="5619750" cy="3048000"/>
+          <a:off xmlns:a="http://schemas.openxmlformats.org/drawingml/2006/main" x="114300" y="2686050"/>
+          <a:ext xmlns:a="http://schemas.openxmlformats.org/drawingml/2006/main" cx="5791200" cy="3190875"/>
         </p:xfrm>
         <a:graphic xmlns:a="http://schemas.openxmlformats.org/drawingml/2006/main">
           <a:graphicData uri="http://schemas.openxmlformats.org/drawingml/2006/chart">
-            <c:chart xmlns:r="http://schemas.openxmlformats.org/officeDocument/2006/relationships" xmlns:c="http://schemas.openxmlformats.org/drawingml/2006/chart" r:id="R7d7b7f2f1e614e69"/>
+            <c:chart xmlns:r="http://schemas.openxmlformats.org/officeDocument/2006/relationships" xmlns:c="http://schemas.openxmlformats.org/drawingml/2006/chart" r:id="R985a7a4115bf45dc"/>
           </a:graphicData>
         </a:graphic>
       </p:graphicFrame>
@@ -14574,7 +14534,7 @@
           <p:cNvPr id="8" name="">
             <a:extLst xmlns:a="http://schemas.openxmlformats.org/drawingml/2006/main">
               <a:ext uri="{FF2B5EF4-FFF2-40B4-BE49-F238E27FC236}">
-                <a16:creationId xmlns:a16="http://schemas.microsoft.com/office/drawing/2014/main" id="{AB138C4F-D0AD-49DC-889B-A1427140C267}"/>
+                <a16:creationId xmlns:a16="http://schemas.microsoft.com/office/drawing/2014/main" id="{8021F97F-D819-41AD-AF5D-FD92D052EDDD}"/>
               </a:ext>
             </a:extLst>
           </p:cNvPr>
@@ -14586,7 +14546,7 @@
         <p:spPr>
           <a:xfrm xmlns:a="http://schemas.openxmlformats.org/drawingml/2006/main">
             <a:off x="6581775" y="2771775"/>
-            <a:ext cx="2386617" cy="1605321"/>
+            <a:ext cx="2528888" cy="2886075"/>
           </a:xfrm>
           <a:prstGeom xmlns:a="http://schemas.openxmlformats.org/drawingml/2006/main" prst="rect">
             <a:avLst/>
@@ -14604,19 +14564,19 @@
           <p:cNvPr id="9" name="">
             <a:extLst xmlns:a="http://schemas.openxmlformats.org/drawingml/2006/main">
               <a:ext uri="{FF2B5EF4-FFF2-40B4-BE49-F238E27FC236}">
-                <a16:creationId xmlns:a16="http://schemas.microsoft.com/office/drawing/2014/main" id="{2516500E-9BFC-4BD9-AEE8-43B9D346FE7D}"/>
-              </a:ext>
-            </a:extLst>
-          </p:cNvPr>
-          <p:cNvSpPr>
-            <a:spLocks xmlns:a="http://schemas.openxmlformats.org/drawingml/2006/main" noGrp="1"/>
-          </p:cNvSpPr>
-          <p:nvPr/>
-        </p:nvSpPr>
-        <p:spPr>
-          <a:xfrm xmlns:a="http://schemas.openxmlformats.org/drawingml/2006/main">
-            <a:off x="6581775" y="3288685"/>
-            <a:ext cx="2386617" cy="666750"/>
+                <a16:creationId xmlns:a16="http://schemas.microsoft.com/office/drawing/2014/main" id="{E2AADAB5-D6B3-436E-B383-740A246F180D}"/>
+              </a:ext>
+            </a:extLst>
+          </p:cNvPr>
+          <p:cNvSpPr>
+            <a:spLocks xmlns:a="http://schemas.openxmlformats.org/drawingml/2006/main" noGrp="1"/>
+          </p:cNvSpPr>
+          <p:nvPr/>
+        </p:nvSpPr>
+        <p:spPr>
+          <a:xfrm xmlns:a="http://schemas.openxmlformats.org/drawingml/2006/main">
+            <a:off x="6581775" y="3929063"/>
+            <a:ext cx="2528888" cy="666750"/>
           </a:xfrm>
           <a:prstGeom xmlns:a="http://schemas.openxmlformats.org/drawingml/2006/main" prst="rect">
             <a:avLst/>
@@ -14660,7 +14620,7 @@
                 <a:ea typeface="Ubuntu Condensed"/>
                 <a:cs typeface="Ubuntu Condensed"/>
               </a:rPr>
-              <a:t>Africa</a:t>
+              <a:t>70–79 years</a:t>
             </a:r>
           </a:p>
           <a:p xmlns:a="http://schemas.openxmlformats.org/drawingml/2006/main">
@@ -14683,7 +14643,7 @@
                 <a:ea typeface="Ubuntu Condensed"/>
                 <a:cs typeface="Ubuntu Condensed"/>
               </a:rPr>
-              <a:t>52</a:t>
+              <a:t>97</a:t>
             </a:r>
           </a:p>
         </p:txBody>
@@ -14693,25 +14653,25 @@
           <p:cNvPr id="10" name="">
             <a:extLst xmlns:a="http://schemas.openxmlformats.org/drawingml/2006/main">
               <a:ext uri="{FF2B5EF4-FFF2-40B4-BE49-F238E27FC236}">
-                <a16:creationId xmlns:a16="http://schemas.microsoft.com/office/drawing/2014/main" id="{DFBD132F-0E37-4B8F-A0A4-F859A0E8E404}"/>
-              </a:ext>
-            </a:extLst>
-          </p:cNvPr>
-          <p:cNvSpPr>
-            <a:spLocks xmlns:a="http://schemas.openxmlformats.org/drawingml/2006/main" noGrp="1"/>
-          </p:cNvSpPr>
-          <p:nvPr/>
-        </p:nvSpPr>
-        <p:spPr>
-          <a:xfrm xmlns:a="http://schemas.openxmlformats.org/drawingml/2006/main">
-            <a:off x="6581775" y="4396146"/>
-            <a:ext cx="2386617" cy="1261704"/>
+                <a16:creationId xmlns:a16="http://schemas.microsoft.com/office/drawing/2014/main" id="{952B16AA-B25C-4A60-A43A-59B66C185AF2}"/>
+              </a:ext>
+            </a:extLst>
+          </p:cNvPr>
+          <p:cNvSpPr>
+            <a:spLocks xmlns:a="http://schemas.openxmlformats.org/drawingml/2006/main" noGrp="1"/>
+          </p:cNvSpPr>
+          <p:nvPr/>
+        </p:nvSpPr>
+        <p:spPr>
+          <a:xfrm xmlns:a="http://schemas.openxmlformats.org/drawingml/2006/main">
+            <a:off x="9129713" y="2771775"/>
+            <a:ext cx="2528888" cy="2017532"/>
           </a:xfrm>
           <a:prstGeom xmlns:a="http://schemas.openxmlformats.org/drawingml/2006/main" prst="rect">
             <a:avLst/>
           </a:prstGeom>
           <a:solidFill xmlns:a="http://schemas.openxmlformats.org/drawingml/2006/main">
-            <a:srgbClr val="457985"/>
+            <a:srgbClr val="C18A34"/>
           </a:solidFill>
           <a:ln xmlns:a="http://schemas.openxmlformats.org/drawingml/2006/main" w="0">
             <a:noFill/>
@@ -14723,19 +14683,19 @@
           <p:cNvPr id="11" name="">
             <a:extLst xmlns:a="http://schemas.openxmlformats.org/drawingml/2006/main">
               <a:ext uri="{FF2B5EF4-FFF2-40B4-BE49-F238E27FC236}">
-                <a16:creationId xmlns:a16="http://schemas.microsoft.com/office/drawing/2014/main" id="{B2EFC774-25E8-46C6-8292-9C93A13F59C2}"/>
-              </a:ext>
-            </a:extLst>
-          </p:cNvPr>
-          <p:cNvSpPr>
-            <a:spLocks xmlns:a="http://schemas.openxmlformats.org/drawingml/2006/main" noGrp="1"/>
-          </p:cNvSpPr>
-          <p:nvPr/>
-        </p:nvSpPr>
-        <p:spPr>
-          <a:xfrm xmlns:a="http://schemas.openxmlformats.org/drawingml/2006/main">
-            <a:off x="6581775" y="4741248"/>
-            <a:ext cx="2386617" cy="666750"/>
+                <a16:creationId xmlns:a16="http://schemas.microsoft.com/office/drawing/2014/main" id="{70640138-FE68-4D73-AC23-BB17282B8636}"/>
+              </a:ext>
+            </a:extLst>
+          </p:cNvPr>
+          <p:cNvSpPr>
+            <a:spLocks xmlns:a="http://schemas.openxmlformats.org/drawingml/2006/main" noGrp="1"/>
+          </p:cNvSpPr>
+          <p:nvPr/>
+        </p:nvSpPr>
+        <p:spPr>
+          <a:xfrm xmlns:a="http://schemas.openxmlformats.org/drawingml/2006/main">
+            <a:off x="9129713" y="3494791"/>
+            <a:ext cx="2528888" cy="666750"/>
           </a:xfrm>
           <a:prstGeom xmlns:a="http://schemas.openxmlformats.org/drawingml/2006/main" prst="rect">
             <a:avLst/>
@@ -14779,7 +14739,7 @@
                 <a:ea typeface="Ubuntu Condensed"/>
                 <a:cs typeface="Ubuntu Condensed"/>
               </a:rPr>
-              <a:t>Asia</a:t>
+              <a:t>Under 70</a:t>
             </a:r>
           </a:p>
           <a:p xmlns:a="http://schemas.openxmlformats.org/drawingml/2006/main">
@@ -14802,7 +14762,7 @@
                 <a:ea typeface="Ubuntu Condensed"/>
                 <a:cs typeface="Ubuntu Condensed"/>
               </a:rPr>
-              <a:t>41</a:t>
+              <a:t>68</a:t>
             </a:r>
           </a:p>
         </p:txBody>
@@ -14812,25 +14772,25 @@
           <p:cNvPr id="12" name="">
             <a:extLst xmlns:a="http://schemas.openxmlformats.org/drawingml/2006/main">
               <a:ext uri="{FF2B5EF4-FFF2-40B4-BE49-F238E27FC236}">
-                <a16:creationId xmlns:a16="http://schemas.microsoft.com/office/drawing/2014/main" id="{071320E4-A13A-4FC1-AA40-0BCD7B43EDFB}"/>
-              </a:ext>
-            </a:extLst>
-          </p:cNvPr>
-          <p:cNvSpPr>
-            <a:spLocks xmlns:a="http://schemas.openxmlformats.org/drawingml/2006/main" noGrp="1"/>
-          </p:cNvSpPr>
-          <p:nvPr/>
-        </p:nvSpPr>
-        <p:spPr>
-          <a:xfrm xmlns:a="http://schemas.openxmlformats.org/drawingml/2006/main">
-            <a:off x="8987442" y="2771775"/>
-            <a:ext cx="1041513" cy="2886075"/>
+                <a16:creationId xmlns:a16="http://schemas.microsoft.com/office/drawing/2014/main" id="{56FE917A-A0BD-4FFE-9F30-0D9DD432537C}"/>
+              </a:ext>
+            </a:extLst>
+          </p:cNvPr>
+          <p:cNvSpPr>
+            <a:spLocks xmlns:a="http://schemas.openxmlformats.org/drawingml/2006/main" noGrp="1"/>
+          </p:cNvSpPr>
+          <p:nvPr/>
+        </p:nvSpPr>
+        <p:spPr>
+          <a:xfrm xmlns:a="http://schemas.openxmlformats.org/drawingml/2006/main">
+            <a:off x="9129713" y="4808357"/>
+            <a:ext cx="2528888" cy="849493"/>
           </a:xfrm>
           <a:prstGeom xmlns:a="http://schemas.openxmlformats.org/drawingml/2006/main" prst="rect">
             <a:avLst/>
           </a:prstGeom>
           <a:solidFill xmlns:a="http://schemas.openxmlformats.org/drawingml/2006/main">
-            <a:srgbClr val="647545"/>
+            <a:srgbClr val="457985"/>
           </a:solidFill>
           <a:ln xmlns:a="http://schemas.openxmlformats.org/drawingml/2006/main" w="0">
             <a:noFill/>
@@ -14842,138 +14802,19 @@
           <p:cNvPr id="13" name="">
             <a:extLst xmlns:a="http://schemas.openxmlformats.org/drawingml/2006/main">
               <a:ext uri="{FF2B5EF4-FFF2-40B4-BE49-F238E27FC236}">
-                <a16:creationId xmlns:a16="http://schemas.microsoft.com/office/drawing/2014/main" id="{5EF851E9-6C63-49B7-853C-0A964262C966}"/>
-              </a:ext>
-            </a:extLst>
-          </p:cNvPr>
-          <p:cNvSpPr>
-            <a:spLocks xmlns:a="http://schemas.openxmlformats.org/drawingml/2006/main" noGrp="1"/>
-          </p:cNvSpPr>
-          <p:nvPr/>
-        </p:nvSpPr>
-        <p:spPr>
-          <a:xfrm xmlns:a="http://schemas.openxmlformats.org/drawingml/2006/main">
-            <a:off x="8987442" y="3929063"/>
-            <a:ext cx="1041513" cy="666750"/>
-          </a:xfrm>
-          <a:prstGeom xmlns:a="http://schemas.openxmlformats.org/drawingml/2006/main" prst="rect">
-            <a:avLst/>
-          </a:prstGeom>
-          <a:noFill xmlns:a="http://schemas.openxmlformats.org/drawingml/2006/main"/>
-          <a:ln xmlns:a="http://schemas.openxmlformats.org/drawingml/2006/main" w="0">
-            <a:noFill/>
-          </a:ln>
-        </p:spPr>
-        <p:txBody>
-          <a:bodyPr xmlns:a="http://schemas.openxmlformats.org/drawingml/2006/main" lIns="0" tIns="0" rIns="0" bIns="0"/>
-          <a:lstStyle xmlns:a="http://schemas.openxmlformats.org/drawingml/2006/main">
-            <a:defPPr algn="ctr">
-              <a:defRPr sz="1350">
-                <a:solidFill>
-                  <a:srgbClr val="FFFFFF"/>
-                </a:solidFill>
-                <a:latin typeface="Ubuntu Condensed"/>
-                <a:ea typeface="Ubuntu Condensed"/>
-                <a:cs typeface="Ubuntu Condensed"/>
-              </a:defRPr>
-            </a:defPPr>
-          </a:lstStyle>
-          <a:p xmlns:a="http://schemas.openxmlformats.org/drawingml/2006/main">
-            <a:pPr algn="ctr">
-              <a:defRPr sz="1350">
-                <a:solidFill>
-                  <a:srgbClr val="FFFFFF"/>
-                </a:solidFill>
-                <a:latin typeface="Ubuntu Condensed"/>
-                <a:ea typeface="Ubuntu Condensed"/>
-                <a:cs typeface="Ubuntu Condensed"/>
-              </a:defRPr>
-            </a:pPr>
-            <a:r>
-              <a:rPr sz="1350">
-                <a:solidFill>
-                  <a:srgbClr val="FFFFFF"/>
-                </a:solidFill>
-                <a:latin typeface="Ubuntu Condensed"/>
-                <a:ea typeface="Ubuntu Condensed"/>
-                <a:cs typeface="Ubuntu Condensed"/>
-              </a:rPr>
-              <a:t>Europe</a:t>
-            </a:r>
-          </a:p>
-          <a:p xmlns:a="http://schemas.openxmlformats.org/drawingml/2006/main">
-            <a:pPr algn="ctr">
-              <a:defRPr sz="1350">
-                <a:solidFill>
-                  <a:srgbClr val="FFFFFF"/>
-                </a:solidFill>
-                <a:latin typeface="Ubuntu Condensed"/>
-                <a:ea typeface="Ubuntu Condensed"/>
-                <a:cs typeface="Ubuntu Condensed"/>
-              </a:defRPr>
-            </a:pPr>
-            <a:r>
-              <a:rPr sz="1350">
-                <a:solidFill>
-                  <a:srgbClr val="FFFFFF"/>
-                </a:solidFill>
-                <a:latin typeface="Ubuntu Condensed"/>
-                <a:ea typeface="Ubuntu Condensed"/>
-                <a:cs typeface="Ubuntu Condensed"/>
-              </a:rPr>
-              <a:t>41</a:t>
-            </a:r>
-          </a:p>
-        </p:txBody>
-      </p:sp>
-      <p:sp>
-        <p:nvSpPr>
-          <p:cNvPr id="14" name="">
-            <a:extLst xmlns:a="http://schemas.openxmlformats.org/drawingml/2006/main">
-              <a:ext uri="{FF2B5EF4-FFF2-40B4-BE49-F238E27FC236}">
-                <a16:creationId xmlns:a16="http://schemas.microsoft.com/office/drawing/2014/main" id="{17A50C80-20C4-482B-89A1-9BB4D5351BFF}"/>
-              </a:ext>
-            </a:extLst>
-          </p:cNvPr>
-          <p:cNvSpPr>
-            <a:spLocks xmlns:a="http://schemas.openxmlformats.org/drawingml/2006/main" noGrp="1"/>
-          </p:cNvSpPr>
-          <p:nvPr/>
-        </p:nvSpPr>
-        <p:spPr>
-          <a:xfrm xmlns:a="http://schemas.openxmlformats.org/drawingml/2006/main">
-            <a:off x="10048005" y="2771775"/>
-            <a:ext cx="1610595" cy="1456569"/>
-          </a:xfrm>
-          <a:prstGeom xmlns:a="http://schemas.openxmlformats.org/drawingml/2006/main" prst="rect">
-            <a:avLst/>
-          </a:prstGeom>
-          <a:solidFill xmlns:a="http://schemas.openxmlformats.org/drawingml/2006/main">
-            <a:srgbClr val="C18A34"/>
-          </a:solidFill>
-          <a:ln xmlns:a="http://schemas.openxmlformats.org/drawingml/2006/main" w="0">
-            <a:noFill/>
-          </a:ln>
-        </p:spPr>
-      </p:sp>
-      <p:sp>
-        <p:nvSpPr>
-          <p:cNvPr id="15" name="">
-            <a:extLst xmlns:a="http://schemas.openxmlformats.org/drawingml/2006/main">
-              <a:ext uri="{FF2B5EF4-FFF2-40B4-BE49-F238E27FC236}">
-                <a16:creationId xmlns:a16="http://schemas.microsoft.com/office/drawing/2014/main" id="{948754DE-9B2E-4C84-B8B3-EE67C2AB3466}"/>
-              </a:ext>
-            </a:extLst>
-          </p:cNvPr>
-          <p:cNvSpPr>
-            <a:spLocks xmlns:a="http://schemas.openxmlformats.org/drawingml/2006/main" noGrp="1"/>
-          </p:cNvSpPr>
-          <p:nvPr/>
-        </p:nvSpPr>
-        <p:spPr>
-          <a:xfrm xmlns:a="http://schemas.openxmlformats.org/drawingml/2006/main">
-            <a:off x="10048005" y="3214310"/>
-            <a:ext cx="1610595" cy="666750"/>
+                <a16:creationId xmlns:a16="http://schemas.microsoft.com/office/drawing/2014/main" id="{06AD902A-1645-4C9B-B2F8-CC608CD9AF76}"/>
+              </a:ext>
+            </a:extLst>
+          </p:cNvPr>
+          <p:cNvSpPr>
+            <a:spLocks xmlns:a="http://schemas.openxmlformats.org/drawingml/2006/main" noGrp="1"/>
+          </p:cNvSpPr>
+          <p:nvPr/>
+        </p:nvSpPr>
+        <p:spPr>
+          <a:xfrm xmlns:a="http://schemas.openxmlformats.org/drawingml/2006/main">
+            <a:off x="9129713" y="4947354"/>
+            <a:ext cx="2528888" cy="666750"/>
           </a:xfrm>
           <a:prstGeom xmlns:a="http://schemas.openxmlformats.org/drawingml/2006/main" prst="rect">
             <a:avLst/>
@@ -15017,7 +14858,7 @@
                 <a:ea typeface="Ubuntu Condensed"/>
                 <a:cs typeface="Ubuntu Condensed"/>
               </a:rPr>
-              <a:t>Americas</a:t>
+              <a:t>80+ years</a:t>
             </a:r>
           </a:p>
           <a:p xmlns:a="http://schemas.openxmlformats.org/drawingml/2006/main">
@@ -15040,297 +14881,29 @@
                 <a:ea typeface="Ubuntu Condensed"/>
                 <a:cs typeface="Ubuntu Condensed"/>
               </a:rPr>
-              <a:t>32</a:t>
+              <a:t>29</a:t>
             </a:r>
           </a:p>
         </p:txBody>
       </p:sp>
       <p:sp>
         <p:nvSpPr>
-          <p:cNvPr id="16" name="">
-            <a:extLst xmlns:a="http://schemas.openxmlformats.org/drawingml/2006/main">
-              <a:ext uri="{FF2B5EF4-FFF2-40B4-BE49-F238E27FC236}">
-                <a16:creationId xmlns:a16="http://schemas.microsoft.com/office/drawing/2014/main" id="{BEF0E9E0-028E-428F-909E-99B2619E0F53}"/>
-              </a:ext>
-            </a:extLst>
-          </p:cNvPr>
-          <p:cNvSpPr>
-            <a:spLocks xmlns:a="http://schemas.openxmlformats.org/drawingml/2006/main" noGrp="1"/>
-          </p:cNvSpPr>
-          <p:nvPr/>
-        </p:nvSpPr>
-        <p:spPr>
-          <a:xfrm xmlns:a="http://schemas.openxmlformats.org/drawingml/2006/main">
-            <a:off x="10048005" y="4247394"/>
-            <a:ext cx="927196" cy="1410456"/>
-          </a:xfrm>
-          <a:prstGeom xmlns:a="http://schemas.openxmlformats.org/drawingml/2006/main" prst="rect">
-            <a:avLst/>
-          </a:prstGeom>
-          <a:solidFill xmlns:a="http://schemas.openxmlformats.org/drawingml/2006/main">
-            <a:srgbClr val="AAA49B"/>
-          </a:solidFill>
-          <a:ln xmlns:a="http://schemas.openxmlformats.org/drawingml/2006/main" w="0">
-            <a:noFill/>
-          </a:ln>
-        </p:spPr>
-      </p:sp>
-      <p:sp>
-        <p:nvSpPr>
-          <p:cNvPr id="17" name="">
-            <a:extLst xmlns:a="http://schemas.openxmlformats.org/drawingml/2006/main">
-              <a:ext uri="{FF2B5EF4-FFF2-40B4-BE49-F238E27FC236}">
-                <a16:creationId xmlns:a16="http://schemas.microsoft.com/office/drawing/2014/main" id="{1CC5B2BC-21B1-4308-882E-FD5F7B02FDA0}"/>
-              </a:ext>
-            </a:extLst>
-          </p:cNvPr>
-          <p:cNvSpPr>
-            <a:spLocks xmlns:a="http://schemas.openxmlformats.org/drawingml/2006/main" noGrp="1"/>
-          </p:cNvSpPr>
-          <p:nvPr/>
-        </p:nvSpPr>
-        <p:spPr>
-          <a:xfrm xmlns:a="http://schemas.openxmlformats.org/drawingml/2006/main">
-            <a:off x="10048005" y="4666872"/>
-            <a:ext cx="927196" cy="666750"/>
-          </a:xfrm>
-          <a:prstGeom xmlns:a="http://schemas.openxmlformats.org/drawingml/2006/main" prst="rect">
-            <a:avLst/>
-          </a:prstGeom>
-          <a:noFill xmlns:a="http://schemas.openxmlformats.org/drawingml/2006/main"/>
-          <a:ln xmlns:a="http://schemas.openxmlformats.org/drawingml/2006/main" w="0">
-            <a:noFill/>
-          </a:ln>
-        </p:spPr>
-        <p:txBody>
-          <a:bodyPr xmlns:a="http://schemas.openxmlformats.org/drawingml/2006/main" lIns="0" tIns="0" rIns="0" bIns="0"/>
-          <a:lstStyle xmlns:a="http://schemas.openxmlformats.org/drawingml/2006/main">
-            <a:defPPr algn="ctr">
-              <a:defRPr sz="1350">
-                <a:solidFill>
-                  <a:srgbClr val="38332E"/>
-                </a:solidFill>
-                <a:latin typeface="Ubuntu Condensed"/>
-                <a:ea typeface="Ubuntu Condensed"/>
-                <a:cs typeface="Ubuntu Condensed"/>
-              </a:defRPr>
-            </a:defPPr>
-          </a:lstStyle>
-          <a:p xmlns:a="http://schemas.openxmlformats.org/drawingml/2006/main">
-            <a:pPr algn="ctr">
-              <a:defRPr sz="1350">
-                <a:solidFill>
-                  <a:srgbClr val="38332E"/>
-                </a:solidFill>
-                <a:latin typeface="Ubuntu Condensed"/>
-                <a:ea typeface="Ubuntu Condensed"/>
-                <a:cs typeface="Ubuntu Condensed"/>
-              </a:defRPr>
-            </a:pPr>
-            <a:r>
-              <a:rPr sz="1350">
-                <a:solidFill>
-                  <a:srgbClr val="38332E"/>
-                </a:solidFill>
-                <a:latin typeface="Ubuntu Condensed"/>
-                <a:ea typeface="Ubuntu Condensed"/>
-                <a:cs typeface="Ubuntu Condensed"/>
-              </a:rPr>
-              <a:t>Unknown</a:t>
-            </a:r>
-          </a:p>
-          <a:p xmlns:a="http://schemas.openxmlformats.org/drawingml/2006/main">
-            <a:pPr algn="ctr">
-              <a:defRPr sz="1350">
-                <a:solidFill>
-                  <a:srgbClr val="38332E"/>
-                </a:solidFill>
-                <a:latin typeface="Ubuntu Condensed"/>
-                <a:ea typeface="Ubuntu Condensed"/>
-                <a:cs typeface="Ubuntu Condensed"/>
-              </a:defRPr>
-            </a:pPr>
-            <a:r>
-              <a:rPr sz="1350">
-                <a:solidFill>
-                  <a:srgbClr val="38332E"/>
-                </a:solidFill>
-                <a:latin typeface="Ubuntu Condensed"/>
-                <a:ea typeface="Ubuntu Condensed"/>
-                <a:cs typeface="Ubuntu Condensed"/>
-              </a:rPr>
-              <a:t>18</a:t>
-            </a:r>
-          </a:p>
-        </p:txBody>
-      </p:sp>
-      <p:sp>
-        <p:nvSpPr>
-          <p:cNvPr id="18" name="">
-            <a:extLst xmlns:a="http://schemas.openxmlformats.org/drawingml/2006/main">
-              <a:ext uri="{FF2B5EF4-FFF2-40B4-BE49-F238E27FC236}">
-                <a16:creationId xmlns:a16="http://schemas.microsoft.com/office/drawing/2014/main" id="{8ED5A916-9FD0-41D5-A7C2-62C174DBFCC8}"/>
-              </a:ext>
-            </a:extLst>
-          </p:cNvPr>
-          <p:cNvSpPr>
-            <a:spLocks xmlns:a="http://schemas.openxmlformats.org/drawingml/2006/main" noGrp="1"/>
-          </p:cNvSpPr>
-          <p:nvPr/>
-        </p:nvSpPr>
-        <p:spPr>
-          <a:xfrm xmlns:a="http://schemas.openxmlformats.org/drawingml/2006/main">
-            <a:off x="10994250" y="4247394"/>
-            <a:ext cx="664350" cy="1410456"/>
-          </a:xfrm>
-          <a:prstGeom xmlns:a="http://schemas.openxmlformats.org/drawingml/2006/main" prst="rect">
-            <a:avLst/>
-          </a:prstGeom>
-          <a:solidFill xmlns:a="http://schemas.openxmlformats.org/drawingml/2006/main">
-            <a:srgbClr val="805773"/>
-          </a:solidFill>
-          <a:ln xmlns:a="http://schemas.openxmlformats.org/drawingml/2006/main" w="0">
-            <a:noFill/>
-          </a:ln>
-        </p:spPr>
-      </p:sp>
-      <p:sp>
-        <p:nvSpPr>
-          <p:cNvPr id="19" name="">
-            <a:extLst xmlns:a="http://schemas.openxmlformats.org/drawingml/2006/main">
-              <a:ext uri="{FF2B5EF4-FFF2-40B4-BE49-F238E27FC236}">
-                <a16:creationId xmlns:a16="http://schemas.microsoft.com/office/drawing/2014/main" id="{F3850BF6-E3C5-4E20-B029-74A79477F64C}"/>
-              </a:ext>
-            </a:extLst>
-          </p:cNvPr>
-          <p:cNvSpPr>
-            <a:spLocks xmlns:a="http://schemas.openxmlformats.org/drawingml/2006/main" noGrp="1"/>
-          </p:cNvSpPr>
-          <p:nvPr/>
-        </p:nvSpPr>
-        <p:spPr>
-          <a:xfrm xmlns:a="http://schemas.openxmlformats.org/drawingml/2006/main">
-            <a:off x="10994250" y="4666872"/>
-            <a:ext cx="664350" cy="666750"/>
-          </a:xfrm>
-          <a:prstGeom xmlns:a="http://schemas.openxmlformats.org/drawingml/2006/main" prst="rect">
-            <a:avLst/>
-          </a:prstGeom>
-          <a:noFill xmlns:a="http://schemas.openxmlformats.org/drawingml/2006/main"/>
-          <a:ln xmlns:a="http://schemas.openxmlformats.org/drawingml/2006/main" w="0">
-            <a:noFill/>
-          </a:ln>
-        </p:spPr>
-        <p:txBody>
-          <a:bodyPr xmlns:a="http://schemas.openxmlformats.org/drawingml/2006/main" lIns="0" tIns="0" rIns="0" bIns="0"/>
-          <a:lstStyle xmlns:a="http://schemas.openxmlformats.org/drawingml/2006/main">
-            <a:defPPr algn="ctr">
-              <a:defRPr sz="1200">
-                <a:solidFill>
-                  <a:srgbClr val="FFFFFF"/>
-                </a:solidFill>
-                <a:latin typeface="Ubuntu Condensed"/>
-                <a:ea typeface="Ubuntu Condensed"/>
-                <a:cs typeface="Ubuntu Condensed"/>
-              </a:defRPr>
-            </a:defPPr>
-          </a:lstStyle>
-          <a:p xmlns:a="http://schemas.openxmlformats.org/drawingml/2006/main">
-            <a:pPr algn="ctr">
-              <a:defRPr sz="1200">
-                <a:solidFill>
-                  <a:srgbClr val="FFFFFF"/>
-                </a:solidFill>
-                <a:latin typeface="Ubuntu Condensed"/>
-                <a:ea typeface="Ubuntu Condensed"/>
-                <a:cs typeface="Ubuntu Condensed"/>
-              </a:defRPr>
-            </a:pPr>
-            <a:r>
-              <a:rPr sz="1200">
-                <a:solidFill>
-                  <a:srgbClr val="FFFFFF"/>
-                </a:solidFill>
-                <a:latin typeface="Ubuntu Condensed"/>
-                <a:ea typeface="Ubuntu Condensed"/>
-                <a:cs typeface="Ubuntu Condensed"/>
-              </a:rPr>
-              <a:t>Oceania</a:t>
-            </a:r>
-          </a:p>
-          <a:p xmlns:a="http://schemas.openxmlformats.org/drawingml/2006/main">
-            <a:pPr algn="ctr">
-              <a:defRPr sz="1200">
-                <a:solidFill>
-                  <a:srgbClr val="FFFFFF"/>
-                </a:solidFill>
-                <a:latin typeface="Ubuntu Condensed"/>
-                <a:ea typeface="Ubuntu Condensed"/>
-                <a:cs typeface="Ubuntu Condensed"/>
-              </a:defRPr>
-            </a:pPr>
-            <a:r>
-              <a:rPr sz="1200">
-                <a:solidFill>
-                  <a:srgbClr val="FFFFFF"/>
-                </a:solidFill>
-                <a:latin typeface="Ubuntu Condensed"/>
-                <a:ea typeface="Ubuntu Condensed"/>
-                <a:cs typeface="Ubuntu Condensed"/>
-              </a:rPr>
-              <a:t>13</a:t>
-            </a:r>
-          </a:p>
-        </p:txBody>
-      </p:sp>
-      <p:sp>
-        <p:nvSpPr>
-          <p:cNvPr id="20" name="">
-            <a:extLst xmlns:a="http://schemas.openxmlformats.org/drawingml/2006/main">
-              <a:ext uri="{FF2B5EF4-FFF2-40B4-BE49-F238E27FC236}">
-                <a16:creationId xmlns:a16="http://schemas.microsoft.com/office/drawing/2014/main" id="{8A13851A-7777-4508-A2C8-5C9DF24074B4}"/>
-              </a:ext>
-            </a:extLst>
-          </p:cNvPr>
-          <p:cNvSpPr>
-            <a:spLocks xmlns:a="http://schemas.openxmlformats.org/drawingml/2006/main" noGrp="1"/>
-          </p:cNvSpPr>
-          <p:nvPr/>
-        </p:nvSpPr>
-        <p:spPr>
-          <a:xfrm xmlns:a="http://schemas.openxmlformats.org/drawingml/2006/main">
-            <a:off x="466725" y="5895975"/>
-            <a:ext cx="114300" cy="114300"/>
-          </a:xfrm>
-          <a:prstGeom xmlns:a="http://schemas.openxmlformats.org/drawingml/2006/main" prst="ellipse">
-            <a:avLst/>
-          </a:prstGeom>
-          <a:solidFill xmlns:a="http://schemas.openxmlformats.org/drawingml/2006/main">
-            <a:srgbClr val="B23C50"/>
-          </a:solidFill>
-          <a:ln xmlns:a="http://schemas.openxmlformats.org/drawingml/2006/main" w="0">
-            <a:noFill/>
-          </a:ln>
-        </p:spPr>
-      </p:sp>
-      <p:sp>
-        <p:nvSpPr>
-          <p:cNvPr id="21" name="">
-            <a:extLst xmlns:a="http://schemas.openxmlformats.org/drawingml/2006/main">
-              <a:ext uri="{FF2B5EF4-FFF2-40B4-BE49-F238E27FC236}">
-                <a16:creationId xmlns:a16="http://schemas.microsoft.com/office/drawing/2014/main" id="{07EACD01-9135-4F1F-AAE2-F8AB0B0870E1}"/>
-              </a:ext>
-            </a:extLst>
-          </p:cNvPr>
-          <p:cNvSpPr>
-            <a:spLocks xmlns:a="http://schemas.openxmlformats.org/drawingml/2006/main" noGrp="1"/>
-          </p:cNvSpPr>
-          <p:nvPr/>
-        </p:nvSpPr>
-        <p:spPr>
-          <a:xfrm xmlns:a="http://schemas.openxmlformats.org/drawingml/2006/main">
-            <a:off x="666750" y="5857875"/>
-            <a:ext cx="1619250" cy="285750"/>
+          <p:cNvPr id="14" name="">
+            <a:extLst xmlns:a="http://schemas.openxmlformats.org/drawingml/2006/main">
+              <a:ext uri="{FF2B5EF4-FFF2-40B4-BE49-F238E27FC236}">
+                <a16:creationId xmlns:a16="http://schemas.microsoft.com/office/drawing/2014/main" id="{1F7338F9-B9EB-4902-9B57-2722565E2BBF}"/>
+              </a:ext>
+            </a:extLst>
+          </p:cNvPr>
+          <p:cNvSpPr>
+            <a:spLocks xmlns:a="http://schemas.openxmlformats.org/drawingml/2006/main" noGrp="1"/>
+          </p:cNvSpPr>
+          <p:nvPr/>
+        </p:nvSpPr>
+        <p:spPr>
+          <a:xfrm xmlns:a="http://schemas.openxmlformats.org/drawingml/2006/main">
+            <a:off x="457200" y="6038850"/>
+            <a:ext cx="11239500" cy="333375"/>
           </a:xfrm>
           <a:prstGeom xmlns:a="http://schemas.openxmlformats.org/drawingml/2006/main" prst="rect">
             <a:avLst/>
@@ -15344,9 +14917,9 @@
           <a:bodyPr xmlns:a="http://schemas.openxmlformats.org/drawingml/2006/main" lIns="0" tIns="0" rIns="0" bIns="0"/>
           <a:lstStyle xmlns:a="http://schemas.openxmlformats.org/drawingml/2006/main">
             <a:defPPr>
-              <a:defRPr sz="1575">
-                <a:solidFill>
-                  <a:srgbClr val="38332E"/>
+              <a:defRPr sz="1800">
+                <a:solidFill>
+                  <a:srgbClr val="81796F"/>
                 </a:solidFill>
                 <a:latin typeface="Ubuntu Condensed"/>
                 <a:ea typeface="Ubuntu Condensed"/>
@@ -15356,9 +14929,9 @@
           </a:lstStyle>
           <a:p xmlns:a="http://schemas.openxmlformats.org/drawingml/2006/main">
             <a:pPr>
-              <a:defRPr sz="1575">
-                <a:solidFill>
-                  <a:srgbClr val="38332E"/>
+              <a:defRPr sz="1800">
+                <a:solidFill>
+                  <a:srgbClr val="81796F"/>
                 </a:solidFill>
                 <a:latin typeface="Ubuntu Condensed"/>
                 <a:ea typeface="Ubuntu Condensed"/>
@@ -15366,67 +14939,37 @@
               </a:defRPr>
             </a:pPr>
             <a:r>
-              <a:rPr sz="1575">
-                <a:solidFill>
-                  <a:srgbClr val="38332E"/>
+              <a:rPr sz="1800">
+                <a:solidFill>
+                  <a:srgbClr val="81796F"/>
                 </a:solidFill>
                 <a:latin typeface="Ubuntu Condensed"/>
                 <a:ea typeface="Ubuntu Condensed"/>
                 <a:cs typeface="Ubuntu Condensed"/>
               </a:rPr>
-              <a:t>Africa</a:t>
+              <a:t>194 countries with valid life expectancy. Shares of countries, not people.</a:t>
             </a:r>
           </a:p>
         </p:txBody>
       </p:sp>
       <p:sp>
         <p:nvSpPr>
-          <p:cNvPr id="22" name="">
-            <a:extLst xmlns:a="http://schemas.openxmlformats.org/drawingml/2006/main">
-              <a:ext uri="{FF2B5EF4-FFF2-40B4-BE49-F238E27FC236}">
-                <a16:creationId xmlns:a16="http://schemas.microsoft.com/office/drawing/2014/main" id="{89847AAA-D477-49BA-A3F2-1001C1121179}"/>
-              </a:ext>
-            </a:extLst>
-          </p:cNvPr>
-          <p:cNvSpPr>
-            <a:spLocks xmlns:a="http://schemas.openxmlformats.org/drawingml/2006/main" noGrp="1"/>
-          </p:cNvSpPr>
-          <p:nvPr/>
-        </p:nvSpPr>
-        <p:spPr>
-          <a:xfrm xmlns:a="http://schemas.openxmlformats.org/drawingml/2006/main">
-            <a:off x="2371725" y="5895975"/>
-            <a:ext cx="114300" cy="114300"/>
-          </a:xfrm>
-          <a:prstGeom xmlns:a="http://schemas.openxmlformats.org/drawingml/2006/main" prst="ellipse">
-            <a:avLst/>
-          </a:prstGeom>
-          <a:solidFill xmlns:a="http://schemas.openxmlformats.org/drawingml/2006/main">
-            <a:srgbClr val="C18A34"/>
-          </a:solidFill>
-          <a:ln xmlns:a="http://schemas.openxmlformats.org/drawingml/2006/main" w="0">
-            <a:noFill/>
-          </a:ln>
-        </p:spPr>
-      </p:sp>
-      <p:sp>
-        <p:nvSpPr>
-          <p:cNvPr id="23" name="">
-            <a:extLst xmlns:a="http://schemas.openxmlformats.org/drawingml/2006/main">
-              <a:ext uri="{FF2B5EF4-FFF2-40B4-BE49-F238E27FC236}">
-                <a16:creationId xmlns:a16="http://schemas.microsoft.com/office/drawing/2014/main" id="{9E9E01D4-AB18-4C89-AED0-0AECCE2BD09B}"/>
-              </a:ext>
-            </a:extLst>
-          </p:cNvPr>
-          <p:cNvSpPr>
-            <a:spLocks xmlns:a="http://schemas.openxmlformats.org/drawingml/2006/main" noGrp="1"/>
-          </p:cNvSpPr>
-          <p:nvPr/>
-        </p:nvSpPr>
-        <p:spPr>
-          <a:xfrm xmlns:a="http://schemas.openxmlformats.org/drawingml/2006/main">
-            <a:off x="2571750" y="5857875"/>
-            <a:ext cx="1619250" cy="285750"/>
+          <p:cNvPr id="15" name="">
+            <a:extLst xmlns:a="http://schemas.openxmlformats.org/drawingml/2006/main">
+              <a:ext uri="{FF2B5EF4-FFF2-40B4-BE49-F238E27FC236}">
+                <a16:creationId xmlns:a16="http://schemas.microsoft.com/office/drawing/2014/main" id="{5C8980FB-5DD1-4F62-9A96-ED15239EA57A}"/>
+              </a:ext>
+            </a:extLst>
+          </p:cNvPr>
+          <p:cNvSpPr>
+            <a:spLocks xmlns:a="http://schemas.openxmlformats.org/drawingml/2006/main" noGrp="1"/>
+          </p:cNvSpPr>
+          <p:nvPr/>
+        </p:nvSpPr>
+        <p:spPr>
+          <a:xfrm xmlns:a="http://schemas.openxmlformats.org/drawingml/2006/main">
+            <a:off x="457200" y="6438900"/>
+            <a:ext cx="11239500" cy="285750"/>
           </a:xfrm>
           <a:prstGeom xmlns:a="http://schemas.openxmlformats.org/drawingml/2006/main" prst="rect">
             <a:avLst/>
@@ -15440,9 +14983,9 @@
           <a:bodyPr xmlns:a="http://schemas.openxmlformats.org/drawingml/2006/main" lIns="0" tIns="0" rIns="0" bIns="0"/>
           <a:lstStyle xmlns:a="http://schemas.openxmlformats.org/drawingml/2006/main">
             <a:defPPr>
-              <a:defRPr sz="1575">
-                <a:solidFill>
-                  <a:srgbClr val="38332E"/>
+              <a:defRPr sz="1800">
+                <a:solidFill>
+                  <a:srgbClr val="B23C50"/>
                 </a:solidFill>
                 <a:latin typeface="Ubuntu Condensed"/>
                 <a:ea typeface="Ubuntu Condensed"/>
@@ -15452,9 +14995,9 @@
           </a:lstStyle>
           <a:p xmlns:a="http://schemas.openxmlformats.org/drawingml/2006/main">
             <a:pPr>
-              <a:defRPr sz="1575">
-                <a:solidFill>
-                  <a:srgbClr val="38332E"/>
+              <a:defRPr sz="1800">
+                <a:solidFill>
+                  <a:srgbClr val="B23C50"/>
                 </a:solidFill>
                 <a:latin typeface="Ubuntu Condensed"/>
                 <a:ea typeface="Ubuntu Condensed"/>
@@ -15462,473 +15005,23 @@
               </a:defRPr>
             </a:pPr>
             <a:r>
-              <a:rPr sz="1575">
-                <a:solidFill>
-                  <a:srgbClr val="38332E"/>
+              <a:rPr sz="1800">
+                <a:solidFill>
+                  <a:srgbClr val="B23C50"/>
                 </a:solidFill>
                 <a:latin typeface="Ubuntu Condensed"/>
                 <a:ea typeface="Ubuntu Condensed"/>
                 <a:cs typeface="Ubuntu Condensed"/>
               </a:rPr>
-              <a:t>Americas</a:t>
+              <a:t>Life band → Color     COUNTD(Country) → Angle / Size</a:t>
             </a:r>
           </a:p>
         </p:txBody>
       </p:sp>
-      <p:sp>
-        <p:nvSpPr>
-          <p:cNvPr id="24" name="">
-            <a:extLst xmlns:a="http://schemas.openxmlformats.org/drawingml/2006/main">
-              <a:ext uri="{FF2B5EF4-FFF2-40B4-BE49-F238E27FC236}">
-                <a16:creationId xmlns:a16="http://schemas.microsoft.com/office/drawing/2014/main" id="{5208EE74-DC93-4DEB-AC25-A979F09E7600}"/>
-              </a:ext>
-            </a:extLst>
-          </p:cNvPr>
-          <p:cNvSpPr>
-            <a:spLocks xmlns:a="http://schemas.openxmlformats.org/drawingml/2006/main" noGrp="1"/>
-          </p:cNvSpPr>
-          <p:nvPr/>
-        </p:nvSpPr>
-        <p:spPr>
-          <a:xfrm xmlns:a="http://schemas.openxmlformats.org/drawingml/2006/main">
-            <a:off x="4276725" y="5895975"/>
-            <a:ext cx="114300" cy="114300"/>
-          </a:xfrm>
-          <a:prstGeom xmlns:a="http://schemas.openxmlformats.org/drawingml/2006/main" prst="ellipse">
-            <a:avLst/>
-          </a:prstGeom>
-          <a:solidFill xmlns:a="http://schemas.openxmlformats.org/drawingml/2006/main">
-            <a:srgbClr val="457985"/>
-          </a:solidFill>
-          <a:ln xmlns:a="http://schemas.openxmlformats.org/drawingml/2006/main" w="0">
-            <a:noFill/>
-          </a:ln>
-        </p:spPr>
-      </p:sp>
-      <p:sp>
-        <p:nvSpPr>
-          <p:cNvPr id="25" name="">
-            <a:extLst xmlns:a="http://schemas.openxmlformats.org/drawingml/2006/main">
-              <a:ext uri="{FF2B5EF4-FFF2-40B4-BE49-F238E27FC236}">
-                <a16:creationId xmlns:a16="http://schemas.microsoft.com/office/drawing/2014/main" id="{83EC37CB-2AA7-4791-A228-6645503F8082}"/>
-              </a:ext>
-            </a:extLst>
-          </p:cNvPr>
-          <p:cNvSpPr>
-            <a:spLocks xmlns:a="http://schemas.openxmlformats.org/drawingml/2006/main" noGrp="1"/>
-          </p:cNvSpPr>
-          <p:nvPr/>
-        </p:nvSpPr>
-        <p:spPr>
-          <a:xfrm xmlns:a="http://schemas.openxmlformats.org/drawingml/2006/main">
-            <a:off x="4476750" y="5857875"/>
-            <a:ext cx="1619250" cy="285750"/>
-          </a:xfrm>
-          <a:prstGeom xmlns:a="http://schemas.openxmlformats.org/drawingml/2006/main" prst="rect">
-            <a:avLst/>
-          </a:prstGeom>
-          <a:noFill xmlns:a="http://schemas.openxmlformats.org/drawingml/2006/main"/>
-          <a:ln xmlns:a="http://schemas.openxmlformats.org/drawingml/2006/main" w="0">
-            <a:noFill/>
-          </a:ln>
-        </p:spPr>
-        <p:txBody>
-          <a:bodyPr xmlns:a="http://schemas.openxmlformats.org/drawingml/2006/main" lIns="0" tIns="0" rIns="0" bIns="0"/>
-          <a:lstStyle xmlns:a="http://schemas.openxmlformats.org/drawingml/2006/main">
-            <a:defPPr>
-              <a:defRPr sz="1575">
-                <a:solidFill>
-                  <a:srgbClr val="38332E"/>
-                </a:solidFill>
-                <a:latin typeface="Ubuntu Condensed"/>
-                <a:ea typeface="Ubuntu Condensed"/>
-                <a:cs typeface="Ubuntu Condensed"/>
-              </a:defRPr>
-            </a:defPPr>
-          </a:lstStyle>
-          <a:p xmlns:a="http://schemas.openxmlformats.org/drawingml/2006/main">
-            <a:pPr>
-              <a:defRPr sz="1575">
-                <a:solidFill>
-                  <a:srgbClr val="38332E"/>
-                </a:solidFill>
-                <a:latin typeface="Ubuntu Condensed"/>
-                <a:ea typeface="Ubuntu Condensed"/>
-                <a:cs typeface="Ubuntu Condensed"/>
-              </a:defRPr>
-            </a:pPr>
-            <a:r>
-              <a:rPr sz="1575">
-                <a:solidFill>
-                  <a:srgbClr val="38332E"/>
-                </a:solidFill>
-                <a:latin typeface="Ubuntu Condensed"/>
-                <a:ea typeface="Ubuntu Condensed"/>
-                <a:cs typeface="Ubuntu Condensed"/>
-              </a:rPr>
-              <a:t>Asia</a:t>
-            </a:r>
-          </a:p>
-        </p:txBody>
-      </p:sp>
-      <p:sp>
-        <p:nvSpPr>
-          <p:cNvPr id="26" name="">
-            <a:extLst xmlns:a="http://schemas.openxmlformats.org/drawingml/2006/main">
-              <a:ext uri="{FF2B5EF4-FFF2-40B4-BE49-F238E27FC236}">
-                <a16:creationId xmlns:a16="http://schemas.microsoft.com/office/drawing/2014/main" id="{EA19ADE1-E04E-4C6E-A1B9-47F0574DC8B0}"/>
-              </a:ext>
-            </a:extLst>
-          </p:cNvPr>
-          <p:cNvSpPr>
-            <a:spLocks xmlns:a="http://schemas.openxmlformats.org/drawingml/2006/main" noGrp="1"/>
-          </p:cNvSpPr>
-          <p:nvPr/>
-        </p:nvSpPr>
-        <p:spPr>
-          <a:xfrm xmlns:a="http://schemas.openxmlformats.org/drawingml/2006/main">
-            <a:off x="466725" y="6219825"/>
-            <a:ext cx="114300" cy="114300"/>
-          </a:xfrm>
-          <a:prstGeom xmlns:a="http://schemas.openxmlformats.org/drawingml/2006/main" prst="ellipse">
-            <a:avLst/>
-          </a:prstGeom>
-          <a:solidFill xmlns:a="http://schemas.openxmlformats.org/drawingml/2006/main">
-            <a:srgbClr val="647545"/>
-          </a:solidFill>
-          <a:ln xmlns:a="http://schemas.openxmlformats.org/drawingml/2006/main" w="0">
-            <a:noFill/>
-          </a:ln>
-        </p:spPr>
-      </p:sp>
-      <p:sp>
-        <p:nvSpPr>
-          <p:cNvPr id="27" name="">
-            <a:extLst xmlns:a="http://schemas.openxmlformats.org/drawingml/2006/main">
-              <a:ext uri="{FF2B5EF4-FFF2-40B4-BE49-F238E27FC236}">
-                <a16:creationId xmlns:a16="http://schemas.microsoft.com/office/drawing/2014/main" id="{B732BB2E-4B24-4735-89BA-D0379D7235C2}"/>
-              </a:ext>
-            </a:extLst>
-          </p:cNvPr>
-          <p:cNvSpPr>
-            <a:spLocks xmlns:a="http://schemas.openxmlformats.org/drawingml/2006/main" noGrp="1"/>
-          </p:cNvSpPr>
-          <p:nvPr/>
-        </p:nvSpPr>
-        <p:spPr>
-          <a:xfrm xmlns:a="http://schemas.openxmlformats.org/drawingml/2006/main">
-            <a:off x="666750" y="6181725"/>
-            <a:ext cx="1619250" cy="285750"/>
-          </a:xfrm>
-          <a:prstGeom xmlns:a="http://schemas.openxmlformats.org/drawingml/2006/main" prst="rect">
-            <a:avLst/>
-          </a:prstGeom>
-          <a:noFill xmlns:a="http://schemas.openxmlformats.org/drawingml/2006/main"/>
-          <a:ln xmlns:a="http://schemas.openxmlformats.org/drawingml/2006/main" w="0">
-            <a:noFill/>
-          </a:ln>
-        </p:spPr>
-        <p:txBody>
-          <a:bodyPr xmlns:a="http://schemas.openxmlformats.org/drawingml/2006/main" lIns="0" tIns="0" rIns="0" bIns="0"/>
-          <a:lstStyle xmlns:a="http://schemas.openxmlformats.org/drawingml/2006/main">
-            <a:defPPr>
-              <a:defRPr sz="1575">
-                <a:solidFill>
-                  <a:srgbClr val="38332E"/>
-                </a:solidFill>
-                <a:latin typeface="Ubuntu Condensed"/>
-                <a:ea typeface="Ubuntu Condensed"/>
-                <a:cs typeface="Ubuntu Condensed"/>
-              </a:defRPr>
-            </a:defPPr>
-          </a:lstStyle>
-          <a:p xmlns:a="http://schemas.openxmlformats.org/drawingml/2006/main">
-            <a:pPr>
-              <a:defRPr sz="1575">
-                <a:solidFill>
-                  <a:srgbClr val="38332E"/>
-                </a:solidFill>
-                <a:latin typeface="Ubuntu Condensed"/>
-                <a:ea typeface="Ubuntu Condensed"/>
-                <a:cs typeface="Ubuntu Condensed"/>
-              </a:defRPr>
-            </a:pPr>
-            <a:r>
-              <a:rPr sz="1575">
-                <a:solidFill>
-                  <a:srgbClr val="38332E"/>
-                </a:solidFill>
-                <a:latin typeface="Ubuntu Condensed"/>
-                <a:ea typeface="Ubuntu Condensed"/>
-                <a:cs typeface="Ubuntu Condensed"/>
-              </a:rPr>
-              <a:t>Europe</a:t>
-            </a:r>
-          </a:p>
-        </p:txBody>
-      </p:sp>
-      <p:sp>
-        <p:nvSpPr>
-          <p:cNvPr id="28" name="">
-            <a:extLst xmlns:a="http://schemas.openxmlformats.org/drawingml/2006/main">
-              <a:ext uri="{FF2B5EF4-FFF2-40B4-BE49-F238E27FC236}">
-                <a16:creationId xmlns:a16="http://schemas.microsoft.com/office/drawing/2014/main" id="{F4DC7DC5-428B-4429-9D5B-2F190C540AAD}"/>
-              </a:ext>
-            </a:extLst>
-          </p:cNvPr>
-          <p:cNvSpPr>
-            <a:spLocks xmlns:a="http://schemas.openxmlformats.org/drawingml/2006/main" noGrp="1"/>
-          </p:cNvSpPr>
-          <p:nvPr/>
-        </p:nvSpPr>
-        <p:spPr>
-          <a:xfrm xmlns:a="http://schemas.openxmlformats.org/drawingml/2006/main">
-            <a:off x="2371725" y="6219825"/>
-            <a:ext cx="114300" cy="114300"/>
-          </a:xfrm>
-          <a:prstGeom xmlns:a="http://schemas.openxmlformats.org/drawingml/2006/main" prst="ellipse">
-            <a:avLst/>
-          </a:prstGeom>
-          <a:solidFill xmlns:a="http://schemas.openxmlformats.org/drawingml/2006/main">
-            <a:srgbClr val="805773"/>
-          </a:solidFill>
-          <a:ln xmlns:a="http://schemas.openxmlformats.org/drawingml/2006/main" w="0">
-            <a:noFill/>
-          </a:ln>
-        </p:spPr>
-      </p:sp>
-      <p:sp>
-        <p:nvSpPr>
-          <p:cNvPr id="29" name="">
-            <a:extLst xmlns:a="http://schemas.openxmlformats.org/drawingml/2006/main">
-              <a:ext uri="{FF2B5EF4-FFF2-40B4-BE49-F238E27FC236}">
-                <a16:creationId xmlns:a16="http://schemas.microsoft.com/office/drawing/2014/main" id="{56A7ADE5-1ABE-4BD4-BDB0-757FB9E784AA}"/>
-              </a:ext>
-            </a:extLst>
-          </p:cNvPr>
-          <p:cNvSpPr>
-            <a:spLocks xmlns:a="http://schemas.openxmlformats.org/drawingml/2006/main" noGrp="1"/>
-          </p:cNvSpPr>
-          <p:nvPr/>
-        </p:nvSpPr>
-        <p:spPr>
-          <a:xfrm xmlns:a="http://schemas.openxmlformats.org/drawingml/2006/main">
-            <a:off x="2571750" y="6181725"/>
-            <a:ext cx="1619250" cy="285750"/>
-          </a:xfrm>
-          <a:prstGeom xmlns:a="http://schemas.openxmlformats.org/drawingml/2006/main" prst="rect">
-            <a:avLst/>
-          </a:prstGeom>
-          <a:noFill xmlns:a="http://schemas.openxmlformats.org/drawingml/2006/main"/>
-          <a:ln xmlns:a="http://schemas.openxmlformats.org/drawingml/2006/main" w="0">
-            <a:noFill/>
-          </a:ln>
-        </p:spPr>
-        <p:txBody>
-          <a:bodyPr xmlns:a="http://schemas.openxmlformats.org/drawingml/2006/main" lIns="0" tIns="0" rIns="0" bIns="0"/>
-          <a:lstStyle xmlns:a="http://schemas.openxmlformats.org/drawingml/2006/main">
-            <a:defPPr>
-              <a:defRPr sz="1575">
-                <a:solidFill>
-                  <a:srgbClr val="38332E"/>
-                </a:solidFill>
-                <a:latin typeface="Ubuntu Condensed"/>
-                <a:ea typeface="Ubuntu Condensed"/>
-                <a:cs typeface="Ubuntu Condensed"/>
-              </a:defRPr>
-            </a:defPPr>
-          </a:lstStyle>
-          <a:p xmlns:a="http://schemas.openxmlformats.org/drawingml/2006/main">
-            <a:pPr>
-              <a:defRPr sz="1575">
-                <a:solidFill>
-                  <a:srgbClr val="38332E"/>
-                </a:solidFill>
-                <a:latin typeface="Ubuntu Condensed"/>
-                <a:ea typeface="Ubuntu Condensed"/>
-                <a:cs typeface="Ubuntu Condensed"/>
-              </a:defRPr>
-            </a:pPr>
-            <a:r>
-              <a:rPr sz="1575">
-                <a:solidFill>
-                  <a:srgbClr val="38332E"/>
-                </a:solidFill>
-                <a:latin typeface="Ubuntu Condensed"/>
-                <a:ea typeface="Ubuntu Condensed"/>
-                <a:cs typeface="Ubuntu Condensed"/>
-              </a:rPr>
-              <a:t>Oceania</a:t>
-            </a:r>
-          </a:p>
-        </p:txBody>
-      </p:sp>
-      <p:sp>
-        <p:nvSpPr>
-          <p:cNvPr id="30" name="">
-            <a:extLst xmlns:a="http://schemas.openxmlformats.org/drawingml/2006/main">
-              <a:ext uri="{FF2B5EF4-FFF2-40B4-BE49-F238E27FC236}">
-                <a16:creationId xmlns:a16="http://schemas.microsoft.com/office/drawing/2014/main" id="{DA667F5D-51BC-4EBB-A287-1AEBC27636FB}"/>
-              </a:ext>
-            </a:extLst>
-          </p:cNvPr>
-          <p:cNvSpPr>
-            <a:spLocks xmlns:a="http://schemas.openxmlformats.org/drawingml/2006/main" noGrp="1"/>
-          </p:cNvSpPr>
-          <p:nvPr/>
-        </p:nvSpPr>
-        <p:spPr>
-          <a:xfrm xmlns:a="http://schemas.openxmlformats.org/drawingml/2006/main">
-            <a:off x="4276725" y="6219825"/>
-            <a:ext cx="114300" cy="114300"/>
-          </a:xfrm>
-          <a:prstGeom xmlns:a="http://schemas.openxmlformats.org/drawingml/2006/main" prst="ellipse">
-            <a:avLst/>
-          </a:prstGeom>
-          <a:solidFill xmlns:a="http://schemas.openxmlformats.org/drawingml/2006/main">
-            <a:srgbClr val="AAA49B"/>
-          </a:solidFill>
-          <a:ln xmlns:a="http://schemas.openxmlformats.org/drawingml/2006/main" w="0">
-            <a:noFill/>
-          </a:ln>
-        </p:spPr>
-      </p:sp>
-      <p:sp>
-        <p:nvSpPr>
-          <p:cNvPr id="31" name="">
-            <a:extLst xmlns:a="http://schemas.openxmlformats.org/drawingml/2006/main">
-              <a:ext uri="{FF2B5EF4-FFF2-40B4-BE49-F238E27FC236}">
-                <a16:creationId xmlns:a16="http://schemas.microsoft.com/office/drawing/2014/main" id="{B5C2095A-EC2F-4E6A-8515-F3613173E884}"/>
-              </a:ext>
-            </a:extLst>
-          </p:cNvPr>
-          <p:cNvSpPr>
-            <a:spLocks xmlns:a="http://schemas.openxmlformats.org/drawingml/2006/main" noGrp="1"/>
-          </p:cNvSpPr>
-          <p:nvPr/>
-        </p:nvSpPr>
-        <p:spPr>
-          <a:xfrm xmlns:a="http://schemas.openxmlformats.org/drawingml/2006/main">
-            <a:off x="4476750" y="6181725"/>
-            <a:ext cx="1619250" cy="285750"/>
-          </a:xfrm>
-          <a:prstGeom xmlns:a="http://schemas.openxmlformats.org/drawingml/2006/main" prst="rect">
-            <a:avLst/>
-          </a:prstGeom>
-          <a:noFill xmlns:a="http://schemas.openxmlformats.org/drawingml/2006/main"/>
-          <a:ln xmlns:a="http://schemas.openxmlformats.org/drawingml/2006/main" w="0">
-            <a:noFill/>
-          </a:ln>
-        </p:spPr>
-        <p:txBody>
-          <a:bodyPr xmlns:a="http://schemas.openxmlformats.org/drawingml/2006/main" lIns="0" tIns="0" rIns="0" bIns="0"/>
-          <a:lstStyle xmlns:a="http://schemas.openxmlformats.org/drawingml/2006/main">
-            <a:defPPr>
-              <a:defRPr sz="1575">
-                <a:solidFill>
-                  <a:srgbClr val="38332E"/>
-                </a:solidFill>
-                <a:latin typeface="Ubuntu Condensed"/>
-                <a:ea typeface="Ubuntu Condensed"/>
-                <a:cs typeface="Ubuntu Condensed"/>
-              </a:defRPr>
-            </a:defPPr>
-          </a:lstStyle>
-          <a:p xmlns:a="http://schemas.openxmlformats.org/drawingml/2006/main">
-            <a:pPr>
-              <a:defRPr sz="1575">
-                <a:solidFill>
-                  <a:srgbClr val="38332E"/>
-                </a:solidFill>
-                <a:latin typeface="Ubuntu Condensed"/>
-                <a:ea typeface="Ubuntu Condensed"/>
-                <a:cs typeface="Ubuntu Condensed"/>
-              </a:defRPr>
-            </a:pPr>
-            <a:r>
-              <a:rPr sz="1575">
-                <a:solidFill>
-                  <a:srgbClr val="38332E"/>
-                </a:solidFill>
-                <a:latin typeface="Ubuntu Condensed"/>
-                <a:ea typeface="Ubuntu Condensed"/>
-                <a:cs typeface="Ubuntu Condensed"/>
-              </a:rPr>
-              <a:t>Unknown</a:t>
-            </a:r>
-          </a:p>
-        </p:txBody>
-      </p:sp>
-      <p:sp>
-        <p:nvSpPr>
-          <p:cNvPr id="32" name="">
-            <a:extLst xmlns:a="http://schemas.openxmlformats.org/drawingml/2006/main">
-              <a:ext uri="{FF2B5EF4-FFF2-40B4-BE49-F238E27FC236}">
-                <a16:creationId xmlns:a16="http://schemas.microsoft.com/office/drawing/2014/main" id="{1305AA8B-E39C-44D3-8056-03EBBBA420BB}"/>
-              </a:ext>
-            </a:extLst>
-          </p:cNvPr>
-          <p:cNvSpPr>
-            <a:spLocks xmlns:a="http://schemas.openxmlformats.org/drawingml/2006/main" noGrp="1"/>
-          </p:cNvSpPr>
-          <p:nvPr/>
-        </p:nvSpPr>
-        <p:spPr>
-          <a:xfrm xmlns:a="http://schemas.openxmlformats.org/drawingml/2006/main">
-            <a:off x="6572250" y="6000750"/>
-            <a:ext cx="5238750" cy="523875"/>
-          </a:xfrm>
-          <a:prstGeom xmlns:a="http://schemas.openxmlformats.org/drawingml/2006/main" prst="rect">
-            <a:avLst/>
-          </a:prstGeom>
-          <a:noFill xmlns:a="http://schemas.openxmlformats.org/drawingml/2006/main"/>
-          <a:ln xmlns:a="http://schemas.openxmlformats.org/drawingml/2006/main" w="0">
-            <a:noFill/>
-          </a:ln>
-        </p:spPr>
-        <p:txBody>
-          <a:bodyPr xmlns:a="http://schemas.openxmlformats.org/drawingml/2006/main" lIns="0" tIns="0" rIns="0" bIns="0"/>
-          <a:lstStyle xmlns:a="http://schemas.openxmlformats.org/drawingml/2006/main">
-            <a:defPPr>
-              <a:defRPr sz="1725">
-                <a:solidFill>
-                  <a:srgbClr val="81796F"/>
-                </a:solidFill>
-                <a:latin typeface="Ubuntu Condensed"/>
-                <a:ea typeface="Ubuntu Condensed"/>
-                <a:cs typeface="Ubuntu Condensed"/>
-              </a:defRPr>
-            </a:defPPr>
-          </a:lstStyle>
-          <a:p xmlns:a="http://schemas.openxmlformats.org/drawingml/2006/main">
-            <a:pPr>
-              <a:defRPr sz="1725">
-                <a:solidFill>
-                  <a:srgbClr val="81796F"/>
-                </a:solidFill>
-                <a:latin typeface="Ubuntu Condensed"/>
-                <a:ea typeface="Ubuntu Condensed"/>
-                <a:cs typeface="Ubuntu Condensed"/>
-              </a:defRPr>
-            </a:pPr>
-            <a:r>
-              <a:rPr sz="1725">
-                <a:solidFill>
-                  <a:srgbClr val="81796F"/>
-                </a:solidFill>
-                <a:latin typeface="Ubuntu Condensed"/>
-                <a:ea typeface="Ubuntu Condensed"/>
-                <a:cs typeface="Ubuntu Condensed"/>
-              </a:rPr>
-              <a:t>197 country records, including Unknown region</a:t>
-            </a:r>
-          </a:p>
-        </p:txBody>
-      </p:sp>
     </p:spTree>
     <p:extLst>
       <p:ext uri="{BB962C8B-B14F-4D97-AF65-F5344CB8AC3E}">
-        <p14:creationId xmlns:p14="http://schemas.microsoft.com/office/powerpoint/2010/main" val="1352445534"/>
+        <p14:creationId xmlns:p14="http://schemas.microsoft.com/office/powerpoint/2010/main" val="363424185"/>
       </p:ext>
     </p:extLst>
   </p:cSld>
@@ -15959,7 +15052,7 @@
           <p:cNvPr id="11" name="">
             <a:extLst xmlns:a="http://schemas.openxmlformats.org/drawingml/2006/main">
               <a:ext uri="{FF2B5EF4-FFF2-40B4-BE49-F238E27FC236}">
-                <a16:creationId xmlns:a16="http://schemas.microsoft.com/office/drawing/2014/main" id="{9D487A6E-10F9-4D4F-B9CF-B9E6C9D238B9}"/>
+                <a16:creationId xmlns:a16="http://schemas.microsoft.com/office/drawing/2014/main" id="{529B62C0-891E-4181-A828-33DCA64315CE}"/>
               </a:ext>
             </a:extLst>
           </p:cNvPr>
@@ -16025,7 +15118,7 @@
           <p:cNvPr id="2" name="">
             <a:extLst xmlns:a="http://schemas.openxmlformats.org/drawingml/2006/main">
               <a:ext uri="{FF2B5EF4-FFF2-40B4-BE49-F238E27FC236}">
-                <a16:creationId xmlns:a16="http://schemas.microsoft.com/office/drawing/2014/main" id="{82D84F02-BC05-4EC4-9F67-0B51524B71DD}"/>
+                <a16:creationId xmlns:a16="http://schemas.microsoft.com/office/drawing/2014/main" id="{131B9063-331A-46E7-A826-ADD88D14ED4C}"/>
               </a:ext>
             </a:extLst>
           </p:cNvPr>
@@ -16091,7 +15184,7 @@
           <p:cNvPr id="3" name="">
             <a:extLst xmlns:a="http://schemas.openxmlformats.org/drawingml/2006/main">
               <a:ext uri="{FF2B5EF4-FFF2-40B4-BE49-F238E27FC236}">
-                <a16:creationId xmlns:a16="http://schemas.microsoft.com/office/drawing/2014/main" id="{90426281-9512-4867-9BBA-F851A04B5919}"/>
+                <a16:creationId xmlns:a16="http://schemas.microsoft.com/office/drawing/2014/main" id="{78071801-6ADA-47C1-A437-B76A24DBC698}"/>
               </a:ext>
             </a:extLst>
           </p:cNvPr>
@@ -16157,7 +15250,7 @@
           <p:cNvPr id="4" name="">
             <a:extLst xmlns:a="http://schemas.openxmlformats.org/drawingml/2006/main">
               <a:ext uri="{FF2B5EF4-FFF2-40B4-BE49-F238E27FC236}">
-                <a16:creationId xmlns:a16="http://schemas.microsoft.com/office/drawing/2014/main" id="{D86B150D-A92C-48E4-B2AC-B80F72D65C84}"/>
+                <a16:creationId xmlns:a16="http://schemas.microsoft.com/office/drawing/2014/main" id="{C7EFD6C1-FF3A-4FD7-9339-CDB091EF976E}"/>
               </a:ext>
             </a:extLst>
           </p:cNvPr>
@@ -16223,7 +15316,7 @@
           <p:cNvPr id="5" name="">
             <a:extLst xmlns:a="http://schemas.openxmlformats.org/drawingml/2006/main">
               <a:ext uri="{FF2B5EF4-FFF2-40B4-BE49-F238E27FC236}">
-                <a16:creationId xmlns:a16="http://schemas.microsoft.com/office/drawing/2014/main" id="{9934909F-4B3A-4461-9505-45786EDCC6E0}"/>
+                <a16:creationId xmlns:a16="http://schemas.microsoft.com/office/drawing/2014/main" id="{D75916F9-AC48-4FA7-BC20-CFA4A70D58FB}"/>
               </a:ext>
             </a:extLst>
           </p:cNvPr>
@@ -16289,7 +15382,7 @@
           <p:cNvPr id="6" name="">
             <a:extLst xmlns:a="http://schemas.openxmlformats.org/drawingml/2006/main">
               <a:ext uri="{FF2B5EF4-FFF2-40B4-BE49-F238E27FC236}">
-                <a16:creationId xmlns:a16="http://schemas.microsoft.com/office/drawing/2014/main" id="{26C6F362-622A-4EE7-B99B-4042CB009502}"/>
+                <a16:creationId xmlns:a16="http://schemas.microsoft.com/office/drawing/2014/main" id="{8CB1EF52-DC27-444F-A746-88B09765B937}"/>
               </a:ext>
             </a:extLst>
           </p:cNvPr>
@@ -16355,7 +15448,7 @@
           <p:cNvPr id="7" name="">
             <a:extLst xmlns:a="http://schemas.openxmlformats.org/drawingml/2006/main">
               <a:ext uri="{FF2B5EF4-FFF2-40B4-BE49-F238E27FC236}">
-                <a16:creationId xmlns:a16="http://schemas.microsoft.com/office/drawing/2014/main" id="{D04B155E-A330-442C-9DCE-5CA028D73CCE}"/>
+                <a16:creationId xmlns:a16="http://schemas.microsoft.com/office/drawing/2014/main" id="{AFE87A54-35D5-4537-B28D-D4577F5DECCE}"/>
               </a:ext>
             </a:extLst>
           </p:cNvPr>
@@ -16365,7 +15458,7 @@
           <p:nvPr/>
         </p:nvPicPr>
         <p:blipFill>
-          <a:blip xmlns:r="http://schemas.openxmlformats.org/officeDocument/2006/relationships" xmlns:a="http://schemas.openxmlformats.org/drawingml/2006/main" r:embed="R22afcbedfab54087"/>
+          <a:blip xmlns:r="http://schemas.openxmlformats.org/officeDocument/2006/relationships" xmlns:a="http://schemas.openxmlformats.org/drawingml/2006/main" r:embed="Rbdad446b83d44d1f"/>
           <a:stretch xmlns:a="http://schemas.openxmlformats.org/drawingml/2006/main"/>
         </p:blipFill>
         <p:spPr>
@@ -16383,7 +15476,7 @@
           <p:cNvPr id="8" name="">
             <a:extLst xmlns:a="http://schemas.openxmlformats.org/drawingml/2006/main">
               <a:ext uri="{FF2B5EF4-FFF2-40B4-BE49-F238E27FC236}">
-                <a16:creationId xmlns:a16="http://schemas.microsoft.com/office/drawing/2014/main" id="{F708E27C-10F5-4385-89DF-E36C0F50CBD7}"/>
+                <a16:creationId xmlns:a16="http://schemas.microsoft.com/office/drawing/2014/main" id="{63DC64B5-8824-4C8E-9D92-D2765F32FE5B}"/>
               </a:ext>
             </a:extLst>
           </p:cNvPr>
@@ -16393,7 +15486,7 @@
           <p:nvPr/>
         </p:nvPicPr>
         <p:blipFill>
-          <a:blip xmlns:r="http://schemas.openxmlformats.org/officeDocument/2006/relationships" xmlns:a="http://schemas.openxmlformats.org/drawingml/2006/main" r:embed="Rfb60e5df52784426"/>
+          <a:blip xmlns:r="http://schemas.openxmlformats.org/officeDocument/2006/relationships" xmlns:a="http://schemas.openxmlformats.org/drawingml/2006/main" r:embed="Rdb2b00a057e14391"/>
           <a:stretch xmlns:a="http://schemas.openxmlformats.org/drawingml/2006/main"/>
         </p:blipFill>
         <p:spPr>
@@ -16411,7 +15504,7 @@
           <p:cNvPr id="9" name="">
             <a:extLst xmlns:a="http://schemas.openxmlformats.org/drawingml/2006/main">
               <a:ext uri="{FF2B5EF4-FFF2-40B4-BE49-F238E27FC236}">
-                <a16:creationId xmlns:a16="http://schemas.microsoft.com/office/drawing/2014/main" id="{991E6A19-EBAA-4061-8964-31597CB57619}"/>
+                <a16:creationId xmlns:a16="http://schemas.microsoft.com/office/drawing/2014/main" id="{07AC5F10-012E-497B-8C4A-6D316A5EA659}"/>
               </a:ext>
             </a:extLst>
           </p:cNvPr>
@@ -16477,7 +15570,7 @@
           <p:cNvPr id="10" name="">
             <a:extLst xmlns:a="http://schemas.openxmlformats.org/drawingml/2006/main">
               <a:ext uri="{FF2B5EF4-FFF2-40B4-BE49-F238E27FC236}">
-                <a16:creationId xmlns:a16="http://schemas.microsoft.com/office/drawing/2014/main" id="{201D7DA6-6C91-453C-80E8-62C4F77BF81B}"/>
+                <a16:creationId xmlns:a16="http://schemas.microsoft.com/office/drawing/2014/main" id="{77DAE39B-FDF1-4616-A424-B146BF6112E2}"/>
               </a:ext>
             </a:extLst>
           </p:cNvPr>
@@ -16541,7 +15634,7 @@
     </p:spTree>
     <p:extLst>
       <p:ext uri="{BB962C8B-B14F-4D97-AF65-F5344CB8AC3E}">
-        <p14:creationId xmlns:p14="http://schemas.microsoft.com/office/powerpoint/2010/main" val="694259380"/>
+        <p14:creationId xmlns:p14="http://schemas.microsoft.com/office/powerpoint/2010/main" val="670145354"/>
       </p:ext>
     </p:extLst>
   </p:cSld>

</xml_diff>